<commit_message>
Implement SCOUT response to Charles regarding ESPN placeholder rows
- Added new markdown files for SCOUT's response to Charles's inquiry about the `"-"` placeholder rows in ESPN box data, detailing the investigation and recommendations.
- Created `20260817_1606_Charles_to_SCOUT_espn_dash_placeholder_rows.md` and `20260817_1610_SCOUT_to_COMPASS_espn_dash_placeholder_rows.md` to document findings and proposed actions.
- Updated `statistics.json` to reflect the latest user and agent message counts, ensuring accurate tracking of project activity.

These changes enhance communication and documentation regarding the handling of placeholder rows in the dataset, supporting ongoing analysis and decision-making.
</commit_message>
<xml_diff>
--- a/3-Master_Plan/re_entry/HEROs_and_PASSes/slides/auto/CHAR_PD21_rho_hsort_calibrate_AUTO.pptx
+++ b/3-Master_Plan/re_entry/HEROs_and_PASSes/slides/auto/CHAR_PD21_rho_hsort_calibrate_AUTO.pptx
@@ -302,7 +302,7 @@
           <a:p>
             <a:fld id="{5BCAD085-E8A6-8845-BD4E-CB4CCA059FC4}" type="datetimeFigureOut">
               <a:rPr lang="en-US" smtClean="0"/>
-              <a:t>8/14/26</a:t>
+              <a:t>8/17/26</a:t>
             </a:fld>
             <a:endParaRPr lang="en-US"/>
           </a:p>
@@ -470,7 +470,7 @@
           <a:p>
             <a:fld id="{5BCAD085-E8A6-8845-BD4E-CB4CCA059FC4}" type="datetimeFigureOut">
               <a:rPr lang="en-US" smtClean="0"/>
-              <a:t>8/14/26</a:t>
+              <a:t>8/17/26</a:t>
             </a:fld>
             <a:endParaRPr lang="en-US"/>
           </a:p>
@@ -648,7 +648,7 @@
           <a:p>
             <a:fld id="{5BCAD085-E8A6-8845-BD4E-CB4CCA059FC4}" type="datetimeFigureOut">
               <a:rPr lang="en-US" smtClean="0"/>
-              <a:t>8/14/26</a:t>
+              <a:t>8/17/26</a:t>
             </a:fld>
             <a:endParaRPr lang="en-US"/>
           </a:p>
@@ -816,7 +816,7 @@
           <a:p>
             <a:fld id="{5BCAD085-E8A6-8845-BD4E-CB4CCA059FC4}" type="datetimeFigureOut">
               <a:rPr lang="en-US" smtClean="0"/>
-              <a:t>8/14/26</a:t>
+              <a:t>8/17/26</a:t>
             </a:fld>
             <a:endParaRPr lang="en-US"/>
           </a:p>
@@ -1061,7 +1061,7 @@
           <a:p>
             <a:fld id="{5BCAD085-E8A6-8845-BD4E-CB4CCA059FC4}" type="datetimeFigureOut">
               <a:rPr lang="en-US" smtClean="0"/>
-              <a:t>8/14/26</a:t>
+              <a:t>8/17/26</a:t>
             </a:fld>
             <a:endParaRPr lang="en-US"/>
           </a:p>
@@ -1346,7 +1346,7 @@
           <a:p>
             <a:fld id="{5BCAD085-E8A6-8845-BD4E-CB4CCA059FC4}" type="datetimeFigureOut">
               <a:rPr lang="en-US" smtClean="0"/>
-              <a:t>8/14/26</a:t>
+              <a:t>8/17/26</a:t>
             </a:fld>
             <a:endParaRPr lang="en-US"/>
           </a:p>
@@ -1765,7 +1765,7 @@
           <a:p>
             <a:fld id="{5BCAD085-E8A6-8845-BD4E-CB4CCA059FC4}" type="datetimeFigureOut">
               <a:rPr lang="en-US" smtClean="0"/>
-              <a:t>8/14/26</a:t>
+              <a:t>8/17/26</a:t>
             </a:fld>
             <a:endParaRPr lang="en-US"/>
           </a:p>
@@ -1882,7 +1882,7 @@
           <a:p>
             <a:fld id="{5BCAD085-E8A6-8845-BD4E-CB4CCA059FC4}" type="datetimeFigureOut">
               <a:rPr lang="en-US" smtClean="0"/>
-              <a:t>8/14/26</a:t>
+              <a:t>8/17/26</a:t>
             </a:fld>
             <a:endParaRPr lang="en-US"/>
           </a:p>
@@ -1977,7 +1977,7 @@
           <a:p>
             <a:fld id="{5BCAD085-E8A6-8845-BD4E-CB4CCA059FC4}" type="datetimeFigureOut">
               <a:rPr lang="en-US" smtClean="0"/>
-              <a:t>8/14/26</a:t>
+              <a:t>8/17/26</a:t>
             </a:fld>
             <a:endParaRPr lang="en-US"/>
           </a:p>
@@ -2252,7 +2252,7 @@
           <a:p>
             <a:fld id="{5BCAD085-E8A6-8845-BD4E-CB4CCA059FC4}" type="datetimeFigureOut">
               <a:rPr lang="en-US" smtClean="0"/>
-              <a:t>8/14/26</a:t>
+              <a:t>8/17/26</a:t>
             </a:fld>
             <a:endParaRPr lang="en-US"/>
           </a:p>
@@ -2504,7 +2504,7 @@
           <a:p>
             <a:fld id="{5BCAD085-E8A6-8845-BD4E-CB4CCA059FC4}" type="datetimeFigureOut">
               <a:rPr lang="en-US" smtClean="0"/>
-              <a:t>8/14/26</a:t>
+              <a:t>8/17/26</a:t>
             </a:fld>
             <a:endParaRPr lang="en-US"/>
           </a:p>
@@ -2715,7 +2715,7 @@
           <a:p>
             <a:fld id="{5BCAD085-E8A6-8845-BD4E-CB4CCA059FC4}" type="datetimeFigureOut">
               <a:rPr lang="en-US" smtClean="0"/>
-              <a:t>8/14/26</a:t>
+              <a:t>8/17/26</a:t>
             </a:fld>
             <a:endParaRPr lang="en-US"/>
           </a:p>
@@ -3090,30 +3090,6 @@
           <a:chExt cx="0" cy="0"/>
         </a:xfrm>
       </p:grpSpPr>
-      <p:pic>
-        <p:nvPicPr>
-          <p:cNvPr id="4" name="Picture 3" descr="PD21_rho_hsort_calibrate_2011_2021_bracket.png"/>
-          <p:cNvPicPr>
-            <a:picLocks noChangeAspect="1"/>
-          </p:cNvPicPr>
-          <p:nvPr/>
-        </p:nvPicPr>
-        <p:blipFill>
-          <a:blip r:embed="rId2"/>
-          <a:stretch>
-            <a:fillRect/>
-          </a:stretch>
-        </p:blipFill>
-        <p:spPr>
-          <a:xfrm>
-            <a:off x="3671407" y="721581"/>
-            <a:ext cx="8337713" cy="5423187"/>
-          </a:xfrm>
-          <a:prstGeom prst="rect">
-            <a:avLst/>
-          </a:prstGeom>
-        </p:spPr>
-      </p:pic>
       <mc:AlternateContent xmlns:mc="http://schemas.openxmlformats.org/markup-compatibility/2006">
         <mc:Choice xmlns:a14="http://schemas.microsoft.com/office/drawing/2010/main" Requires="a14">
           <p:sp>
@@ -3125,7 +3101,7 @@
             <p:spPr>
               <a:xfrm>
                 <a:off x="384048" y="219456"/>
-                <a:ext cx="6819944" cy="400110"/>
+                <a:ext cx="10413492" cy="400110"/>
               </a:xfrm>
               <a:prstGeom prst="rect">
                 <a:avLst/>
@@ -3155,30 +3131,24 @@
                   </m:oMath>
                 </a14:m>
                 <a:r>
-                  <a:rPr lang="en-US" sz="2000" b="1" i="0" baseline="0" dirty="0">
-                    <a:latin typeface="Calibri"/>
-                  </a:rPr>
-                  <a:t> </a:t>
-                </a:r>
-                <a:r>
                   <a:rPr sz="2000" b="1" i="0" baseline="0" dirty="0">
                     <a:latin typeface="Calibri"/>
                   </a:rPr>
-                  <a:t>to empirical sorting index </a:t>
+                  <a:t> to empirical sorting index </a:t>
                 </a:r>
                 <a14:m>
                   <m:oMath xmlns:m="http://schemas.openxmlformats.org/officeDocument/2006/math">
                     <m:sSub>
                       <m:sSubPr>
                         <m:ctrlPr>
-                          <a:rPr lang="en-US" sz="2000" b="1" i="0" baseline="0" dirty="0" smtClean="0">
+                          <a:rPr lang="en-US" sz="2000" b="1" i="0" baseline="0" dirty="0">
                             <a:latin typeface="Cambria Math" panose="02040503050406030204" pitchFamily="18" charset="0"/>
                           </a:rPr>
                         </m:ctrlPr>
                       </m:sSubPr>
                       <m:e>
                         <m:r>
-                          <a:rPr lang="en-US" sz="2000" b="1" i="0" baseline="0" dirty="0" smtClean="0">
+                          <a:rPr lang="en-US" sz="2000" b="1" i="0" baseline="0" dirty="0">
                             <a:latin typeface="Cambria Math" panose="02040503050406030204" pitchFamily="18" charset="0"/>
                           </a:rPr>
                           <m:t>𝐻</m:t>
@@ -3189,7 +3159,7 @@
                           <m:rPr>
                             <m:sty m:val="p"/>
                           </m:rPr>
-                          <a:rPr lang="en-US" sz="2000" b="1" i="0" baseline="0" dirty="0" smtClean="0">
+                          <a:rPr lang="en-US" sz="2000" b="1" i="0" baseline="0" dirty="0">
                             <a:latin typeface="Cambria Math" panose="02040503050406030204" pitchFamily="18" charset="0"/>
                           </a:rPr>
                           <m:t>sort</m:t>
@@ -3198,9 +3168,12 @@
                     </m:sSub>
                   </m:oMath>
                 </a14:m>
-                <a:endParaRPr sz="2000" b="1" i="0" baseline="0" dirty="0">
-                  <a:latin typeface="Calibri"/>
-                </a:endParaRPr>
+                <a:r>
+                  <a:rPr sz="2000" b="1" i="0" baseline="0" dirty="0">
+                    <a:latin typeface="Calibri"/>
+                  </a:rPr>
+                  <a:t> (hero panel — locked calibration)</a:t>
+                </a:r>
               </a:p>
             </p:txBody>
           </p:sp>
@@ -3217,15 +3190,15 @@
             <p:spPr>
               <a:xfrm>
                 <a:off x="384048" y="219456"/>
-                <a:ext cx="6819944" cy="400110"/>
+                <a:ext cx="10413492" cy="400110"/>
               </a:xfrm>
               <a:prstGeom prst="rect">
                 <a:avLst/>
               </a:prstGeom>
               <a:blipFill>
-                <a:blip r:embed="rId3"/>
+                <a:blip r:embed="rId2"/>
                 <a:stretch>
-                  <a:fillRect l="-929" t="-9375" b="-28125"/>
+                  <a:fillRect l="-609" t="-9375" b="-28125"/>
                 </a:stretch>
               </a:blipFill>
             </p:spPr>
@@ -3255,7 +3228,7 @@
             <p:spPr>
               <a:xfrm>
                 <a:off x="384048" y="713232"/>
-                <a:ext cx="5406929" cy="246221"/>
+                <a:ext cx="5721118" cy="246221"/>
               </a:xfrm>
               <a:prstGeom prst="rect">
                 <a:avLst/>
@@ -3272,19 +3245,29 @@
                   <a:rPr sz="1000" b="0" i="0" baseline="0" dirty="0">
                     <a:latin typeface="Calibri"/>
                   </a:rPr>
-                  <a:t>PD21 · LG ASSIGN calibration · 2011-2021 · 50 seeds · bracket </a:t>
+                  <a:t>PD21 · LG ASSIGN calibration · 2011-2021 · </a:t>
+                </a:r>
+                <a14:m>
+                  <m:oMath xmlns:m="http://schemas.openxmlformats.org/officeDocument/2006/math">
+                    <m:r>
+                      <a:rPr lang="en-US" sz="1000" b="0" i="0" baseline="0" dirty="0" smtClean="0">
+                        <a:latin typeface="Cambria Math" panose="02040503050406030204" pitchFamily="18" charset="0"/>
+                      </a:rPr>
+                      <m:t>50</m:t>
+                    </m:r>
+                  </m:oMath>
+                </a14:m>
+                <a:r>
+                  <a:rPr sz="1000" b="0" i="0" baseline="0" dirty="0">
+                    <a:latin typeface="Calibri"/>
+                  </a:rPr>
+                  <a:t> seeds · bracket </a:t>
                 </a:r>
                 <a:r>
                   <a:rPr sz="1000" b="0" i="0" baseline="0" dirty="0" err="1">
                     <a:latin typeface="Calibri"/>
                   </a:rPr>
                   <a:t>tol</a:t>
-                </a:r>
-                <a:r>
-                  <a:rPr lang="en-US" sz="1000" b="0" i="0" baseline="0" dirty="0">
-                    <a:latin typeface="Calibri"/>
-                  </a:rPr>
-                  <a:t> </a:t>
                 </a:r>
                 <a14:m>
                   <m:oMath xmlns:m="http://schemas.openxmlformats.org/officeDocument/2006/math">
@@ -3333,13 +3316,16 @@
                       <a:rPr lang="en-US" sz="1000" b="0" i="0" baseline="0" dirty="0">
                         <a:latin typeface="Cambria Math" panose="02040503050406030204" pitchFamily="18" charset="0"/>
                       </a:rPr>
-                      <m:t>≈0.0703</m:t>
+                      <m:t>≈0</m:t>
                     </m:r>
                   </m:oMath>
                 </a14:m>
-                <a:endParaRPr sz="1000" b="0" i="0" baseline="0" dirty="0">
-                  <a:latin typeface="Calibri"/>
-                </a:endParaRPr>
+                <a:r>
+                  <a:rPr sz="1000" b="0" i="0" baseline="0" dirty="0">
+                    <a:latin typeface="Calibri"/>
+                  </a:rPr>
+                  <a:t> · hero panel</a:t>
+                </a:r>
               </a:p>
             </p:txBody>
           </p:sp>
@@ -3356,13 +3342,13 @@
             <p:spPr>
               <a:xfrm>
                 <a:off x="384048" y="713232"/>
-                <a:ext cx="5406929" cy="246221"/>
+                <a:ext cx="5721118" cy="246221"/>
               </a:xfrm>
               <a:prstGeom prst="rect">
                 <a:avLst/>
               </a:prstGeom>
               <a:blipFill>
-                <a:blip r:embed="rId4"/>
+                <a:blip r:embed="rId3"/>
                 <a:stretch>
                   <a:fillRect b="-10000"/>
                 </a:stretch>
@@ -3383,6 +3369,30 @@
           </p:sp>
         </mc:Fallback>
       </mc:AlternateContent>
+      <p:pic>
+        <p:nvPicPr>
+          <p:cNvPr id="4" name="Picture 3" descr="PD21_rho_hsort_calibrate_2011_2021_bracket.png"/>
+          <p:cNvPicPr>
+            <a:picLocks noChangeAspect="1"/>
+          </p:cNvPicPr>
+          <p:nvPr/>
+        </p:nvPicPr>
+        <p:blipFill>
+          <a:blip r:embed="rId4"/>
+          <a:stretch>
+            <a:fillRect/>
+          </a:stretch>
+        </p:blipFill>
+        <p:spPr>
+          <a:xfrm>
+            <a:off x="4379976" y="1160349"/>
+            <a:ext cx="7653840" cy="4982550"/>
+          </a:xfrm>
+          <a:prstGeom prst="rect">
+            <a:avLst/>
+          </a:prstGeom>
+        </p:spPr>
+      </p:pic>
       <mc:AlternateContent xmlns:mc="http://schemas.openxmlformats.org/markup-compatibility/2006">
         <mc:Choice xmlns:a14="http://schemas.microsoft.com/office/drawing/2010/main" Requires="a14">
           <p:sp>
@@ -3393,8 +3403,8 @@
             </p:nvSpPr>
             <p:spPr>
               <a:xfrm>
-                <a:off x="182880" y="1053120"/>
-                <a:ext cx="2886323" cy="5296470"/>
+                <a:off x="283932" y="1199867"/>
+                <a:ext cx="4147904" cy="4481291"/>
               </a:xfrm>
               <a:prstGeom prst="rect">
                 <a:avLst/>
@@ -3402,15 +3412,23 @@
               <a:noFill/>
             </p:spPr>
             <p:txBody>
-              <a:bodyPr wrap="square" numCol="1">
-                <a:noAutofit/>
+              <a:bodyPr wrap="square">
+                <a:spAutoFit/>
               </a:bodyPr>
               <a:lstStyle/>
               <a:p>
                 <a:pPr>
-                  <a:lnSpc>
-                    <a:spcPct val="150000"/>
-                  </a:lnSpc>
+                  <a:buChar char="•"/>
+                </a:pPr>
+                <a:r>
+                  <a:rPr sz="1000" b="0" i="0" baseline="0" dirty="0">
+                    <a:latin typeface="Calibri"/>
+                  </a:rPr>
+                  <a:t>  PD21 locked calibration (Aug 2026): bracket search on hero panel for Alex ASSIGN $\rho$.</a:t>
+                </a:r>
+              </a:p>
+              <a:p>
+                <a:pPr>
                   <a:buChar char="•"/>
                 </a:pPr>
                 <a:r>
@@ -3492,23 +3510,33 @@
               </a:p>
               <a:p>
                 <a:pPr>
-                  <a:lnSpc>
-                    <a:spcPct val="150000"/>
-                  </a:lnSpc>
                   <a:buChar char="•"/>
                 </a:pPr>
                 <a:r>
                   <a:rPr sz="1000" b="0" i="0" baseline="0" dirty="0">
                     <a:latin typeface="Calibri"/>
                   </a:rPr>
-                  <a:t>  Panel: 2011–2021 hero MBB · min 20 min · empirical roster caps · PPM z within season.</a:t>
+                  <a:t>  Panel: 2011–2021 MBB · min</a:t>
+                </a:r>
+                <a14:m>
+                  <m:oMath xmlns:m="http://schemas.openxmlformats.org/officeDocument/2006/math">
+                    <m:r>
+                      <a:rPr lang="en-US" sz="1000" b="0" i="0" baseline="0" dirty="0" smtClean="0">
+                        <a:latin typeface="Cambria Math" panose="02040503050406030204" pitchFamily="18" charset="0"/>
+                      </a:rPr>
+                      <m:t>≥20</m:t>
+                    </m:r>
+                  </m:oMath>
+                </a14:m>
+                <a:r>
+                  <a:rPr sz="1000" b="0" i="0" baseline="0" dirty="0">
+                    <a:latin typeface="Calibri"/>
+                  </a:rPr>
+                  <a:t> min player-season drop · box QC at panel build · empirical roster caps · PPM z-scored within season.</a:t>
                 </a:r>
               </a:p>
               <a:p>
                 <a:pPr>
-                  <a:lnSpc>
-                    <a:spcPct val="150000"/>
-                  </a:lnSpc>
                   <a:buChar char="•"/>
                 </a:pPr>
                 <a:r>
@@ -3623,9 +3651,6 @@
               </a:p>
               <a:p>
                 <a:pPr>
-                  <a:lnSpc>
-                    <a:spcPct val="150000"/>
-                  </a:lnSpc>
                   <a:buChar char="•"/>
                 </a:pPr>
                 <a:r>
@@ -3948,9 +3973,6 @@
               </a:p>
               <a:p>
                 <a:pPr>
-                  <a:lnSpc>
-                    <a:spcPct val="150000"/>
-                  </a:lnSpc>
                   <a:buChar char="•"/>
                 </a:pPr>
                 <a:r>
@@ -3990,7 +4012,7 @@
                       <a:rPr lang="en-US" sz="1000" b="0" i="0" baseline="0" dirty="0">
                         <a:latin typeface="Cambria Math" panose="02040503050406030204" pitchFamily="18" charset="0"/>
                       </a:rPr>
-                      <m:t>≈0.07031</m:t>
+                      <m:t>≈0</m:t>
                     </m:r>
                   </m:oMath>
                 </a14:m>
@@ -4002,25 +4024,45 @@
                 </a:r>
                 <a14:m>
                   <m:oMath xmlns:m="http://schemas.openxmlformats.org/officeDocument/2006/math">
-                    <m:d>
-                      <m:dPr>
-                        <m:begChr m:val="|"/>
-                        <m:endChr m:val="|"/>
+                    <m:sSubSup>
+                      <m:sSubSupPr>
                         <m:ctrlPr>
                           <a:rPr lang="en-US" sz="1000" b="0" i="0" baseline="0" dirty="0">
                             <a:latin typeface="Cambria Math" panose="02040503050406030204" pitchFamily="18" charset="0"/>
                           </a:rPr>
                         </m:ctrlPr>
-                      </m:dPr>
+                      </m:sSubSupPr>
                       <m:e>
                         <m:r>
                           <a:rPr lang="en-US" sz="1000" b="0" i="0" baseline="0" dirty="0">
                             <a:latin typeface="Cambria Math" panose="02040503050406030204" pitchFamily="18" charset="0"/>
                           </a:rPr>
-                          <m:t>𝑒𝑟𝑟𝑜𝑟</m:t>
+                          <m:t>𝐻</m:t>
                         </m:r>
                       </m:e>
-                    </m:d>
+                      <m:sub>
+                        <m:r>
+                          <m:rPr>
+                            <m:sty m:val="p"/>
+                          </m:rPr>
+                          <a:rPr lang="en-US" sz="1000" b="0" i="0" baseline="0" dirty="0">
+                            <a:latin typeface="Cambria Math" panose="02040503050406030204" pitchFamily="18" charset="0"/>
+                          </a:rPr>
+                          <m:t>sort</m:t>
+                        </m:r>
+                      </m:sub>
+                      <m:sup>
+                        <m:r>
+                          <m:rPr>
+                            <m:sty m:val="p"/>
+                          </m:rPr>
+                          <a:rPr lang="en-US" sz="1000" b="0" i="0" baseline="0" dirty="0">
+                            <a:latin typeface="Cambria Math" panose="02040503050406030204" pitchFamily="18" charset="0"/>
+                          </a:rPr>
+                          <m:t>sim</m:t>
+                        </m:r>
+                      </m:sup>
+                    </m:sSubSup>
                   </m:oMath>
                 </a14:m>
                 <a:r>
@@ -4056,23 +4098,86 @@
                         </m:r>
                       </m:sup>
                     </m:sSup>
+                  </m:oMath>
+                </a14:m>
+                <a:r>
+                  <a:rPr sz="1000" b="0" i="0" baseline="0" dirty="0">
+                    <a:latin typeface="Calibri"/>
+                  </a:rPr>
+                  <a:t> </a:t>
+                </a:r>
+                <a14:m>
+                  <m:oMath xmlns:m="http://schemas.openxmlformats.org/officeDocument/2006/math">
                     <m:r>
                       <a:rPr lang="en-US" sz="1000" b="0" i="0" baseline="0" dirty="0" smtClean="0">
                         <a:latin typeface="Cambria Math" panose="02040503050406030204" pitchFamily="18" charset="0"/>
                       </a:rPr>
-                      <m:t>=1.5</m:t>
+                      <m:t>=0.082</m:t>
                     </m:r>
+                  </m:oMath>
+                </a14:m>
+                <a:r>
+                  <a:rPr sz="1000" b="0" i="0" baseline="0" dirty="0">
+                    <a:latin typeface="Calibri"/>
+                  </a:rPr>
+                  <a:t>; mean </a:t>
+                </a:r>
+                <a14:m>
+                  <m:oMath xmlns:m="http://schemas.openxmlformats.org/officeDocument/2006/math">
+                    <m:sSubSup>
+                      <m:sSubSupPr>
+                        <m:ctrlPr>
+                          <a:rPr lang="en-US" sz="1000" b="0" i="0" baseline="0" dirty="0">
+                            <a:latin typeface="Cambria Math" panose="02040503050406030204" pitchFamily="18" charset="0"/>
+                          </a:rPr>
+                        </m:ctrlPr>
+                      </m:sSubSupPr>
+                      <m:e>
+                        <m:r>
+                          <a:rPr lang="en-US" sz="1000" b="0" i="0" baseline="0" dirty="0">
+                            <a:latin typeface="Cambria Math" panose="02040503050406030204" pitchFamily="18" charset="0"/>
+                          </a:rPr>
+                          <m:t>𝐻</m:t>
+                        </m:r>
+                      </m:e>
+                      <m:sub>
+                        <m:r>
+                          <m:rPr>
+                            <m:sty m:val="p"/>
+                          </m:rPr>
+                          <a:rPr lang="en-US" sz="1000" b="0" i="0" baseline="0" dirty="0">
+                            <a:latin typeface="Cambria Math" panose="02040503050406030204" pitchFamily="18" charset="0"/>
+                          </a:rPr>
+                          <m:t>sort</m:t>
+                        </m:r>
+                      </m:sub>
+                      <m:sup>
+                        <m:r>
+                          <m:rPr>
+                            <m:sty m:val="p"/>
+                          </m:rPr>
+                          <a:rPr lang="en-US" sz="1000" b="0" i="0" baseline="0" dirty="0">
+                            <a:latin typeface="Cambria Math" panose="02040503050406030204" pitchFamily="18" charset="0"/>
+                          </a:rPr>
+                          <m:t>emp</m:t>
+                        </m:r>
+                      </m:sup>
+                    </m:sSubSup>
+                  </m:oMath>
+                </a14:m>
+                <a:r>
+                  <a:rPr sz="1000" b="0" i="0" baseline="0" dirty="0">
+                    <a:latin typeface="Calibri"/>
+                  </a:rPr>
+                  <a:t> </a:t>
+                </a:r>
+                <a14:m>
+                  <m:oMath xmlns:m="http://schemas.openxmlformats.org/officeDocument/2006/math">
                     <m:r>
                       <a:rPr lang="en-US" sz="1000" b="0" i="0" baseline="0" dirty="0" smtClean="0">
                         <a:latin typeface="Cambria Math" panose="02040503050406030204" pitchFamily="18" charset="0"/>
                       </a:rPr>
-                      <m:t>𝑒</m:t>
-                    </m:r>
-                    <m:r>
-                      <a:rPr lang="en-US" sz="1000" b="0" i="0" baseline="0" dirty="0" smtClean="0">
-                        <a:latin typeface="Cambria Math" panose="02040503050406030204" pitchFamily="18" charset="0"/>
-                      </a:rPr>
-                      <m:t>−05</m:t>
+                      <m:t>=0.064</m:t>
                     </m:r>
                   </m:oMath>
                 </a14:m>
@@ -4085,16 +4190,13 @@
               </a:p>
               <a:p>
                 <a:pPr>
-                  <a:lnSpc>
-                    <a:spcPct val="150000"/>
-                  </a:lnSpc>
                   <a:buChar char="•"/>
                 </a:pPr>
                 <a:r>
                   <a:rPr sz="1000" b="0" i="0" baseline="0" dirty="0">
                     <a:latin typeface="Calibri"/>
                   </a:rPr>
-                  <a:t>  Per-season: 6/11 seasons at </a:t>
+                  <a:t>  Per-season: 11/11 seasons at </a:t>
                 </a:r>
                 <a14:m>
                   <m:oMath xmlns:m="http://schemas.openxmlformats.org/officeDocument/2006/math">
@@ -4135,7 +4237,7 @@
                   <a:rPr sz="1000" b="0" i="0" baseline="0" dirty="0">
                     <a:latin typeface="Calibri"/>
                   </a:rPr>
-                  <a:t>; nonzero — 2013: </a:t>
+                  <a:t>; all at </a:t>
                 </a:r>
                 <a14:m>
                   <m:oMath xmlns:m="http://schemas.openxmlformats.org/officeDocument/2006/math">
@@ -4168,7 +4270,7 @@
                       <a:rPr lang="en-US" sz="1000" b="0" i="0" baseline="0" dirty="0">
                         <a:latin typeface="Cambria Math" panose="02040503050406030204" pitchFamily="18" charset="0"/>
                       </a:rPr>
-                      <m:t>≈0.0715</m:t>
+                      <m:t>=0</m:t>
                     </m:r>
                   </m:oMath>
                 </a14:m>
@@ -4176,175 +4278,11 @@
                   <a:rPr sz="1000" b="0" i="0" baseline="0" dirty="0">
                     <a:latin typeface="Calibri"/>
                   </a:rPr>
-                  <a:t>, 2015: </a:t>
-                </a:r>
-                <a14:m>
-                  <m:oMath xmlns:m="http://schemas.openxmlformats.org/officeDocument/2006/math">
-                    <m:sSup>
-                      <m:sSupPr>
-                        <m:ctrlPr>
-                          <a:rPr lang="en-US" sz="1000" b="0" i="0" baseline="0" dirty="0">
-                            <a:latin typeface="Cambria Math" panose="02040503050406030204" pitchFamily="18" charset="0"/>
-                          </a:rPr>
-                        </m:ctrlPr>
-                      </m:sSupPr>
-                      <m:e>
-                        <m:r>
-                          <a:rPr lang="en-US" sz="1000" b="0" i="0" baseline="0" dirty="0">
-                            <a:latin typeface="Cambria Math" panose="02040503050406030204" pitchFamily="18" charset="0"/>
-                          </a:rPr>
-                          <m:t>𝜌</m:t>
-                        </m:r>
-                      </m:e>
-                      <m:sup>
-                        <m:r>
-                          <a:rPr lang="en-US" sz="1000" b="0" i="0" baseline="0" dirty="0">
-                            <a:latin typeface="Cambria Math" panose="02040503050406030204" pitchFamily="18" charset="0"/>
-                          </a:rPr>
-                          <m:t>∗</m:t>
-                        </m:r>
-                      </m:sup>
-                    </m:sSup>
-                    <m:r>
-                      <a:rPr lang="en-US" sz="1000" b="0" i="0" baseline="0" dirty="0">
-                        <a:latin typeface="Cambria Math" panose="02040503050406030204" pitchFamily="18" charset="0"/>
-                      </a:rPr>
-                      <m:t>≈0.0668</m:t>
-                    </m:r>
-                  </m:oMath>
-                </a14:m>
-                <a:r>
-                  <a:rPr sz="1000" b="0" i="0" baseline="0" dirty="0">
-                    <a:latin typeface="Calibri"/>
-                  </a:rPr>
-                  <a:t>, 2018: </a:t>
-                </a:r>
-                <a14:m>
-                  <m:oMath xmlns:m="http://schemas.openxmlformats.org/officeDocument/2006/math">
-                    <m:sSup>
-                      <m:sSupPr>
-                        <m:ctrlPr>
-                          <a:rPr lang="en-US" sz="1000" b="0" i="0" baseline="0" dirty="0">
-                            <a:latin typeface="Cambria Math" panose="02040503050406030204" pitchFamily="18" charset="0"/>
-                          </a:rPr>
-                        </m:ctrlPr>
-                      </m:sSupPr>
-                      <m:e>
-                        <m:r>
-                          <a:rPr lang="en-US" sz="1000" b="0" i="0" baseline="0" dirty="0">
-                            <a:latin typeface="Cambria Math" panose="02040503050406030204" pitchFamily="18" charset="0"/>
-                          </a:rPr>
-                          <m:t>𝜌</m:t>
-                        </m:r>
-                      </m:e>
-                      <m:sup>
-                        <m:r>
-                          <a:rPr lang="en-US" sz="1000" b="0" i="0" baseline="0" dirty="0">
-                            <a:latin typeface="Cambria Math" panose="02040503050406030204" pitchFamily="18" charset="0"/>
-                          </a:rPr>
-                          <m:t>∗</m:t>
-                        </m:r>
-                      </m:sup>
-                    </m:sSup>
-                    <m:r>
-                      <a:rPr lang="en-US" sz="1000" b="0" i="0" baseline="0" dirty="0">
-                        <a:latin typeface="Cambria Math" panose="02040503050406030204" pitchFamily="18" charset="0"/>
-                      </a:rPr>
-                      <m:t>≈0.0168</m:t>
-                    </m:r>
-                  </m:oMath>
-                </a14:m>
-                <a:r>
-                  <a:rPr sz="1000" b="0" i="0" baseline="0" dirty="0">
-                    <a:latin typeface="Calibri"/>
-                  </a:rPr>
-                  <a:t>, 2019: </a:t>
-                </a:r>
-                <a14:m>
-                  <m:oMath xmlns:m="http://schemas.openxmlformats.org/officeDocument/2006/math">
-                    <m:sSup>
-                      <m:sSupPr>
-                        <m:ctrlPr>
-                          <a:rPr lang="en-US" sz="1000" b="0" i="0" baseline="0" dirty="0">
-                            <a:latin typeface="Cambria Math" panose="02040503050406030204" pitchFamily="18" charset="0"/>
-                          </a:rPr>
-                        </m:ctrlPr>
-                      </m:sSupPr>
-                      <m:e>
-                        <m:r>
-                          <a:rPr lang="en-US" sz="1000" b="0" i="0" baseline="0" dirty="0">
-                            <a:latin typeface="Cambria Math" panose="02040503050406030204" pitchFamily="18" charset="0"/>
-                          </a:rPr>
-                          <m:t>𝜌</m:t>
-                        </m:r>
-                      </m:e>
-                      <m:sup>
-                        <m:r>
-                          <a:rPr lang="en-US" sz="1000" b="0" i="0" baseline="0" dirty="0">
-                            <a:latin typeface="Cambria Math" panose="02040503050406030204" pitchFamily="18" charset="0"/>
-                          </a:rPr>
-                          <m:t>∗</m:t>
-                        </m:r>
-                      </m:sup>
-                    </m:sSup>
-                    <m:r>
-                      <a:rPr lang="en-US" sz="1000" b="0" i="0" baseline="0" dirty="0">
-                        <a:latin typeface="Cambria Math" panose="02040503050406030204" pitchFamily="18" charset="0"/>
-                      </a:rPr>
-                      <m:t>≈0.0293</m:t>
-                    </m:r>
-                  </m:oMath>
-                </a14:m>
-                <a:r>
-                  <a:rPr sz="1000" b="0" i="0" baseline="0" dirty="0">
-                    <a:latin typeface="Calibri"/>
-                  </a:rPr>
-                  <a:t>, 2021: </a:t>
-                </a:r>
-                <a14:m>
-                  <m:oMath xmlns:m="http://schemas.openxmlformats.org/officeDocument/2006/math">
-                    <m:sSup>
-                      <m:sSupPr>
-                        <m:ctrlPr>
-                          <a:rPr lang="en-US" sz="1000" b="0" i="0" baseline="0" dirty="0">
-                            <a:latin typeface="Cambria Math" panose="02040503050406030204" pitchFamily="18" charset="0"/>
-                          </a:rPr>
-                        </m:ctrlPr>
-                      </m:sSupPr>
-                      <m:e>
-                        <m:r>
-                          <a:rPr lang="en-US" sz="1000" b="0" i="0" baseline="0" dirty="0">
-                            <a:latin typeface="Cambria Math" panose="02040503050406030204" pitchFamily="18" charset="0"/>
-                          </a:rPr>
-                          <m:t>𝜌</m:t>
-                        </m:r>
-                      </m:e>
-                      <m:sup>
-                        <m:r>
-                          <a:rPr lang="en-US" sz="1000" b="0" i="0" baseline="0" dirty="0">
-                            <a:latin typeface="Cambria Math" panose="02040503050406030204" pitchFamily="18" charset="0"/>
-                          </a:rPr>
-                          <m:t>∗</m:t>
-                        </m:r>
-                      </m:sup>
-                    </m:sSup>
-                    <m:r>
-                      <a:rPr lang="en-US" sz="1000" b="0" i="0" baseline="0" dirty="0">
-                        <a:latin typeface="Cambria Math" panose="02040503050406030204" pitchFamily="18" charset="0"/>
-                      </a:rPr>
-                      <m:t>≈0.0652</m:t>
-                    </m:r>
-                  </m:oMath>
-                </a14:m>
-                <a:endParaRPr sz="1000" b="0" i="0" baseline="0" dirty="0">
-                  <a:latin typeface="Calibri"/>
-                </a:endParaRPr>
+                  <a:t>.</a:t>
+                </a:r>
               </a:p>
               <a:p>
                 <a:pPr>
-                  <a:lnSpc>
-                    <a:spcPct val="150000"/>
-                  </a:lnSpc>
                   <a:buChar char="•"/>
                 </a:pPr>
                 <a:r>
@@ -4400,7 +4338,7 @@
                       <a:rPr lang="en-US" sz="1000" b="0" i="0" baseline="0" dirty="0">
                         <a:latin typeface="Cambria Math" panose="02040503050406030204" pitchFamily="18" charset="0"/>
                       </a:rPr>
-                      <m:t>≈0.098</m:t>
+                      <m:t>≈0.112</m:t>
                     </m:r>
                   </m:oMath>
                 </a14:m>
@@ -4416,19 +4354,7 @@
                       <a:rPr lang="en-US" sz="1000" b="0" i="0" baseline="0" dirty="0" smtClean="0">
                         <a:latin typeface="Cambria Math" panose="02040503050406030204" pitchFamily="18" charset="0"/>
                       </a:rPr>
-                      <m:t>≈1.5</m:t>
-                    </m:r>
-                    <m:r>
-                      <a:rPr lang="en-US" sz="1000" b="0" i="0" baseline="0" dirty="0" smtClean="0">
-                        <a:latin typeface="Cambria Math" panose="02040503050406030204" pitchFamily="18" charset="0"/>
-                      </a:rPr>
-                      <m:t>𝑒</m:t>
-                    </m:r>
-                    <m:r>
-                      <a:rPr lang="en-US" sz="1000" b="0" i="0" baseline="0" dirty="0" smtClean="0">
-                        <a:latin typeface="Cambria Math" panose="02040503050406030204" pitchFamily="18" charset="0"/>
-                      </a:rPr>
-                      <m:t>−05</m:t>
+                      <m:t>≈0.018</m:t>
                     </m:r>
                   </m:oMath>
                 </a14:m>
@@ -4476,16 +4402,116 @@
               </a:p>
               <a:p>
                 <a:pPr>
-                  <a:lnSpc>
-                    <a:spcPct val="150000"/>
-                  </a:lnSpc>
                   <a:buChar char="•"/>
                 </a:pPr>
                 <a:r>
                   <a:rPr sz="1000" b="0" i="0" baseline="0" dirty="0">
                     <a:latin typeface="Calibri"/>
                   </a:rPr>
-                  <a:t>  VECTOR lock: </a:t>
+                  <a:t>  Figure bottom-right inset: per-season </a:t>
+                </a:r>
+                <a14:m>
+                  <m:oMath xmlns:m="http://schemas.openxmlformats.org/officeDocument/2006/math">
+                    <m:sSup>
+                      <m:sSupPr>
+                        <m:ctrlPr>
+                          <a:rPr lang="en-US" sz="1000" b="0" i="0" baseline="0" dirty="0">
+                            <a:latin typeface="Cambria Math" panose="02040503050406030204" pitchFamily="18" charset="0"/>
+                          </a:rPr>
+                        </m:ctrlPr>
+                      </m:sSupPr>
+                      <m:e>
+                        <m:r>
+                          <a:rPr lang="en-US" sz="1000" b="0" i="0" baseline="0" dirty="0">
+                            <a:latin typeface="Cambria Math" panose="02040503050406030204" pitchFamily="18" charset="0"/>
+                          </a:rPr>
+                          <m:t>𝜌</m:t>
+                        </m:r>
+                      </m:e>
+                      <m:sup>
+                        <m:r>
+                          <a:rPr lang="en-US" sz="1000" b="0" i="0" baseline="0" dirty="0">
+                            <a:latin typeface="Cambria Math" panose="02040503050406030204" pitchFamily="18" charset="0"/>
+                          </a:rPr>
+                          <m:t>∗</m:t>
+                        </m:r>
+                      </m:sup>
+                    </m:sSup>
+                  </m:oMath>
+                </a14:m>
+                <a:r>
+                  <a:rPr sz="1000" b="0" i="0" baseline="0" dirty="0">
+                    <a:latin typeface="Calibri"/>
+                  </a:rPr>
+                  <a:t> — flat at </a:t>
+                </a:r>
+                <a14:m>
+                  <m:oMath xmlns:m="http://schemas.openxmlformats.org/officeDocument/2006/math">
+                    <m:r>
+                      <a:rPr lang="en-US" sz="1000" b="0" i="0" baseline="0" dirty="0" smtClean="0">
+                        <a:latin typeface="Cambria Math" panose="02040503050406030204" pitchFamily="18" charset="0"/>
+                      </a:rPr>
+                      <m:t>0</m:t>
+                    </m:r>
+                  </m:oMath>
+                </a14:m>
+                <a:r>
+                  <a:rPr sz="1000" b="0" i="0" baseline="0" dirty="0">
+                    <a:latin typeface="Calibri"/>
+                  </a:rPr>
+                  <a:t> all seasons on hero panel.</a:t>
+                </a:r>
+              </a:p>
+              <a:p>
+                <a:pPr>
+                  <a:buChar char="•"/>
+                </a:pPr>
+                <a:r>
+                  <a:rPr sz="1000" b="0" i="0" baseline="0" dirty="0">
+                    <a:latin typeface="Calibri"/>
+                  </a:rPr>
+                  <a:t>  </a:t>
+                </a:r>
+                <a14:m>
+                  <m:oMath xmlns:m="http://schemas.openxmlformats.org/officeDocument/2006/math">
+                    <m:sSup>
+                      <m:sSupPr>
+                        <m:ctrlPr>
+                          <a:rPr lang="en-US" sz="1000" b="0" i="0" baseline="0" dirty="0">
+                            <a:latin typeface="Cambria Math" panose="02040503050406030204" pitchFamily="18" charset="0"/>
+                          </a:rPr>
+                        </m:ctrlPr>
+                      </m:sSupPr>
+                      <m:e>
+                        <m:r>
+                          <a:rPr lang="en-US" sz="1000" b="0" i="0" baseline="0" dirty="0">
+                            <a:latin typeface="Cambria Math" panose="02040503050406030204" pitchFamily="18" charset="0"/>
+                          </a:rPr>
+                          <m:t>𝜌</m:t>
+                        </m:r>
+                      </m:e>
+                      <m:sup>
+                        <m:r>
+                          <a:rPr lang="en-US" sz="1000" b="0" i="0" baseline="0" dirty="0">
+                            <a:latin typeface="Cambria Math" panose="02040503050406030204" pitchFamily="18" charset="0"/>
+                          </a:rPr>
+                          <m:t>∗</m:t>
+                        </m:r>
+                      </m:sup>
+                    </m:sSup>
+                    <m:r>
+                      <a:rPr lang="en-US" sz="1000" b="0" i="0" baseline="0" dirty="0">
+                        <a:latin typeface="Cambria Math" panose="02040503050406030204" pitchFamily="18" charset="0"/>
+                      </a:rPr>
+                      <m:t>=0</m:t>
+                    </m:r>
+                  </m:oMath>
+                </a14:m>
+                <a:r>
+                  <a:rPr sz="1000" b="0" i="0" baseline="0" dirty="0">
+                    <a:latin typeface="Calibri"/>
+                  </a:rPr>
+                  <a:t> — what we DO say: on the locked hero panel, the LG ASSIGN homophily knob calibrates to zero (11/11 seasons); empirical </a:t>
                 </a:r>
                 <a14:m>
                   <m:oMath xmlns:m="http://schemas.openxmlformats.org/officeDocument/2006/math">
@@ -4507,20 +4533,125 @@
                       </m:e>
                       <m:sub>
                         <m:r>
-                          <a:rPr lang="en-US" sz="1000" b="0" i="0" baseline="0" dirty="0">
-                            <a:latin typeface="Cambria Math" panose="02040503050406030204" pitchFamily="18" charset="0"/>
-                          </a:rPr>
-                          <m:t>𝑠𝑜𝑟𝑡</m:t>
+                          <m:rPr>
+                            <m:sty m:val="p"/>
+                          </m:rPr>
+                          <a:rPr lang="en-US" sz="1000" b="0" i="0" baseline="0" dirty="0">
+                            <a:latin typeface="Cambria Math" panose="02040503050406030204" pitchFamily="18" charset="0"/>
+                          </a:rPr>
+                          <m:t>sort</m:t>
                         </m:r>
                       </m:sub>
                     </m:sSub>
+                    <m:r>
+                      <a:rPr lang="en-US" sz="1000" b="0" i="0" baseline="0" dirty="0">
+                        <a:latin typeface="Cambria Math" panose="02040503050406030204" pitchFamily="18" charset="0"/>
+                      </a:rPr>
+                      <m:t>≈0.064</m:t>
+                    </m:r>
                   </m:oMath>
                 </a14:m>
                 <a:r>
                   <a:rPr sz="1000" b="0" i="0" baseline="0" dirty="0">
                     <a:latin typeface="Calibri"/>
                   </a:rPr>
-                  <a:t> is realized sorting — not the generative homophily knob </a:t>
+                  <a:t> (</a:t>
+                </a:r>
+                <a14:m>
+                  <m:oMath xmlns:m="http://schemas.openxmlformats.org/officeDocument/2006/math">
+                    <m:r>
+                      <a:rPr lang="en-US" sz="1000" b="0" i="0" baseline="0" dirty="0" smtClean="0">
+                        <a:latin typeface="Cambria Math" panose="02040503050406030204" pitchFamily="18" charset="0"/>
+                      </a:rPr>
+                      <m:t>≈0.0642059</m:t>
+                    </m:r>
+                  </m:oMath>
+                </a14:m>
+                <a:r>
+                  <a:rPr sz="1000" b="0" i="0" baseline="0" dirty="0">
+                    <a:latin typeface="Calibri"/>
+                  </a:rPr>
+                  <a:t> on </a:t>
+                </a:r>
+                <a14:m>
+                  <m:oMath xmlns:m="http://schemas.openxmlformats.org/officeDocument/2006/math">
+                    <m:d>
+                      <m:dPr>
+                        <m:begChr m:val="["/>
+                        <m:endChr m:val="]"/>
+                        <m:ctrlPr>
+                          <a:rPr lang="en-US" sz="1000" b="0" i="0" baseline="0" dirty="0">
+                            <a:latin typeface="Cambria Math" panose="02040503050406030204" pitchFamily="18" charset="0"/>
+                          </a:rPr>
+                        </m:ctrlPr>
+                      </m:dPr>
+                      <m:e>
+                        <m:r>
+                          <a:rPr lang="en-US" sz="1000" b="0" i="0" baseline="0" dirty="0">
+                            <a:latin typeface="Cambria Math" panose="02040503050406030204" pitchFamily="18" charset="0"/>
+                          </a:rPr>
+                          <m:t>0,1</m:t>
+                        </m:r>
+                      </m:e>
+                    </m:d>
+                  </m:oMath>
+                </a14:m>
+                <a:r>
+                  <a:rPr sz="1000" b="0" i="0" baseline="0" dirty="0">
+                    <a:latin typeface="Calibri"/>
+                  </a:rPr>
+                  <a:t> scale); sim at </a:t>
+                </a:r>
+                <a14:m>
+                  <m:oMath xmlns:m="http://schemas.openxmlformats.org/officeDocument/2006/math">
+                    <m:sSup>
+                      <m:sSupPr>
+                        <m:ctrlPr>
+                          <a:rPr lang="en-US" sz="1000" b="0" i="0" baseline="0" dirty="0">
+                            <a:latin typeface="Cambria Math" panose="02040503050406030204" pitchFamily="18" charset="0"/>
+                          </a:rPr>
+                        </m:ctrlPr>
+                      </m:sSupPr>
+                      <m:e>
+                        <m:r>
+                          <a:rPr lang="en-US" sz="1000" b="0" i="0" baseline="0" dirty="0">
+                            <a:latin typeface="Cambria Math" panose="02040503050406030204" pitchFamily="18" charset="0"/>
+                          </a:rPr>
+                          <m:t>𝜌</m:t>
+                        </m:r>
+                      </m:e>
+                      <m:sup>
+                        <m:r>
+                          <a:rPr lang="en-US" sz="1000" b="0" i="0" baseline="0" dirty="0">
+                            <a:latin typeface="Cambria Math" panose="02040503050406030204" pitchFamily="18" charset="0"/>
+                          </a:rPr>
+                          <m:t>∗</m:t>
+                        </m:r>
+                      </m:sup>
+                    </m:sSup>
+                  </m:oMath>
+                </a14:m>
+                <a:r>
+                  <a:rPr sz="1000" b="0" i="0" baseline="0" dirty="0">
+                    <a:latin typeface="Calibri"/>
+                  </a:rPr>
+                  <a:t> slightly high (</a:t>
+                </a:r>
+                <a14:m>
+                  <m:oMath xmlns:m="http://schemas.openxmlformats.org/officeDocument/2006/math">
+                    <m:r>
+                      <a:rPr lang="en-US" sz="1000" b="0" i="0" baseline="0" dirty="0" smtClean="0">
+                        <a:latin typeface="Cambria Math" panose="02040503050406030204" pitchFamily="18" charset="0"/>
+                      </a:rPr>
+                      <m:t>≈0.0821529</m:t>
+                    </m:r>
+                  </m:oMath>
+                </a14:m>
+                <a:r>
+                  <a:rPr sz="1000" b="0" i="0" baseline="0" dirty="0">
+                    <a:latin typeface="Calibri"/>
+                  </a:rPr>
+                  <a:t>); turning </a:t>
                 </a:r>
                 <a14:m>
                   <m:oMath xmlns:m="http://schemas.openxmlformats.org/officeDocument/2006/math">
@@ -4536,21 +4667,40 @@
                   <a:rPr sz="1000" b="0" i="0" baseline="0" dirty="0">
                     <a:latin typeface="Calibri"/>
                   </a:rPr>
-                  <a:t>.</a:t>
+                  <a:t> up overshoots (see legacy </a:t>
+                </a:r>
+                <a14:m>
+                  <m:oMath xmlns:m="http://schemas.openxmlformats.org/officeDocument/2006/math">
+                    <m:r>
+                      <a:rPr lang="en-US" sz="1000" b="0" i="0" baseline="0" dirty="0" smtClean="0">
+                        <a:latin typeface="Cambria Math" panose="02040503050406030204" pitchFamily="18" charset="0"/>
+                      </a:rPr>
+                      <m:t>𝜌</m:t>
+                    </m:r>
+                    <m:r>
+                      <a:rPr lang="en-US" sz="1000" b="0" i="0" baseline="0" dirty="0" smtClean="0">
+                        <a:latin typeface="Cambria Math" panose="02040503050406030204" pitchFamily="18" charset="0"/>
+                      </a:rPr>
+                      <m:t>=0.5</m:t>
+                    </m:r>
+                  </m:oMath>
+                </a14:m>
+                <a:r>
+                  <a:rPr sz="1000" b="0" i="0" baseline="0" dirty="0">
+                    <a:latin typeface="Calibri"/>
+                  </a:rPr>
+                  <a:t> bullet).</a:t>
                 </a:r>
               </a:p>
               <a:p>
                 <a:pPr>
-                  <a:lnSpc>
-                    <a:spcPct val="150000"/>
-                  </a:lnSpc>
                   <a:buChar char="•"/>
                 </a:pPr>
                 <a:r>
                   <a:rPr sz="1000" b="0" i="0" baseline="0" dirty="0">
                     <a:latin typeface="Calibri"/>
                   </a:rPr>
-                  <a:t>  Figure: small multiples — blue sim curve, red empirical line, green </a:t>
+                  <a:t>  </a:t>
                 </a:r>
                 <a14:m>
                   <m:oMath xmlns:m="http://schemas.openxmlformats.org/officeDocument/2006/math">
@@ -4579,13 +4729,84 @@
                         </m:r>
                       </m:sup>
                     </m:sSup>
+                    <m:r>
+                      <a:rPr lang="en-US" sz="1000" b="0" i="0" baseline="0" dirty="0">
+                        <a:latin typeface="Cambria Math" panose="02040503050406030204" pitchFamily="18" charset="0"/>
+                      </a:rPr>
+                      <m:t>=0</m:t>
+                    </m:r>
                   </m:oMath>
                 </a14:m>
                 <a:r>
                   <a:rPr sz="1000" b="0" i="0" baseline="0" dirty="0">
                     <a:latin typeface="Calibri"/>
                   </a:rPr>
-                  <a:t> (x-axis zoomed to evaluated bracket; reference </a:t>
+                  <a:t> — what we DO NOT say: NCAA has no team formation; Duke and a weak D-I school draw from the same talent pool; real-world assortativity is absent; Hero inverted-U / </a:t>
+                </a:r>
+                <a14:m>
+                  <m:oMath xmlns:m="http://schemas.openxmlformats.org/officeDocument/2006/math">
+                    <m:r>
+                      <a:rPr lang="en-US" sz="1000" b="0" i="0" baseline="0" dirty="0" smtClean="0">
+                        <a:latin typeface="Cambria Math" panose="02040503050406030204" pitchFamily="18" charset="0"/>
+                      </a:rPr>
+                      <m:t>𝜆</m:t>
+                    </m:r>
+                  </m:oMath>
+                </a14:m>
+                <a:r>
+                  <a:rPr sz="1000" b="0" i="0" baseline="0" dirty="0">
+                    <a:latin typeface="Calibri"/>
+                  </a:rPr>
+                  <a:t> / SELECT story is dead.</a:t>
+                </a:r>
+              </a:p>
+              <a:p>
+                <a:pPr>
+                  <a:buChar char="•"/>
+                </a:pPr>
+                <a:r>
+                  <a:rPr sz="1000" b="0" i="0" baseline="0" dirty="0">
+                    <a:latin typeface="Calibri"/>
+                  </a:rPr>
+                  <a:t>  </a:t>
+                </a:r>
+                <a14:m>
+                  <m:oMath xmlns:m="http://schemas.openxmlformats.org/officeDocument/2006/math">
+                    <m:sSub>
+                      <m:sSubPr>
+                        <m:ctrlPr>
+                          <a:rPr lang="en-US" sz="1000" b="0" i="0" baseline="0" dirty="0">
+                            <a:latin typeface="Cambria Math" panose="02040503050406030204" pitchFamily="18" charset="0"/>
+                          </a:rPr>
+                        </m:ctrlPr>
+                      </m:sSubPr>
+                      <m:e>
+                        <m:r>
+                          <a:rPr lang="en-US" sz="1000" b="0" i="0" baseline="0" dirty="0">
+                            <a:latin typeface="Cambria Math" panose="02040503050406030204" pitchFamily="18" charset="0"/>
+                          </a:rPr>
+                          <m:t>𝐻</m:t>
+                        </m:r>
+                      </m:e>
+                      <m:sub>
+                        <m:r>
+                          <m:rPr>
+                            <m:sty m:val="p"/>
+                          </m:rPr>
+                          <a:rPr lang="en-US" sz="1000" b="0" i="0" baseline="0" dirty="0">
+                            <a:latin typeface="Cambria Math" panose="02040503050406030204" pitchFamily="18" charset="0"/>
+                          </a:rPr>
+                          <m:t>sort</m:t>
+                        </m:r>
+                      </m:sub>
+                    </m:sSub>
+                  </m:oMath>
+                </a14:m>
+                <a:r>
+                  <a:rPr sz="1000" b="0" i="0" baseline="0" dirty="0">
+                    <a:latin typeface="Calibri"/>
+                  </a:rPr>
+                  <a:t> is realized sorting on a fixed roster partition (VECTOR lock) — not the generative </a:t>
                 </a:r>
                 <a14:m>
                   <m:oMath xmlns:m="http://schemas.openxmlformats.org/officeDocument/2006/math">
@@ -4601,7 +4822,231 @@
                   <a:rPr sz="1000" b="0" i="0" baseline="0" dirty="0">
                     <a:latin typeface="Calibri"/>
                   </a:rPr>
-                  <a:t> excluded from axis).</a:t>
+                  <a:t> knob. Box QC lowered measured </a:t>
+                </a:r>
+                <a14:m>
+                  <m:oMath xmlns:m="http://schemas.openxmlformats.org/officeDocument/2006/math">
+                    <m:sSub>
+                      <m:sSubPr>
+                        <m:ctrlPr>
+                          <a:rPr lang="en-US" sz="1000" b="0" i="0" baseline="0" dirty="0">
+                            <a:latin typeface="Cambria Math" panose="02040503050406030204" pitchFamily="18" charset="0"/>
+                          </a:rPr>
+                        </m:ctrlPr>
+                      </m:sSubPr>
+                      <m:e>
+                        <m:r>
+                          <a:rPr lang="en-US" sz="1000" b="0" i="0" baseline="0" dirty="0">
+                            <a:latin typeface="Cambria Math" panose="02040503050406030204" pitchFamily="18" charset="0"/>
+                          </a:rPr>
+                          <m:t>𝐻</m:t>
+                        </m:r>
+                      </m:e>
+                      <m:sub>
+                        <m:r>
+                          <m:rPr>
+                            <m:sty m:val="p"/>
+                          </m:rPr>
+                          <a:rPr lang="en-US" sz="1000" b="0" i="0" baseline="0" dirty="0">
+                            <a:latin typeface="Cambria Math" panose="02040503050406030204" pitchFamily="18" charset="0"/>
+                          </a:rPr>
+                          <m:t>sort</m:t>
+                        </m:r>
+                      </m:sub>
+                    </m:sSub>
+                  </m:oMath>
+                </a14:m>
+                <a:r>
+                  <a:rPr sz="1000" b="0" i="0" baseline="0" dirty="0">
+                    <a:latin typeface="Calibri"/>
+                  </a:rPr>
+                  <a:t> vs pre-QC (</a:t>
+                </a:r>
+                <a14:m>
+                  <m:oMath xmlns:m="http://schemas.openxmlformats.org/officeDocument/2006/math">
+                    <m:r>
+                      <a:rPr lang="en-US" sz="1000" b="0" i="0" baseline="0" dirty="0" smtClean="0">
+                        <a:latin typeface="Cambria Math" panose="02040503050406030204" pitchFamily="18" charset="0"/>
+                      </a:rPr>
+                      <m:t>∼0.10→∼0.06</m:t>
+                    </m:r>
+                  </m:oMath>
+                </a14:m>
+                <a:r>
+                  <a:rPr sz="1000" b="0" i="0" baseline="0" dirty="0">
+                    <a:latin typeface="Calibri"/>
+                  </a:rPr>
+                  <a:t>); modest </a:t>
+                </a:r>
+                <a14:m>
+                  <m:oMath xmlns:m="http://schemas.openxmlformats.org/officeDocument/2006/math">
+                    <m:r>
+                      <a:rPr lang="en-US" sz="1000" b="0" i="0" baseline="0" dirty="0" smtClean="0">
+                        <a:latin typeface="Cambria Math" panose="02040503050406030204" pitchFamily="18" charset="0"/>
+                      </a:rPr>
+                      <m:t>≠</m:t>
+                    </m:r>
+                  </m:oMath>
+                </a14:m>
+                <a:r>
+                  <a:rPr sz="1000" b="0" i="0" baseline="0" dirty="0">
+                    <a:latin typeface="Calibri"/>
+                  </a:rPr>
+                  <a:t> zero. Contrast: slide</a:t>
+                </a:r>
+                <a:r>
+                  <a:rPr lang="en-US" sz="1000" b="0" i="0" baseline="0" dirty="0">
+                    <a:latin typeface="Calibri"/>
+                  </a:rPr>
+                  <a:t> 6 </a:t>
+                </a:r>
+                <a:r>
+                  <a:rPr sz="1000" b="0" i="0" baseline="0" dirty="0">
+                    <a:latin typeface="Calibri"/>
+                  </a:rPr>
+                  <a:t> </a:t>
+                </a:r>
+                <a14:m>
+                  <m:oMath xmlns:m="http://schemas.openxmlformats.org/officeDocument/2006/math">
+                    <m:r>
+                      <a:rPr lang="en-US" sz="1000" b="0" i="0" baseline="0" dirty="0" smtClean="0">
+                        <a:latin typeface="Cambria Math" panose="02040503050406030204" pitchFamily="18" charset="0"/>
+                      </a:rPr>
+                      <m:t>𝑝𝑝𝑚</m:t>
+                    </m:r>
+                    <m:r>
+                      <a:rPr lang="en-US" sz="1000" b="0" i="0" baseline="0" dirty="0" smtClean="0">
+                        <a:latin typeface="Cambria Math" panose="02040503050406030204" pitchFamily="18" charset="0"/>
+                      </a:rPr>
+                      <m:t>0</m:t>
+                    </m:r>
+                    <m:r>
+                      <a:rPr lang="en-US" sz="1000" b="0" i="0" baseline="0" dirty="0" smtClean="0">
+                        <a:latin typeface="Cambria Math" panose="02040503050406030204" pitchFamily="18" charset="0"/>
+                      </a:rPr>
+                      <m:t>𝑙𝑡</m:t>
+                    </m:r>
+                    <m:r>
+                      <a:rPr lang="en-US" sz="1000" b="0" i="0" baseline="0" dirty="0" smtClean="0">
+                        <a:latin typeface="Cambria Math" panose="02040503050406030204" pitchFamily="18" charset="0"/>
+                      </a:rPr>
+                      <m:t>20</m:t>
+                    </m:r>
+                  </m:oMath>
+                </a14:m>
+                <a:r>
+                  <a:rPr sz="1000" b="0" i="0" baseline="0" dirty="0">
+                    <a:latin typeface="Calibri"/>
+                  </a:rPr>
+                  <a:t> panel.</a:t>
+                </a:r>
+              </a:p>
+              <a:p>
+                <a:pPr>
+                  <a:buChar char="•"/>
+                </a:pPr>
+                <a:r>
+                  <a:rPr sz="1000" b="0" i="0" baseline="0" dirty="0">
+                    <a:latin typeface="Calibri"/>
+                  </a:rPr>
+                  <a:t>  VECTOR lock: </a:t>
+                </a:r>
+                <a14:m>
+                  <m:oMath xmlns:m="http://schemas.openxmlformats.org/officeDocument/2006/math">
+                    <m:sSub>
+                      <m:sSubPr>
+                        <m:ctrlPr>
+                          <a:rPr lang="en-US" sz="1000" b="0" i="0" baseline="0" dirty="0">
+                            <a:latin typeface="Cambria Math" panose="02040503050406030204" pitchFamily="18" charset="0"/>
+                          </a:rPr>
+                        </m:ctrlPr>
+                      </m:sSubPr>
+                      <m:e>
+                        <m:r>
+                          <a:rPr lang="en-US" sz="1000" b="0" i="0" baseline="0" dirty="0">
+                            <a:latin typeface="Cambria Math" panose="02040503050406030204" pitchFamily="18" charset="0"/>
+                          </a:rPr>
+                          <m:t>𝐻</m:t>
+                        </m:r>
+                      </m:e>
+                      <m:sub>
+                        <m:r>
+                          <a:rPr lang="en-US" sz="1000" b="0" i="0" baseline="0" dirty="0">
+                            <a:latin typeface="Cambria Math" panose="02040503050406030204" pitchFamily="18" charset="0"/>
+                          </a:rPr>
+                          <m:t>𝑠𝑜𝑟𝑡</m:t>
+                        </m:r>
+                      </m:sub>
+                    </m:sSub>
+                  </m:oMath>
+                </a14:m>
+                <a:r>
+                  <a:rPr sz="1000" b="0" i="0" baseline="0" dirty="0">
+                    <a:latin typeface="Calibri"/>
+                  </a:rPr>
+                  <a:t> is realized sorting — not the generative homophily knob </a:t>
+                </a:r>
+                <a14:m>
+                  <m:oMath xmlns:m="http://schemas.openxmlformats.org/officeDocument/2006/math">
+                    <m:r>
+                      <a:rPr lang="en-US" sz="1000" b="0" i="0" baseline="0" dirty="0" smtClean="0">
+                        <a:latin typeface="Cambria Math" panose="02040503050406030204" pitchFamily="18" charset="0"/>
+                      </a:rPr>
+                      <m:t>𝜌</m:t>
+                    </m:r>
+                  </m:oMath>
+                </a14:m>
+                <a:r>
+                  <a:rPr sz="1000" b="0" i="0" baseline="0" dirty="0">
+                    <a:latin typeface="Calibri"/>
+                  </a:rPr>
+                  <a:t>.</a:t>
+                </a:r>
+              </a:p>
+              <a:p>
+                <a:pPr>
+                  <a:buChar char="•"/>
+                </a:pPr>
+                <a:r>
+                  <a:rPr sz="1000" b="0" i="0" baseline="0" dirty="0">
+                    <a:latin typeface="Calibri"/>
+                  </a:rPr>
+                  <a:t>  Figure: small multiples — blue sim curve, red empirical line, green </a:t>
+                </a:r>
+                <a14:m>
+                  <m:oMath xmlns:m="http://schemas.openxmlformats.org/officeDocument/2006/math">
+                    <m:sSup>
+                      <m:sSupPr>
+                        <m:ctrlPr>
+                          <a:rPr lang="en-US" sz="1000" b="0" i="0" baseline="0" dirty="0">
+                            <a:latin typeface="Cambria Math" panose="02040503050406030204" pitchFamily="18" charset="0"/>
+                          </a:rPr>
+                        </m:ctrlPr>
+                      </m:sSupPr>
+                      <m:e>
+                        <m:r>
+                          <a:rPr lang="en-US" sz="1000" b="0" i="0" baseline="0" dirty="0">
+                            <a:latin typeface="Cambria Math" panose="02040503050406030204" pitchFamily="18" charset="0"/>
+                          </a:rPr>
+                          <m:t>𝜌</m:t>
+                        </m:r>
+                      </m:e>
+                      <m:sup>
+                        <m:r>
+                          <a:rPr lang="en-US" sz="1000" b="0" i="0" baseline="0" dirty="0">
+                            <a:latin typeface="Cambria Math" panose="02040503050406030204" pitchFamily="18" charset="0"/>
+                          </a:rPr>
+                          <m:t>∗</m:t>
+                        </m:r>
+                      </m:sup>
+                    </m:sSup>
+                  </m:oMath>
+                </a14:m>
+                <a:r>
+                  <a:rPr sz="1000" b="0" i="0" baseline="0" dirty="0">
+                    <a:latin typeface="Calibri"/>
+                  </a:rPr>
+                  <a:t> (x-axis zoomed to evaluated bracket).</a:t>
                 </a:r>
               </a:p>
             </p:txBody>
@@ -4618,8 +5063,8 @@
             </p:nvSpPr>
             <p:spPr>
               <a:xfrm>
-                <a:off x="182880" y="1053120"/>
-                <a:ext cx="2886323" cy="5296470"/>
+                <a:off x="283932" y="1199867"/>
+                <a:ext cx="4147904" cy="4481291"/>
               </a:xfrm>
               <a:prstGeom prst="rect">
                 <a:avLst/>
@@ -4627,7 +5072,7 @@
               <a:blipFill>
                 <a:blip r:embed="rId5"/>
                 <a:stretch>
-                  <a:fillRect/>
+                  <a:fillRect t="-282"/>
                 </a:stretch>
               </a:blipFill>
             </p:spPr>
@@ -4656,8 +5101,8 @@
             </p:nvSpPr>
             <p:spPr>
               <a:xfrm>
-                <a:off x="384046" y="6349589"/>
-                <a:ext cx="11423599" cy="261610"/>
+                <a:off x="384048" y="6166786"/>
+                <a:ext cx="11423599" cy="430887"/>
               </a:xfrm>
               <a:prstGeom prst="rect">
                 <a:avLst/>
@@ -4675,15 +5120,40 @@
                   <a:rPr sz="1100" b="1" i="0" baseline="0" dirty="0">
                     <a:latin typeface="Calibri"/>
                   </a:rPr>
-                  <a:t>Claim (Alex): Near-zero ASSIGN homophily </a:t>
+                  <a:t>Claim (Alex): Hero panel — LG ASSIGN </a:t>
                 </a:r>
                 <a14:m>
                   <m:oMath xmlns:m="http://schemas.openxmlformats.org/officeDocument/2006/math">
+                    <m:sSup>
+                      <m:sSupPr>
+                        <m:ctrlPr>
+                          <a:rPr lang="en-US" sz="1100" b="1" i="0" baseline="0" dirty="0">
+                            <a:latin typeface="Cambria Math" panose="02040503050406030204" pitchFamily="18" charset="0"/>
+                          </a:rPr>
+                        </m:ctrlPr>
+                      </m:sSupPr>
+                      <m:e>
+                        <m:r>
+                          <a:rPr lang="en-US" sz="1100" b="1" i="0" baseline="0" dirty="0">
+                            <a:latin typeface="Cambria Math" panose="02040503050406030204" pitchFamily="18" charset="0"/>
+                          </a:rPr>
+                          <m:t>𝜌</m:t>
+                        </m:r>
+                      </m:e>
+                      <m:sup>
+                        <m:r>
+                          <a:rPr lang="en-US" sz="1100" b="1" i="0" baseline="0" dirty="0">
+                            <a:latin typeface="Cambria Math" panose="02040503050406030204" pitchFamily="18" charset="0"/>
+                          </a:rPr>
+                          <m:t>∗</m:t>
+                        </m:r>
+                      </m:sup>
+                    </m:sSup>
                     <m:r>
-                      <a:rPr lang="en-US" sz="1100" b="1" i="0" baseline="0" dirty="0" smtClean="0">
+                      <a:rPr lang="en-US" sz="1100" b="1" i="0" baseline="0" dirty="0">
                         <a:latin typeface="Cambria Math" panose="02040503050406030204" pitchFamily="18" charset="0"/>
                       </a:rPr>
-                      <m:t>𝜌</m:t>
+                      <m:t>=0</m:t>
                     </m:r>
                   </m:oMath>
                 </a14:m>
@@ -4691,7 +5161,7 @@
                   <a:rPr sz="1100" b="1" i="0" baseline="0" dirty="0">
                     <a:latin typeface="Calibri"/>
                   </a:rPr>
-                  <a:t> matches empirical </a:t>
+                  <a:t> matches modest empirical </a:t>
                 </a:r>
                 <a14:m>
                   <m:oMath xmlns:m="http://schemas.openxmlformats.org/officeDocument/2006/math">
@@ -4723,13 +5193,19 @@
                         </m:r>
                       </m:sub>
                     </m:sSub>
+                    <m:r>
+                      <a:rPr lang="en-US" sz="1100" b="1" i="0" baseline="0" dirty="0">
+                        <a:latin typeface="Cambria Math" panose="02040503050406030204" pitchFamily="18" charset="0"/>
+                      </a:rPr>
+                      <m:t>≈0.064</m:t>
+                    </m:r>
                   </m:oMath>
                 </a14:m>
                 <a:r>
                   <a:rPr sz="1100" b="1" i="0" baseline="0" dirty="0">
                     <a:latin typeface="Calibri"/>
                   </a:rPr>
-                  <a:t> on the hero panel — legacy </a:t>
+                  <a:t>; legacy </a:t>
                 </a:r>
                 <a14:m>
                   <m:oMath xmlns:m="http://schemas.openxmlformats.org/officeDocument/2006/math">
@@ -4751,7 +5227,7 @@
                   <a:rPr sz="1100" b="1" i="0" baseline="0" dirty="0">
                     <a:latin typeface="Calibri"/>
                   </a:rPr>
-                  <a:t> overshoots simulated sorting by </a:t>
+                  <a:t> overshoots (</a:t>
                 </a:r>
                 <a14:m>
                   <m:oMath xmlns:m="http://schemas.openxmlformats.org/officeDocument/2006/math">
@@ -4759,7 +5235,7 @@
                       <a:rPr lang="en-US" sz="1100" b="1" i="0" baseline="0" dirty="0" smtClean="0">
                         <a:latin typeface="Cambria Math" panose="02040503050406030204" pitchFamily="18" charset="0"/>
                       </a:rPr>
-                      <m:t>∼0.10</m:t>
+                      <m:t>0.11</m:t>
                     </m:r>
                   </m:oMath>
                 </a14:m>
@@ -4767,7 +5243,36 @@
                   <a:rPr sz="1100" b="1" i="0" baseline="0" dirty="0">
                     <a:latin typeface="Calibri"/>
                   </a:rPr>
-                  <a:t>.</a:t>
+                  <a:t> mean </a:t>
+                </a:r>
+                <a14:m>
+                  <m:oMath xmlns:m="http://schemas.openxmlformats.org/officeDocument/2006/math">
+                    <m:d>
+                      <m:dPr>
+                        <m:begChr m:val="|"/>
+                        <m:endChr m:val="|"/>
+                        <m:ctrlPr>
+                          <a:rPr lang="en-US" sz="1100" b="1" i="0" baseline="0" dirty="0">
+                            <a:latin typeface="Cambria Math" panose="02040503050406030204" pitchFamily="18" charset="0"/>
+                          </a:rPr>
+                        </m:ctrlPr>
+                      </m:dPr>
+                      <m:e>
+                        <m:r>
+                          <a:rPr lang="en-US" sz="1100" b="1" i="0" baseline="0" dirty="0">
+                            <a:latin typeface="Cambria Math" panose="02040503050406030204" pitchFamily="18" charset="0"/>
+                          </a:rPr>
+                          <m:t>𝑒𝑟𝑟𝑜𝑟</m:t>
+                        </m:r>
+                      </m:e>
+                    </m:d>
+                  </m:oMath>
+                </a14:m>
+                <a:r>
+                  <a:rPr sz="1100" b="1" i="0" baseline="0" dirty="0">
+                    <a:latin typeface="Calibri"/>
+                  </a:rPr>
+                  <a:t>). Model–measurement fit on this panel — not a claim that NCAA rosters are random.</a:t>
                 </a:r>
               </a:p>
             </p:txBody>
@@ -4784,8 +5289,8 @@
             </p:nvSpPr>
             <p:spPr>
               <a:xfrm>
-                <a:off x="384046" y="6349589"/>
-                <a:ext cx="11423599" cy="261610"/>
+                <a:off x="384048" y="6166786"/>
+                <a:ext cx="11423599" cy="430887"/>
               </a:xfrm>
               <a:prstGeom prst="rect">
                 <a:avLst/>
@@ -4793,7 +5298,7 @@
               <a:blipFill>
                 <a:blip r:embed="rId6"/>
                 <a:stretch>
-                  <a:fillRect b="-14286"/>
+                  <a:fillRect b="-5714"/>
                 </a:stretch>
               </a:blipFill>
             </p:spPr>

</xml_diff>

<commit_message>
Add new analyses and outputs for PD22 interval overlap for seasons 2012 and 2013
- Introduced CSV, JSON, and PNG files for the interval overlap analysis of seasons 2012 and 2013, enhancing the dataset for performance evaluation.
- Updated the markdown documentation to reflect the new analyses and findings, ensuring clarity on the methodologies used.
- Enhanced the existing panel investigation documentation with results from the new analyses, supporting ongoing evaluations of player performance dynamics.

These additions strengthen the analytical framework for the PD22 project, providing valuable insights into player performance and selection dynamics across multiple seasons.
</commit_message>
<xml_diff>
--- a/3-Master_Plan/re_entry/HEROs_and_PASSes/slides/auto/CHAR_PD21_rho_hsort_calibrate_AUTO.pptx
+++ b/3-Master_Plan/re_entry/HEROs_and_PASSes/slides/auto/CHAR_PD21_rho_hsort_calibrate_AUTO.pptx
@@ -5,9 +5,9 @@
     <p:sldMasterId id="2147483648" r:id="rId1"/>
   </p:sldMasterIdLst>
   <p:sldIdLst>
-    <p:sldId id="256" r:id="rId2"/>
+    <p:sldId id="256" r:id="rId7"/>
   </p:sldIdLst>
-  <p:sldSz cx="12192000" cy="6858000"/>
+  <p:sldSz cx="12191695" cy="6858000" type="screen4x3"/>
   <p:notesSz cx="6858000" cy="9144000"/>
   <p:defaultTextStyle>
     <a:defPPr>
@@ -104,22 +104,6 @@
       </a:defRPr>
     </a:lvl9pPr>
   </p:defaultTextStyle>
-  <p:extLst>
-    <p:ext uri="{EFAFB233-063F-42B5-8137-9DF3F51BA10A}">
-      <p15:sldGuideLst xmlns:p15="http://schemas.microsoft.com/office/powerpoint/2012/main">
-        <p15:guide id="1" orient="horz" pos="2160">
-          <p15:clr>
-            <a:srgbClr val="A4A3A4"/>
-          </p15:clr>
-        </p15:guide>
-        <p15:guide id="2" pos="2880">
-          <p15:clr>
-            <a:srgbClr val="A4A3A4"/>
-          </p15:clr>
-        </p15:guide>
-      </p15:sldGuideLst>
-    </p:ext>
-  </p:extLst>
 </p:presentation>
 </file>
 
@@ -161,9 +145,10 @@
           <a:lstStyle/>
           <a:p>
             <a:r>
-              <a:rPr lang="en-US"/>
+              <a:rPr lang="en-US" smtClean="0"/>
               <a:t>Click to edit Master title style</a:t>
             </a:r>
+            <a:endParaRPr lang="en-US"/>
           </a:p>
         </p:txBody>
       </p:sp>
@@ -279,9 +264,10 @@
           </a:lstStyle>
           <a:p>
             <a:r>
-              <a:rPr lang="en-US"/>
+              <a:rPr lang="en-US" smtClean="0"/>
               <a:t>Click to edit Master subtitle style</a:t>
             </a:r>
+            <a:endParaRPr lang="en-US"/>
           </a:p>
         </p:txBody>
       </p:sp>
@@ -302,7 +288,7 @@
           <a:p>
             <a:fld id="{5BCAD085-E8A6-8845-BD4E-CB4CCA059FC4}" type="datetimeFigureOut">
               <a:rPr lang="en-US" smtClean="0"/>
-              <a:t>8/17/26</a:t>
+              <a:t>1/27/13</a:t>
             </a:fld>
             <a:endParaRPr lang="en-US"/>
           </a:p>
@@ -396,9 +382,10 @@
           <a:lstStyle/>
           <a:p>
             <a:r>
-              <a:rPr lang="en-US"/>
+              <a:rPr lang="en-US" smtClean="0"/>
               <a:t>Click to edit Master title style</a:t>
             </a:r>
+            <a:endParaRPr lang="en-US"/>
           </a:p>
         </p:txBody>
       </p:sp>
@@ -419,37 +406,38 @@
           <a:p>
             <a:pPr lvl="0"/>
             <a:r>
-              <a:rPr lang="en-US"/>
+              <a:rPr lang="en-US" smtClean="0"/>
               <a:t>Click to edit Master text styles</a:t>
             </a:r>
           </a:p>
           <a:p>
             <a:pPr lvl="1"/>
             <a:r>
-              <a:rPr lang="en-US"/>
+              <a:rPr lang="en-US" smtClean="0"/>
               <a:t>Second level</a:t>
             </a:r>
           </a:p>
           <a:p>
             <a:pPr lvl="2"/>
             <a:r>
-              <a:rPr lang="en-US"/>
+              <a:rPr lang="en-US" smtClean="0"/>
               <a:t>Third level</a:t>
             </a:r>
           </a:p>
           <a:p>
             <a:pPr lvl="3"/>
             <a:r>
-              <a:rPr lang="en-US"/>
+              <a:rPr lang="en-US" smtClean="0"/>
               <a:t>Fourth level</a:t>
             </a:r>
           </a:p>
           <a:p>
             <a:pPr lvl="4"/>
             <a:r>
-              <a:rPr lang="en-US"/>
+              <a:rPr lang="en-US" smtClean="0"/>
               <a:t>Fifth level</a:t>
             </a:r>
+            <a:endParaRPr lang="en-US"/>
           </a:p>
         </p:txBody>
       </p:sp>
@@ -470,7 +458,7 @@
           <a:p>
             <a:fld id="{5BCAD085-E8A6-8845-BD4E-CB4CCA059FC4}" type="datetimeFigureOut">
               <a:rPr lang="en-US" smtClean="0"/>
-              <a:t>8/17/26</a:t>
+              <a:t>1/27/13</a:t>
             </a:fld>
             <a:endParaRPr lang="en-US"/>
           </a:p>
@@ -569,9 +557,10 @@
           <a:lstStyle/>
           <a:p>
             <a:r>
-              <a:rPr lang="en-US"/>
+              <a:rPr lang="en-US" smtClean="0"/>
               <a:t>Click to edit Master title style</a:t>
             </a:r>
+            <a:endParaRPr lang="en-US"/>
           </a:p>
         </p:txBody>
       </p:sp>
@@ -597,37 +586,38 @@
           <a:p>
             <a:pPr lvl="0"/>
             <a:r>
-              <a:rPr lang="en-US"/>
+              <a:rPr lang="en-US" smtClean="0"/>
               <a:t>Click to edit Master text styles</a:t>
             </a:r>
           </a:p>
           <a:p>
             <a:pPr lvl="1"/>
             <a:r>
-              <a:rPr lang="en-US"/>
+              <a:rPr lang="en-US" smtClean="0"/>
               <a:t>Second level</a:t>
             </a:r>
           </a:p>
           <a:p>
             <a:pPr lvl="2"/>
             <a:r>
-              <a:rPr lang="en-US"/>
+              <a:rPr lang="en-US" smtClean="0"/>
               <a:t>Third level</a:t>
             </a:r>
           </a:p>
           <a:p>
             <a:pPr lvl="3"/>
             <a:r>
-              <a:rPr lang="en-US"/>
+              <a:rPr lang="en-US" smtClean="0"/>
               <a:t>Fourth level</a:t>
             </a:r>
           </a:p>
           <a:p>
             <a:pPr lvl="4"/>
             <a:r>
-              <a:rPr lang="en-US"/>
+              <a:rPr lang="en-US" smtClean="0"/>
               <a:t>Fifth level</a:t>
             </a:r>
+            <a:endParaRPr lang="en-US"/>
           </a:p>
         </p:txBody>
       </p:sp>
@@ -648,7 +638,7 @@
           <a:p>
             <a:fld id="{5BCAD085-E8A6-8845-BD4E-CB4CCA059FC4}" type="datetimeFigureOut">
               <a:rPr lang="en-US" smtClean="0"/>
-              <a:t>8/17/26</a:t>
+              <a:t>1/27/13</a:t>
             </a:fld>
             <a:endParaRPr lang="en-US"/>
           </a:p>
@@ -742,9 +732,10 @@
           <a:lstStyle/>
           <a:p>
             <a:r>
-              <a:rPr lang="en-US"/>
+              <a:rPr lang="en-US" smtClean="0"/>
               <a:t>Click to edit Master title style</a:t>
             </a:r>
+            <a:endParaRPr lang="en-US"/>
           </a:p>
         </p:txBody>
       </p:sp>
@@ -765,37 +756,38 @@
           <a:p>
             <a:pPr lvl="0"/>
             <a:r>
-              <a:rPr lang="en-US"/>
+              <a:rPr lang="en-US" smtClean="0"/>
               <a:t>Click to edit Master text styles</a:t>
             </a:r>
           </a:p>
           <a:p>
             <a:pPr lvl="1"/>
             <a:r>
-              <a:rPr lang="en-US"/>
+              <a:rPr lang="en-US" smtClean="0"/>
               <a:t>Second level</a:t>
             </a:r>
           </a:p>
           <a:p>
             <a:pPr lvl="2"/>
             <a:r>
-              <a:rPr lang="en-US"/>
+              <a:rPr lang="en-US" smtClean="0"/>
               <a:t>Third level</a:t>
             </a:r>
           </a:p>
           <a:p>
             <a:pPr lvl="3"/>
             <a:r>
-              <a:rPr lang="en-US"/>
+              <a:rPr lang="en-US" smtClean="0"/>
               <a:t>Fourth level</a:t>
             </a:r>
           </a:p>
           <a:p>
             <a:pPr lvl="4"/>
             <a:r>
-              <a:rPr lang="en-US"/>
+              <a:rPr lang="en-US" smtClean="0"/>
               <a:t>Fifth level</a:t>
             </a:r>
+            <a:endParaRPr lang="en-US"/>
           </a:p>
         </p:txBody>
       </p:sp>
@@ -816,7 +808,7 @@
           <a:p>
             <a:fld id="{5BCAD085-E8A6-8845-BD4E-CB4CCA059FC4}" type="datetimeFigureOut">
               <a:rPr lang="en-US" smtClean="0"/>
-              <a:t>8/17/26</a:t>
+              <a:t>1/27/13</a:t>
             </a:fld>
             <a:endParaRPr lang="en-US"/>
           </a:p>
@@ -919,9 +911,10 @@
           </a:lstStyle>
           <a:p>
             <a:r>
-              <a:rPr lang="en-US"/>
+              <a:rPr lang="en-US" smtClean="0"/>
               <a:t>Click to edit Master title style</a:t>
             </a:r>
+            <a:endParaRPr lang="en-US"/>
           </a:p>
         </p:txBody>
       </p:sp>
@@ -1038,7 +1031,7 @@
           <a:p>
             <a:pPr lvl="0"/>
             <a:r>
-              <a:rPr lang="en-US"/>
+              <a:rPr lang="en-US" smtClean="0"/>
               <a:t>Click to edit Master text styles</a:t>
             </a:r>
           </a:p>
@@ -1061,7 +1054,7 @@
           <a:p>
             <a:fld id="{5BCAD085-E8A6-8845-BD4E-CB4CCA059FC4}" type="datetimeFigureOut">
               <a:rPr lang="en-US" smtClean="0"/>
-              <a:t>8/17/26</a:t>
+              <a:t>1/27/13</a:t>
             </a:fld>
             <a:endParaRPr lang="en-US"/>
           </a:p>
@@ -1155,9 +1148,10 @@
           <a:lstStyle/>
           <a:p>
             <a:r>
-              <a:rPr lang="en-US"/>
+              <a:rPr lang="en-US" smtClean="0"/>
               <a:t>Click to edit Master title style</a:t>
             </a:r>
+            <a:endParaRPr lang="en-US"/>
           </a:p>
         </p:txBody>
       </p:sp>
@@ -1211,37 +1205,38 @@
           <a:p>
             <a:pPr lvl="0"/>
             <a:r>
-              <a:rPr lang="en-US"/>
+              <a:rPr lang="en-US" smtClean="0"/>
               <a:t>Click to edit Master text styles</a:t>
             </a:r>
           </a:p>
           <a:p>
             <a:pPr lvl="1"/>
             <a:r>
-              <a:rPr lang="en-US"/>
+              <a:rPr lang="en-US" smtClean="0"/>
               <a:t>Second level</a:t>
             </a:r>
           </a:p>
           <a:p>
             <a:pPr lvl="2"/>
             <a:r>
-              <a:rPr lang="en-US"/>
+              <a:rPr lang="en-US" smtClean="0"/>
               <a:t>Third level</a:t>
             </a:r>
           </a:p>
           <a:p>
             <a:pPr lvl="3"/>
             <a:r>
-              <a:rPr lang="en-US"/>
+              <a:rPr lang="en-US" smtClean="0"/>
               <a:t>Fourth level</a:t>
             </a:r>
           </a:p>
           <a:p>
             <a:pPr lvl="4"/>
             <a:r>
-              <a:rPr lang="en-US"/>
+              <a:rPr lang="en-US" smtClean="0"/>
               <a:t>Fifth level</a:t>
             </a:r>
+            <a:endParaRPr lang="en-US"/>
           </a:p>
         </p:txBody>
       </p:sp>
@@ -1295,37 +1290,38 @@
           <a:p>
             <a:pPr lvl="0"/>
             <a:r>
-              <a:rPr lang="en-US"/>
+              <a:rPr lang="en-US" smtClean="0"/>
               <a:t>Click to edit Master text styles</a:t>
             </a:r>
           </a:p>
           <a:p>
             <a:pPr lvl="1"/>
             <a:r>
-              <a:rPr lang="en-US"/>
+              <a:rPr lang="en-US" smtClean="0"/>
               <a:t>Second level</a:t>
             </a:r>
           </a:p>
           <a:p>
             <a:pPr lvl="2"/>
             <a:r>
-              <a:rPr lang="en-US"/>
+              <a:rPr lang="en-US" smtClean="0"/>
               <a:t>Third level</a:t>
             </a:r>
           </a:p>
           <a:p>
             <a:pPr lvl="3"/>
             <a:r>
-              <a:rPr lang="en-US"/>
+              <a:rPr lang="en-US" smtClean="0"/>
               <a:t>Fourth level</a:t>
             </a:r>
           </a:p>
           <a:p>
             <a:pPr lvl="4"/>
             <a:r>
-              <a:rPr lang="en-US"/>
+              <a:rPr lang="en-US" smtClean="0"/>
               <a:t>Fifth level</a:t>
             </a:r>
+            <a:endParaRPr lang="en-US"/>
           </a:p>
         </p:txBody>
       </p:sp>
@@ -1346,7 +1342,7 @@
           <a:p>
             <a:fld id="{5BCAD085-E8A6-8845-BD4E-CB4CCA059FC4}" type="datetimeFigureOut">
               <a:rPr lang="en-US" smtClean="0"/>
-              <a:t>8/17/26</a:t>
+              <a:t>1/27/13</a:t>
             </a:fld>
             <a:endParaRPr lang="en-US"/>
           </a:p>
@@ -1444,9 +1440,10 @@
           </a:lstStyle>
           <a:p>
             <a:r>
-              <a:rPr lang="en-US"/>
+              <a:rPr lang="en-US" smtClean="0"/>
               <a:t>Click to edit Master title style</a:t>
             </a:r>
+            <a:endParaRPr lang="en-US"/>
           </a:p>
         </p:txBody>
       </p:sp>
@@ -1509,7 +1506,7 @@
           <a:p>
             <a:pPr lvl="0"/>
             <a:r>
-              <a:rPr lang="en-US"/>
+              <a:rPr lang="en-US" smtClean="0"/>
               <a:t>Click to edit Master text styles</a:t>
             </a:r>
           </a:p>
@@ -1565,37 +1562,38 @@
           <a:p>
             <a:pPr lvl="0"/>
             <a:r>
-              <a:rPr lang="en-US"/>
+              <a:rPr lang="en-US" smtClean="0"/>
               <a:t>Click to edit Master text styles</a:t>
             </a:r>
           </a:p>
           <a:p>
             <a:pPr lvl="1"/>
             <a:r>
-              <a:rPr lang="en-US"/>
+              <a:rPr lang="en-US" smtClean="0"/>
               <a:t>Second level</a:t>
             </a:r>
           </a:p>
           <a:p>
             <a:pPr lvl="2"/>
             <a:r>
-              <a:rPr lang="en-US"/>
+              <a:rPr lang="en-US" smtClean="0"/>
               <a:t>Third level</a:t>
             </a:r>
           </a:p>
           <a:p>
             <a:pPr lvl="3"/>
             <a:r>
-              <a:rPr lang="en-US"/>
+              <a:rPr lang="en-US" smtClean="0"/>
               <a:t>Fourth level</a:t>
             </a:r>
           </a:p>
           <a:p>
             <a:pPr lvl="4"/>
             <a:r>
-              <a:rPr lang="en-US"/>
+              <a:rPr lang="en-US" smtClean="0"/>
               <a:t>Fifth level</a:t>
             </a:r>
+            <a:endParaRPr lang="en-US"/>
           </a:p>
         </p:txBody>
       </p:sp>
@@ -1658,7 +1656,7 @@
           <a:p>
             <a:pPr lvl="0"/>
             <a:r>
-              <a:rPr lang="en-US"/>
+              <a:rPr lang="en-US" smtClean="0"/>
               <a:t>Click to edit Master text styles</a:t>
             </a:r>
           </a:p>
@@ -1714,37 +1712,38 @@
           <a:p>
             <a:pPr lvl="0"/>
             <a:r>
-              <a:rPr lang="en-US"/>
+              <a:rPr lang="en-US" smtClean="0"/>
               <a:t>Click to edit Master text styles</a:t>
             </a:r>
           </a:p>
           <a:p>
             <a:pPr lvl="1"/>
             <a:r>
-              <a:rPr lang="en-US"/>
+              <a:rPr lang="en-US" smtClean="0"/>
               <a:t>Second level</a:t>
             </a:r>
           </a:p>
           <a:p>
             <a:pPr lvl="2"/>
             <a:r>
-              <a:rPr lang="en-US"/>
+              <a:rPr lang="en-US" smtClean="0"/>
               <a:t>Third level</a:t>
             </a:r>
           </a:p>
           <a:p>
             <a:pPr lvl="3"/>
             <a:r>
-              <a:rPr lang="en-US"/>
+              <a:rPr lang="en-US" smtClean="0"/>
               <a:t>Fourth level</a:t>
             </a:r>
           </a:p>
           <a:p>
             <a:pPr lvl="4"/>
             <a:r>
-              <a:rPr lang="en-US"/>
+              <a:rPr lang="en-US" smtClean="0"/>
               <a:t>Fifth level</a:t>
             </a:r>
+            <a:endParaRPr lang="en-US"/>
           </a:p>
         </p:txBody>
       </p:sp>
@@ -1765,7 +1764,7 @@
           <a:p>
             <a:fld id="{5BCAD085-E8A6-8845-BD4E-CB4CCA059FC4}" type="datetimeFigureOut">
               <a:rPr lang="en-US" smtClean="0"/>
-              <a:t>8/17/26</a:t>
+              <a:t>1/27/13</a:t>
             </a:fld>
             <a:endParaRPr lang="en-US"/>
           </a:p>
@@ -1859,9 +1858,10 @@
           <a:lstStyle/>
           <a:p>
             <a:r>
-              <a:rPr lang="en-US"/>
+              <a:rPr lang="en-US" smtClean="0"/>
               <a:t>Click to edit Master title style</a:t>
             </a:r>
+            <a:endParaRPr lang="en-US"/>
           </a:p>
         </p:txBody>
       </p:sp>
@@ -1882,7 +1882,7 @@
           <a:p>
             <a:fld id="{5BCAD085-E8A6-8845-BD4E-CB4CCA059FC4}" type="datetimeFigureOut">
               <a:rPr lang="en-US" smtClean="0"/>
-              <a:t>8/17/26</a:t>
+              <a:t>1/27/13</a:t>
             </a:fld>
             <a:endParaRPr lang="en-US"/>
           </a:p>
@@ -1977,7 +1977,7 @@
           <a:p>
             <a:fld id="{5BCAD085-E8A6-8845-BD4E-CB4CCA059FC4}" type="datetimeFigureOut">
               <a:rPr lang="en-US" smtClean="0"/>
-              <a:t>8/17/26</a:t>
+              <a:t>1/27/13</a:t>
             </a:fld>
             <a:endParaRPr lang="en-US"/>
           </a:p>
@@ -2080,9 +2080,10 @@
           </a:lstStyle>
           <a:p>
             <a:r>
-              <a:rPr lang="en-US"/>
+              <a:rPr lang="en-US" smtClean="0"/>
               <a:t>Click to edit Master title style</a:t>
             </a:r>
+            <a:endParaRPr lang="en-US"/>
           </a:p>
         </p:txBody>
       </p:sp>
@@ -2136,37 +2137,38 @@
           <a:p>
             <a:pPr lvl="0"/>
             <a:r>
-              <a:rPr lang="en-US"/>
+              <a:rPr lang="en-US" smtClean="0"/>
               <a:t>Click to edit Master text styles</a:t>
             </a:r>
           </a:p>
           <a:p>
             <a:pPr lvl="1"/>
             <a:r>
-              <a:rPr lang="en-US"/>
+              <a:rPr lang="en-US" smtClean="0"/>
               <a:t>Second level</a:t>
             </a:r>
           </a:p>
           <a:p>
             <a:pPr lvl="2"/>
             <a:r>
-              <a:rPr lang="en-US"/>
+              <a:rPr lang="en-US" smtClean="0"/>
               <a:t>Third level</a:t>
             </a:r>
           </a:p>
           <a:p>
             <a:pPr lvl="3"/>
             <a:r>
-              <a:rPr lang="en-US"/>
+              <a:rPr lang="en-US" smtClean="0"/>
               <a:t>Fourth level</a:t>
             </a:r>
           </a:p>
           <a:p>
             <a:pPr lvl="4"/>
             <a:r>
-              <a:rPr lang="en-US"/>
+              <a:rPr lang="en-US" smtClean="0"/>
               <a:t>Fifth level</a:t>
             </a:r>
+            <a:endParaRPr lang="en-US"/>
           </a:p>
         </p:txBody>
       </p:sp>
@@ -2229,7 +2231,7 @@
           <a:p>
             <a:pPr lvl="0"/>
             <a:r>
-              <a:rPr lang="en-US"/>
+              <a:rPr lang="en-US" smtClean="0"/>
               <a:t>Click to edit Master text styles</a:t>
             </a:r>
           </a:p>
@@ -2252,7 +2254,7 @@
           <a:p>
             <a:fld id="{5BCAD085-E8A6-8845-BD4E-CB4CCA059FC4}" type="datetimeFigureOut">
               <a:rPr lang="en-US" smtClean="0"/>
-              <a:t>8/17/26</a:t>
+              <a:t>1/27/13</a:t>
             </a:fld>
             <a:endParaRPr lang="en-US"/>
           </a:p>
@@ -2355,9 +2357,10 @@
           </a:lstStyle>
           <a:p>
             <a:r>
-              <a:rPr lang="en-US"/>
+              <a:rPr lang="en-US" smtClean="0"/>
               <a:t>Click to edit Master title style</a:t>
             </a:r>
+            <a:endParaRPr lang="en-US"/>
           </a:p>
         </p:txBody>
       </p:sp>
@@ -2481,7 +2484,7 @@
           <a:p>
             <a:pPr lvl="0"/>
             <a:r>
-              <a:rPr lang="en-US"/>
+              <a:rPr lang="en-US" smtClean="0"/>
               <a:t>Click to edit Master text styles</a:t>
             </a:r>
           </a:p>
@@ -2504,7 +2507,7 @@
           <a:p>
             <a:fld id="{5BCAD085-E8A6-8845-BD4E-CB4CCA059FC4}" type="datetimeFigureOut">
               <a:rPr lang="en-US" smtClean="0"/>
-              <a:t>8/17/26</a:t>
+              <a:t>1/27/13</a:t>
             </a:fld>
             <a:endParaRPr lang="en-US"/>
           </a:p>
@@ -2613,9 +2616,10 @@
           <a:lstStyle/>
           <a:p>
             <a:r>
-              <a:rPr lang="en-US"/>
+              <a:rPr lang="en-US" smtClean="0"/>
               <a:t>Click to edit Master title style</a:t>
             </a:r>
+            <a:endParaRPr lang="en-US"/>
           </a:p>
         </p:txBody>
       </p:sp>
@@ -2646,37 +2650,38 @@
           <a:p>
             <a:pPr lvl="0"/>
             <a:r>
-              <a:rPr lang="en-US"/>
+              <a:rPr lang="en-US" smtClean="0"/>
               <a:t>Click to edit Master text styles</a:t>
             </a:r>
           </a:p>
           <a:p>
             <a:pPr lvl="1"/>
             <a:r>
-              <a:rPr lang="en-US"/>
+              <a:rPr lang="en-US" smtClean="0"/>
               <a:t>Second level</a:t>
             </a:r>
           </a:p>
           <a:p>
             <a:pPr lvl="2"/>
             <a:r>
-              <a:rPr lang="en-US"/>
+              <a:rPr lang="en-US" smtClean="0"/>
               <a:t>Third level</a:t>
             </a:r>
           </a:p>
           <a:p>
             <a:pPr lvl="3"/>
             <a:r>
-              <a:rPr lang="en-US"/>
+              <a:rPr lang="en-US" smtClean="0"/>
               <a:t>Fourth level</a:t>
             </a:r>
           </a:p>
           <a:p>
             <a:pPr lvl="4"/>
             <a:r>
-              <a:rPr lang="en-US"/>
+              <a:rPr lang="en-US" smtClean="0"/>
               <a:t>Fifth level</a:t>
             </a:r>
+            <a:endParaRPr lang="en-US"/>
           </a:p>
         </p:txBody>
       </p:sp>
@@ -2715,7 +2720,7 @@
           <a:p>
             <a:fld id="{5BCAD085-E8A6-8845-BD4E-CB4CCA059FC4}" type="datetimeFigureOut">
               <a:rPr lang="en-US" smtClean="0"/>
-              <a:t>8/17/26</a:t>
+              <a:t>1/27/13</a:t>
             </a:fld>
             <a:endParaRPr lang="en-US"/>
           </a:p>
@@ -3074,7 +3079,7 @@
 </file>
 
 <file path=ppt/slides/slide1.xml><?xml version="1.0" encoding="utf-8"?>
-<p:sld xmlns:a="http://schemas.openxmlformats.org/drawingml/2006/main" xmlns:r="http://schemas.openxmlformats.org/officeDocument/2006/relationships" xmlns:p="http://schemas.openxmlformats.org/presentationml/2006/main">
+<p:sld xmlns:a="http://schemas.openxmlformats.org/drawingml/2006/main" xmlns:p="http://schemas.openxmlformats.org/presentationml/2006/main" xmlns:r="http://schemas.openxmlformats.org/officeDocument/2006/relationships">
   <p:cSld>
     <p:spTree>
       <p:nvGrpSpPr>
@@ -3082,293 +3087,69 @@
         <p:cNvGrpSpPr/>
         <p:nvPr/>
       </p:nvGrpSpPr>
-      <p:grpSpPr>
-        <a:xfrm>
-          <a:off x="0" y="0"/>
-          <a:ext cx="0" cy="0"/>
-          <a:chOff x="0" y="0"/>
-          <a:chExt cx="0" cy="0"/>
-        </a:xfrm>
-      </p:grpSpPr>
-      <mc:AlternateContent xmlns:mc="http://schemas.openxmlformats.org/markup-compatibility/2006">
-        <mc:Choice xmlns:a14="http://schemas.microsoft.com/office/drawing/2010/main" Requires="a14">
-          <p:sp>
-            <p:nvSpPr>
-              <p:cNvPr id="2" name="TextBox 1"/>
-              <p:cNvSpPr txBox="1"/>
-              <p:nvPr/>
-            </p:nvSpPr>
-            <p:spPr>
-              <a:xfrm>
-                <a:off x="384048" y="219456"/>
-                <a:ext cx="10413492" cy="400110"/>
-              </a:xfrm>
-              <a:prstGeom prst="rect">
-                <a:avLst/>
-              </a:prstGeom>
-              <a:noFill/>
-            </p:spPr>
-            <p:txBody>
-              <a:bodyPr wrap="none">
-                <a:spAutoFit/>
-              </a:bodyPr>
-              <a:lstStyle/>
-              <a:p>
-                <a:r>
-                  <a:rPr sz="2000" b="1" i="0" baseline="0" dirty="0">
-                    <a:latin typeface="Calibri"/>
-                  </a:rPr>
-                  <a:t>PD21 — Calibrate homophily </a:t>
-                </a:r>
-                <a14:m>
-                  <m:oMath xmlns:m="http://schemas.openxmlformats.org/officeDocument/2006/math">
-                    <m:r>
-                      <a:rPr lang="en-US" sz="2000" b="1" i="0" baseline="0" dirty="0" smtClean="0">
-                        <a:latin typeface="Cambria Math" panose="02040503050406030204" pitchFamily="18" charset="0"/>
-                      </a:rPr>
-                      <m:t>𝜌</m:t>
-                    </m:r>
-                  </m:oMath>
-                </a14:m>
-                <a:r>
-                  <a:rPr sz="2000" b="1" i="0" baseline="0" dirty="0">
-                    <a:latin typeface="Calibri"/>
-                  </a:rPr>
-                  <a:t> to empirical sorting index </a:t>
-                </a:r>
-                <a14:m>
-                  <m:oMath xmlns:m="http://schemas.openxmlformats.org/officeDocument/2006/math">
-                    <m:sSub>
-                      <m:sSubPr>
-                        <m:ctrlPr>
-                          <a:rPr lang="en-US" sz="2000" b="1" i="0" baseline="0" dirty="0">
-                            <a:latin typeface="Cambria Math" panose="02040503050406030204" pitchFamily="18" charset="0"/>
-                          </a:rPr>
-                        </m:ctrlPr>
-                      </m:sSubPr>
-                      <m:e>
-                        <m:r>
-                          <a:rPr lang="en-US" sz="2000" b="1" i="0" baseline="0" dirty="0">
-                            <a:latin typeface="Cambria Math" panose="02040503050406030204" pitchFamily="18" charset="0"/>
-                          </a:rPr>
-                          <m:t>𝐻</m:t>
-                        </m:r>
-                      </m:e>
-                      <m:sub>
-                        <m:r>
-                          <m:rPr>
-                            <m:sty m:val="p"/>
-                          </m:rPr>
-                          <a:rPr lang="en-US" sz="2000" b="1" i="0" baseline="0" dirty="0">
-                            <a:latin typeface="Cambria Math" panose="02040503050406030204" pitchFamily="18" charset="0"/>
-                          </a:rPr>
-                          <m:t>sort</m:t>
-                        </m:r>
-                      </m:sub>
-                    </m:sSub>
-                  </m:oMath>
-                </a14:m>
-                <a:r>
-                  <a:rPr sz="2000" b="1" i="0" baseline="0" dirty="0">
-                    <a:latin typeface="Calibri"/>
-                  </a:rPr>
-                  <a:t> (hero panel — locked calibration)</a:t>
-                </a:r>
-              </a:p>
-            </p:txBody>
-          </p:sp>
-        </mc:Choice>
-        <mc:Fallback>
-          <p:sp>
-            <p:nvSpPr>
-              <p:cNvPr id="2" name="TextBox 1"/>
-              <p:cNvSpPr txBox="1">
-                <a:spLocks noRot="1" noChangeAspect="1" noMove="1" noResize="1" noEditPoints="1" noAdjustHandles="1" noChangeArrowheads="1" noChangeShapeType="1" noTextEdit="1"/>
-              </p:cNvSpPr>
-              <p:nvPr/>
-            </p:nvSpPr>
-            <p:spPr>
-              <a:xfrm>
-                <a:off x="384048" y="219456"/>
-                <a:ext cx="10413492" cy="400110"/>
-              </a:xfrm>
-              <a:prstGeom prst="rect">
-                <a:avLst/>
-              </a:prstGeom>
-              <a:blipFill>
-                <a:blip r:embed="rId2"/>
-                <a:stretch>
-                  <a:fillRect l="-609" t="-9375" b="-28125"/>
-                </a:stretch>
-              </a:blipFill>
-            </p:spPr>
-            <p:txBody>
-              <a:bodyPr/>
-              <a:lstStyle/>
-              <a:p>
-                <a:r>
-                  <a:rPr lang="en-US">
-                    <a:noFill/>
-                  </a:rPr>
-                  <a:t> </a:t>
-                </a:r>
-              </a:p>
-            </p:txBody>
-          </p:sp>
-        </mc:Fallback>
-      </mc:AlternateContent>
-      <mc:AlternateContent xmlns:mc="http://schemas.openxmlformats.org/markup-compatibility/2006">
-        <mc:Choice xmlns:a14="http://schemas.microsoft.com/office/drawing/2010/main" Requires="a14">
-          <p:sp>
-            <p:nvSpPr>
-              <p:cNvPr id="3" name="TextBox 2"/>
-              <p:cNvSpPr txBox="1"/>
-              <p:nvPr/>
-            </p:nvSpPr>
-            <p:spPr>
-              <a:xfrm>
-                <a:off x="384048" y="713232"/>
-                <a:ext cx="5721118" cy="246221"/>
-              </a:xfrm>
-              <a:prstGeom prst="rect">
-                <a:avLst/>
-              </a:prstGeom>
-              <a:noFill/>
-            </p:spPr>
-            <p:txBody>
-              <a:bodyPr wrap="none">
-                <a:spAutoFit/>
-              </a:bodyPr>
-              <a:lstStyle/>
-              <a:p>
-                <a:r>
-                  <a:rPr sz="1000" b="0" i="0" baseline="0" dirty="0">
-                    <a:latin typeface="Calibri"/>
-                  </a:rPr>
-                  <a:t>PD21 · LG ASSIGN calibration · 2011-2021 · </a:t>
-                </a:r>
-                <a14:m>
-                  <m:oMath xmlns:m="http://schemas.openxmlformats.org/officeDocument/2006/math">
-                    <m:r>
-                      <a:rPr lang="en-US" sz="1000" b="0" i="0" baseline="0" dirty="0" smtClean="0">
-                        <a:latin typeface="Cambria Math" panose="02040503050406030204" pitchFamily="18" charset="0"/>
-                      </a:rPr>
-                      <m:t>50</m:t>
-                    </m:r>
-                  </m:oMath>
-                </a14:m>
-                <a:r>
-                  <a:rPr sz="1000" b="0" i="0" baseline="0" dirty="0">
-                    <a:latin typeface="Calibri"/>
-                  </a:rPr>
-                  <a:t> seeds · bracket </a:t>
-                </a:r>
-                <a:r>
-                  <a:rPr sz="1000" b="0" i="0" baseline="0" dirty="0" err="1">
-                    <a:latin typeface="Calibri"/>
-                  </a:rPr>
-                  <a:t>tol</a:t>
-                </a:r>
-                <a14:m>
-                  <m:oMath xmlns:m="http://schemas.openxmlformats.org/officeDocument/2006/math">
-                    <m:r>
-                      <a:rPr lang="en-US" sz="1000" b="0" i="0" baseline="0" dirty="0" smtClean="0">
-                        <a:latin typeface="Cambria Math" panose="02040503050406030204" pitchFamily="18" charset="0"/>
-                      </a:rPr>
-                      <m:t>=0.001</m:t>
-                    </m:r>
-                  </m:oMath>
-                </a14:m>
-                <a:r>
-                  <a:rPr sz="1000" b="0" i="0" baseline="0" dirty="0">
-                    <a:latin typeface="Calibri"/>
-                  </a:rPr>
-                  <a:t> · longitudinal </a:t>
-                </a:r>
-                <a14:m>
-                  <m:oMath xmlns:m="http://schemas.openxmlformats.org/officeDocument/2006/math">
-                    <m:sSup>
-                      <m:sSupPr>
-                        <m:ctrlPr>
-                          <a:rPr lang="en-US" sz="1000" b="0" i="0" baseline="0" dirty="0">
-                            <a:latin typeface="Cambria Math" panose="02040503050406030204" pitchFamily="18" charset="0"/>
-                          </a:rPr>
-                        </m:ctrlPr>
-                      </m:sSupPr>
-                      <m:e>
-                        <m:r>
-                          <a:rPr lang="en-US" sz="1000" b="0" i="0" baseline="0" dirty="0">
-                            <a:latin typeface="Cambria Math" panose="02040503050406030204" pitchFamily="18" charset="0"/>
-                          </a:rPr>
-                          <m:t>𝜌</m:t>
-                        </m:r>
-                      </m:e>
-                      <m:sup>
-                        <m:r>
-                          <a:rPr lang="en-US" sz="1000" b="0" i="0" baseline="0" dirty="0">
-                            <a:latin typeface="Cambria Math" panose="02040503050406030204" pitchFamily="18" charset="0"/>
-                          </a:rPr>
-                          <m:t>∗</m:t>
-                        </m:r>
-                      </m:sup>
-                    </m:sSup>
-                    <m:r>
-                      <a:rPr lang="en-US" sz="1000" b="0" i="0" baseline="0" dirty="0">
-                        <a:latin typeface="Cambria Math" panose="02040503050406030204" pitchFamily="18" charset="0"/>
-                      </a:rPr>
-                      <m:t>≈0</m:t>
-                    </m:r>
-                  </m:oMath>
-                </a14:m>
-                <a:r>
-                  <a:rPr sz="1000" b="0" i="0" baseline="0" dirty="0">
-                    <a:latin typeface="Calibri"/>
-                  </a:rPr>
-                  <a:t> · hero panel</a:t>
-                </a:r>
-              </a:p>
-            </p:txBody>
-          </p:sp>
-        </mc:Choice>
-        <mc:Fallback>
-          <p:sp>
-            <p:nvSpPr>
-              <p:cNvPr id="3" name="TextBox 2"/>
-              <p:cNvSpPr txBox="1">
-                <a:spLocks noRot="1" noChangeAspect="1" noMove="1" noResize="1" noEditPoints="1" noAdjustHandles="1" noChangeArrowheads="1" noChangeShapeType="1" noTextEdit="1"/>
-              </p:cNvSpPr>
-              <p:nvPr/>
-            </p:nvSpPr>
-            <p:spPr>
-              <a:xfrm>
-                <a:off x="384048" y="713232"/>
-                <a:ext cx="5721118" cy="246221"/>
-              </a:xfrm>
-              <a:prstGeom prst="rect">
-                <a:avLst/>
-              </a:prstGeom>
-              <a:blipFill>
-                <a:blip r:embed="rId3"/>
-                <a:stretch>
-                  <a:fillRect b="-10000"/>
-                </a:stretch>
-              </a:blipFill>
-            </p:spPr>
-            <p:txBody>
-              <a:bodyPr/>
-              <a:lstStyle/>
-              <a:p>
-                <a:r>
-                  <a:rPr lang="en-US">
-                    <a:noFill/>
-                  </a:rPr>
-                  <a:t> </a:t>
-                </a:r>
-              </a:p>
-            </p:txBody>
-          </p:sp>
-        </mc:Fallback>
-      </mc:AlternateContent>
+      <p:grpSpPr/>
+      <p:sp>
+        <p:nvSpPr>
+          <p:cNvPr id="2" name="TextBox 1"/>
+          <p:cNvSpPr txBox="1"/>
+          <p:nvPr/>
+        </p:nvSpPr>
+        <p:spPr>
+          <a:xfrm>
+            <a:off x="384048" y="219456"/>
+            <a:ext cx="11423599" cy="457200"/>
+          </a:xfrm>
+          <a:prstGeom prst="rect">
+            <a:avLst/>
+          </a:prstGeom>
+          <a:noFill/>
+        </p:spPr>
+        <p:txBody>
+          <a:bodyPr wrap="none">
+            <a:spAutoFit/>
+          </a:bodyPr>
+          <a:lstStyle/>
+          <a:p>
+            <a:r>
+              <a:rPr sz="2000" b="1" i="0" baseline="0">
+                <a:latin typeface="Calibri"/>
+              </a:rPr>
+              <a:t>PD21 — Calibrate homophily $\rho$ to empirical sorting index $H_{\mathrm{sort}}$ (hero panel — locked calibration)</a:t>
+            </a:r>
+          </a:p>
+        </p:txBody>
+      </p:sp>
+      <p:sp>
+        <p:nvSpPr>
+          <p:cNvPr id="3" name="TextBox 2"/>
+          <p:cNvSpPr txBox="1"/>
+          <p:nvPr/>
+        </p:nvSpPr>
+        <p:spPr>
+          <a:xfrm>
+            <a:off x="384048" y="713232"/>
+            <a:ext cx="11423599" cy="246888"/>
+          </a:xfrm>
+          <a:prstGeom prst="rect">
+            <a:avLst/>
+          </a:prstGeom>
+          <a:noFill/>
+        </p:spPr>
+        <p:txBody>
+          <a:bodyPr wrap="none">
+            <a:spAutoFit/>
+          </a:bodyPr>
+          <a:lstStyle/>
+          <a:p>
+            <a:r>
+              <a:rPr sz="1000" b="0" i="0" baseline="0">
+                <a:latin typeface="Calibri"/>
+              </a:rPr>
+              <a:t>PD21 · LG ASSIGN calibration · 2011-2021 · 50 seeds · bracket tol=0.001 · longitudinal $\rho^* \approx 0$ · hero panel</a:t>
+            </a:r>
+          </a:p>
+        </p:txBody>
+      </p:sp>
       <p:pic>
         <p:nvPicPr>
           <p:cNvPr id="4" name="Picture 3" descr="PD21_rho_hsort_calibrate_2011_2021_bracket.png"/>
@@ -3378,1945 +3159,356 @@
           <p:nvPr/>
         </p:nvPicPr>
         <p:blipFill>
-          <a:blip r:embed="rId4"/>
+          <a:blip r:embed="rId2"/>
           <a:stretch>
             <a:fillRect/>
           </a:stretch>
         </p:blipFill>
         <p:spPr>
           <a:xfrm>
-            <a:off x="4379976" y="1160349"/>
-            <a:ext cx="7653840" cy="4982550"/>
+            <a:off x="4379976" y="1107353"/>
+            <a:ext cx="7427671" cy="4835317"/>
           </a:xfrm>
           <a:prstGeom prst="rect">
             <a:avLst/>
           </a:prstGeom>
         </p:spPr>
       </p:pic>
-      <mc:AlternateContent xmlns:mc="http://schemas.openxmlformats.org/markup-compatibility/2006">
-        <mc:Choice xmlns:a14="http://schemas.microsoft.com/office/drawing/2010/main" Requires="a14">
-          <p:sp>
-            <p:nvSpPr>
-              <p:cNvPr id="5" name="TextBox 4"/>
-              <p:cNvSpPr txBox="1"/>
-              <p:nvPr/>
-            </p:nvSpPr>
-            <p:spPr>
-              <a:xfrm>
-                <a:off x="283932" y="1199867"/>
-                <a:ext cx="4147904" cy="4481291"/>
-              </a:xfrm>
-              <a:prstGeom prst="rect">
-                <a:avLst/>
-              </a:prstGeom>
-              <a:noFill/>
-            </p:spPr>
-            <p:txBody>
-              <a:bodyPr wrap="square">
-                <a:spAutoFit/>
-              </a:bodyPr>
-              <a:lstStyle/>
-              <a:p>
-                <a:pPr>
-                  <a:buChar char="•"/>
-                </a:pPr>
-                <a:r>
-                  <a:rPr sz="1000" b="0" i="0" baseline="0" dirty="0">
-                    <a:latin typeface="Calibri"/>
-                  </a:rPr>
-                  <a:t>  PD21 locked calibration (Aug 2026): bracket search on hero panel for Alex ASSIGN $\rho$.</a:t>
-                </a:r>
-              </a:p>
-              <a:p>
-                <a:pPr>
-                  <a:buChar char="•"/>
-                </a:pPr>
-                <a:r>
-                  <a:rPr sz="1000" b="0" i="0" baseline="0" dirty="0">
-                    <a:latin typeface="Calibri"/>
-                  </a:rPr>
-                  <a:t>  Alex (Aug 2026): calibrate ASSIGN </a:t>
-                </a:r>
-                <a14:m>
-                  <m:oMath xmlns:m="http://schemas.openxmlformats.org/officeDocument/2006/math">
-                    <m:r>
-                      <a:rPr lang="en-US" sz="1000" b="0" i="0" baseline="0" dirty="0" smtClean="0">
-                        <a:latin typeface="Cambria Math" panose="02040503050406030204" pitchFamily="18" charset="0"/>
-                      </a:rPr>
-                      <m:t>𝜌</m:t>
-                    </m:r>
-                  </m:oMath>
-                </a14:m>
-                <a:r>
-                  <a:rPr sz="1000" b="0" i="0" baseline="0" dirty="0">
-                    <a:latin typeface="Calibri"/>
-                  </a:rPr>
-                  <a:t> so LG simulated </a:t>
-                </a:r>
-                <a14:m>
-                  <m:oMath xmlns:m="http://schemas.openxmlformats.org/officeDocument/2006/math">
-                    <m:sSub>
-                      <m:sSubPr>
-                        <m:ctrlPr>
-                          <a:rPr lang="en-US" sz="1000" b="0" i="0" baseline="0" dirty="0">
-                            <a:latin typeface="Cambria Math" panose="02040503050406030204" pitchFamily="18" charset="0"/>
-                          </a:rPr>
-                        </m:ctrlPr>
-                      </m:sSubPr>
-                      <m:e>
-                        <m:r>
-                          <a:rPr lang="en-US" sz="1000" b="0" i="0" baseline="0" dirty="0">
-                            <a:latin typeface="Cambria Math" panose="02040503050406030204" pitchFamily="18" charset="0"/>
-                          </a:rPr>
-                          <m:t>𝐻</m:t>
-                        </m:r>
-                      </m:e>
-                      <m:sub>
-                        <m:r>
-                          <m:rPr>
-                            <m:sty m:val="p"/>
-                          </m:rPr>
-                          <a:rPr lang="en-US" sz="1000" b="0" i="0" baseline="0" dirty="0">
-                            <a:latin typeface="Cambria Math" panose="02040503050406030204" pitchFamily="18" charset="0"/>
-                          </a:rPr>
-                          <m:t>sort</m:t>
-                        </m:r>
-                      </m:sub>
-                    </m:sSub>
-                  </m:oMath>
-                </a14:m>
-                <a:r>
-                  <a:rPr sz="1000" b="0" i="0" baseline="0" dirty="0">
-                    <a:latin typeface="Calibri"/>
-                  </a:rPr>
-                  <a:t> matches empirical NCAA; formal </a:t>
-                </a:r>
-                <a14:m>
-                  <m:oMath xmlns:m="http://schemas.openxmlformats.org/officeDocument/2006/math">
-                    <m:r>
-                      <a:rPr lang="en-US" sz="1000" b="0" i="0" baseline="0" dirty="0" smtClean="0">
-                        <a:latin typeface="Cambria Math" panose="02040503050406030204" pitchFamily="18" charset="0"/>
-                      </a:rPr>
-                      <m:t>𝜌</m:t>
-                    </m:r>
-                  </m:oMath>
-                </a14:m>
-                <a:r>
-                  <a:rPr sz="1000" b="0" i="0" baseline="0" dirty="0">
-                    <a:latin typeface="Calibri"/>
-                  </a:rPr>
-                  <a:t> MLE parked.</a:t>
-                </a:r>
-              </a:p>
-              <a:p>
-                <a:pPr>
-                  <a:buChar char="•"/>
-                </a:pPr>
-                <a:r>
-                  <a:rPr sz="1000" b="0" i="0" baseline="0" dirty="0">
-                    <a:latin typeface="Calibri"/>
-                  </a:rPr>
-                  <a:t>  Panel: 2011–2021 MBB · min</a:t>
-                </a:r>
-                <a14:m>
-                  <m:oMath xmlns:m="http://schemas.openxmlformats.org/officeDocument/2006/math">
-                    <m:r>
-                      <a:rPr lang="en-US" sz="1000" b="0" i="0" baseline="0" dirty="0" smtClean="0">
-                        <a:latin typeface="Cambria Math" panose="02040503050406030204" pitchFamily="18" charset="0"/>
-                      </a:rPr>
-                      <m:t>≥20</m:t>
-                    </m:r>
-                  </m:oMath>
-                </a14:m>
-                <a:r>
-                  <a:rPr sz="1000" b="0" i="0" baseline="0" dirty="0">
-                    <a:latin typeface="Calibri"/>
-                  </a:rPr>
-                  <a:t> min player-season drop · box QC at panel build · empirical roster caps · PPM z-scored within season.</a:t>
-                </a:r>
-              </a:p>
-              <a:p>
-                <a:pPr>
-                  <a:buChar char="•"/>
-                </a:pPr>
-                <a:r>
-                  <a:rPr sz="1000" b="0" i="0" baseline="0" dirty="0">
-                    <a:latin typeface="Calibri"/>
-                  </a:rPr>
-                  <a:t>  Search: bracket + bisect (</a:t>
-                </a:r>
-                <a:r>
-                  <a:rPr sz="1000" b="0" i="0" baseline="0" dirty="0" err="1">
-                    <a:latin typeface="Calibri"/>
-                  </a:rPr>
-                  <a:t>tol</a:t>
-                </a:r>
-                <a14:m>
-                  <m:oMath xmlns:m="http://schemas.openxmlformats.org/officeDocument/2006/math">
-                    <m:r>
-                      <a:rPr lang="en-US" sz="1000" b="0" i="0" baseline="0" dirty="0" smtClean="0">
-                        <a:latin typeface="Cambria Math" panose="02040503050406030204" pitchFamily="18" charset="0"/>
-                      </a:rPr>
-                      <m:t>=0.001</m:t>
-                    </m:r>
-                  </m:oMath>
-                </a14:m>
-                <a:r>
-                  <a:rPr sz="1000" b="0" i="0" baseline="0" dirty="0">
-                    <a:latin typeface="Calibri"/>
-                  </a:rPr>
-                  <a:t>), </a:t>
-                </a:r>
-                <a14:m>
-                  <m:oMath xmlns:m="http://schemas.openxmlformats.org/officeDocument/2006/math">
-                    <m:r>
-                      <a:rPr lang="en-US" sz="1000" b="0" i="0" baseline="0" dirty="0" smtClean="0">
-                        <a:latin typeface="Cambria Math" panose="02040503050406030204" pitchFamily="18" charset="0"/>
-                      </a:rPr>
-                      <m:t>50</m:t>
-                    </m:r>
-                  </m:oMath>
-                </a14:m>
-                <a:r>
-                  <a:rPr sz="1000" b="0" i="0" baseline="0" dirty="0">
-                    <a:latin typeface="Calibri"/>
-                  </a:rPr>
-                  <a:t> seeds/arm; </a:t>
-                </a:r>
-                <a14:m>
-                  <m:oMath xmlns:m="http://schemas.openxmlformats.org/officeDocument/2006/math">
-                    <m:sSubSup>
-                      <m:sSubSupPr>
-                        <m:ctrlPr>
-                          <a:rPr lang="en-US" sz="1000" b="0" i="0" baseline="0" dirty="0">
-                            <a:latin typeface="Cambria Math" panose="02040503050406030204" pitchFamily="18" charset="0"/>
-                          </a:rPr>
-                        </m:ctrlPr>
-                      </m:sSubSupPr>
-                      <m:e>
-                        <m:r>
-                          <a:rPr lang="en-US" sz="1000" b="0" i="0" baseline="0" dirty="0">
-                            <a:latin typeface="Cambria Math" panose="02040503050406030204" pitchFamily="18" charset="0"/>
-                          </a:rPr>
-                          <m:t>𝐻</m:t>
-                        </m:r>
-                      </m:e>
-                      <m:sub>
-                        <m:r>
-                          <m:rPr>
-                            <m:sty m:val="p"/>
-                          </m:rPr>
-                          <a:rPr lang="en-US" sz="1000" b="0" i="0" baseline="0" dirty="0">
-                            <a:latin typeface="Cambria Math" panose="02040503050406030204" pitchFamily="18" charset="0"/>
-                          </a:rPr>
-                          <m:t>sort</m:t>
-                        </m:r>
-                      </m:sub>
-                      <m:sup>
-                        <m:r>
-                          <m:rPr>
-                            <m:sty m:val="p"/>
-                          </m:rPr>
-                          <a:rPr lang="en-US" sz="1000" b="0" i="0" baseline="0" dirty="0">
-                            <a:latin typeface="Cambria Math" panose="02040503050406030204" pitchFamily="18" charset="0"/>
-                          </a:rPr>
-                          <m:t>sim</m:t>
-                        </m:r>
-                      </m:sup>
-                    </m:sSubSup>
-                  </m:oMath>
-                </a14:m>
-                <a:r>
-                  <a:rPr sz="1000" b="0" i="0" baseline="0" dirty="0">
-                    <a:latin typeface="Calibri"/>
-                  </a:rPr>
-                  <a:t> monotone in </a:t>
-                </a:r>
-                <a14:m>
-                  <m:oMath xmlns:m="http://schemas.openxmlformats.org/officeDocument/2006/math">
-                    <m:r>
-                      <a:rPr lang="en-US" sz="1000" b="0" i="0" baseline="0" dirty="0" smtClean="0">
-                        <a:latin typeface="Cambria Math" panose="02040503050406030204" pitchFamily="18" charset="0"/>
-                      </a:rPr>
-                      <m:t>𝜌</m:t>
-                    </m:r>
-                  </m:oMath>
-                </a14:m>
-                <a:r>
-                  <a:rPr sz="1000" b="0" i="0" baseline="0" dirty="0">
-                    <a:latin typeface="Calibri"/>
-                  </a:rPr>
-                  <a:t>.</a:t>
-                </a:r>
-              </a:p>
-              <a:p>
-                <a:pPr>
-                  <a:buChar char="•"/>
-                </a:pPr>
-                <a:r>
-                  <a:rPr sz="1000" b="0" i="0" baseline="0" dirty="0">
-                    <a:latin typeface="Calibri"/>
-                  </a:rPr>
-                  <a:t>  </a:t>
-                </a:r>
-                <a14:m>
-                  <m:oMath xmlns:m="http://schemas.openxmlformats.org/officeDocument/2006/math">
-                    <m:sSub>
-                      <m:sSubPr>
-                        <m:ctrlPr>
-                          <a:rPr lang="en-US" sz="1000" b="0" i="0" baseline="0" dirty="0">
-                            <a:latin typeface="Cambria Math" panose="02040503050406030204" pitchFamily="18" charset="0"/>
-                          </a:rPr>
-                        </m:ctrlPr>
-                      </m:sSubPr>
-                      <m:e>
-                        <m:r>
-                          <a:rPr lang="en-US" sz="1000" b="0" i="0" baseline="0" dirty="0">
-                            <a:latin typeface="Cambria Math" panose="02040503050406030204" pitchFamily="18" charset="0"/>
-                          </a:rPr>
-                          <m:t>𝐻</m:t>
-                        </m:r>
-                      </m:e>
-                      <m:sub>
-                        <m:r>
-                          <a:rPr lang="en-US" sz="1000" b="0" i="0" baseline="0" dirty="0">
-                            <a:latin typeface="Cambria Math" panose="02040503050406030204" pitchFamily="18" charset="0"/>
-                          </a:rPr>
-                          <m:t>𝑠𝑜𝑟𝑡</m:t>
-                        </m:r>
-                      </m:sub>
-                    </m:sSub>
-                    <m:r>
-                      <a:rPr lang="en-US" sz="1000" b="0" i="0" baseline="0" dirty="0">
-                        <a:latin typeface="Cambria Math" panose="02040503050406030204" pitchFamily="18" charset="0"/>
-                      </a:rPr>
-                      <m:t>=1−</m:t>
-                    </m:r>
-                    <m:nary>
-                      <m:naryPr>
-                        <m:chr m:val="∑"/>
-                        <m:limLoc m:val="undOvr"/>
-                        <m:supHide m:val="on"/>
-                        <m:ctrlPr>
-                          <a:rPr lang="en-US" sz="1000" b="0" i="0" baseline="0" dirty="0">
-                            <a:latin typeface="Cambria Math" panose="02040503050406030204" pitchFamily="18" charset="0"/>
-                          </a:rPr>
-                        </m:ctrlPr>
-                      </m:naryPr>
-                      <m:sub>
-                        <m:r>
-                          <a:rPr lang="en-US" sz="1000" b="0" i="0" baseline="0" dirty="0">
-                            <a:latin typeface="Cambria Math" panose="02040503050406030204" pitchFamily="18" charset="0"/>
-                          </a:rPr>
-                          <m:t>𝑖</m:t>
-                        </m:r>
-                      </m:sub>
-                      <m:sup/>
-                      <m:e>
-                        <m:sSup>
-                          <m:sSupPr>
-                            <m:ctrlPr>
-                              <a:rPr lang="en-US" sz="1000" b="0" i="0" baseline="0" dirty="0">
-                                <a:latin typeface="Cambria Math" panose="02040503050406030204" pitchFamily="18" charset="0"/>
-                              </a:rPr>
-                            </m:ctrlPr>
-                          </m:sSupPr>
-                          <m:e>
-                            <m:d>
-                              <m:dPr>
-                                <m:ctrlPr>
-                                  <a:rPr lang="en-US" sz="1000" b="0" i="0" baseline="0" dirty="0">
-                                    <a:latin typeface="Cambria Math" panose="02040503050406030204" pitchFamily="18" charset="0"/>
-                                  </a:rPr>
-                                </m:ctrlPr>
-                              </m:dPr>
-                              <m:e>
-                                <m:sSub>
-                                  <m:sSubPr>
-                                    <m:ctrlPr>
-                                      <a:rPr lang="en-US" sz="1000" b="0" i="0" baseline="0" dirty="0">
-                                        <a:latin typeface="Cambria Math" panose="02040503050406030204" pitchFamily="18" charset="0"/>
-                                      </a:rPr>
-                                    </m:ctrlPr>
-                                  </m:sSubPr>
-                                  <m:e>
-                                    <m:acc>
-                                      <m:accPr>
-                                        <m:chr m:val="ˆ"/>
-                                        <m:ctrlPr>
-                                          <a:rPr lang="en-US" sz="1000" b="0" i="0" baseline="0" dirty="0">
-                                            <a:latin typeface="Cambria Math" panose="02040503050406030204" pitchFamily="18" charset="0"/>
-                                          </a:rPr>
-                                        </m:ctrlPr>
-                                      </m:accPr>
-                                      <m:e>
-                                        <m:r>
-                                          <a:rPr lang="en-US" sz="1000" b="0" i="0" baseline="0" dirty="0">
-                                            <a:latin typeface="Cambria Math" panose="02040503050406030204" pitchFamily="18" charset="0"/>
-                                          </a:rPr>
-                                          <m:t>𝐴</m:t>
-                                        </m:r>
-                                      </m:e>
-                                    </m:acc>
-                                  </m:e>
-                                  <m:sub>
-                                    <m:r>
-                                      <a:rPr lang="en-US" sz="1000" b="0" i="0" baseline="0" dirty="0">
-                                        <a:latin typeface="Cambria Math" panose="02040503050406030204" pitchFamily="18" charset="0"/>
-                                      </a:rPr>
-                                      <m:t>𝑖</m:t>
-                                    </m:r>
-                                  </m:sub>
-                                </m:sSub>
-                                <m:r>
-                                  <a:rPr lang="en-US" sz="1000" b="0" i="0" baseline="0" dirty="0">
-                                    <a:latin typeface="Cambria Math" panose="02040503050406030204" pitchFamily="18" charset="0"/>
-                                  </a:rPr>
-                                  <m:t>−</m:t>
-                                </m:r>
-                                <m:sSub>
-                                  <m:sSubPr>
-                                    <m:ctrlPr>
-                                      <a:rPr lang="en-US" sz="1000" b="0" i="0" baseline="0" dirty="0">
-                                        <a:latin typeface="Cambria Math" panose="02040503050406030204" pitchFamily="18" charset="0"/>
-                                      </a:rPr>
-                                    </m:ctrlPr>
-                                  </m:sSubPr>
-                                  <m:e>
-                                    <m:acc>
-                                      <m:accPr>
-                                        <m:chr m:val="ˆ"/>
-                                        <m:ctrlPr>
-                                          <a:rPr lang="en-US" sz="1000" b="0" i="0" baseline="0" dirty="0">
-                                            <a:latin typeface="Cambria Math" panose="02040503050406030204" pitchFamily="18" charset="0"/>
-                                          </a:rPr>
-                                        </m:ctrlPr>
-                                      </m:accPr>
-                                      <m:e>
-                                        <m:r>
-                                          <a:rPr lang="en-US" sz="1000" b="0" i="0" baseline="0" dirty="0">
-                                            <a:latin typeface="Cambria Math" panose="02040503050406030204" pitchFamily="18" charset="0"/>
-                                          </a:rPr>
-                                          <m:t>𝜇</m:t>
-                                        </m:r>
-                                      </m:e>
-                                    </m:acc>
-                                  </m:e>
-                                  <m:sub>
-                                    <m:r>
-                                      <a:rPr lang="en-US" sz="1000" b="0" i="0" baseline="0" dirty="0">
-                                        <a:latin typeface="Cambria Math" panose="02040503050406030204" pitchFamily="18" charset="0"/>
-                                      </a:rPr>
-                                      <m:t>𝑔</m:t>
-                                    </m:r>
-                                    <m:d>
-                                      <m:dPr>
-                                        <m:ctrlPr>
-                                          <a:rPr lang="en-US" sz="1000" b="0" i="0" baseline="0" dirty="0">
-                                            <a:latin typeface="Cambria Math" panose="02040503050406030204" pitchFamily="18" charset="0"/>
-                                          </a:rPr>
-                                        </m:ctrlPr>
-                                      </m:dPr>
-                                      <m:e>
-                                        <m:r>
-                                          <a:rPr lang="en-US" sz="1000" b="0" i="0" baseline="0" dirty="0">
-                                            <a:latin typeface="Cambria Math" panose="02040503050406030204" pitchFamily="18" charset="0"/>
-                                          </a:rPr>
-                                          <m:t>𝑖</m:t>
-                                        </m:r>
-                                      </m:e>
-                                    </m:d>
-                                  </m:sub>
-                                </m:sSub>
-                              </m:e>
-                            </m:d>
-                          </m:e>
-                          <m:sup>
-                            <m:r>
-                              <a:rPr lang="en-US" sz="1000" b="0" i="0" baseline="0" dirty="0">
-                                <a:latin typeface="Cambria Math" panose="02040503050406030204" pitchFamily="18" charset="0"/>
-                              </a:rPr>
-                              <m:t>2</m:t>
-                            </m:r>
-                          </m:sup>
-                        </m:sSup>
-                      </m:e>
-                    </m:nary>
-                    <m:r>
-                      <a:rPr lang="en-US" sz="1000" b="0" i="0" baseline="0" dirty="0">
-                        <a:latin typeface="Cambria Math" panose="02040503050406030204" pitchFamily="18" charset="0"/>
-                      </a:rPr>
-                      <m:t>/</m:t>
-                    </m:r>
-                    <m:nary>
-                      <m:naryPr>
-                        <m:chr m:val="∑"/>
-                        <m:limLoc m:val="undOvr"/>
-                        <m:supHide m:val="on"/>
-                        <m:ctrlPr>
-                          <a:rPr lang="en-US" sz="1000" b="0" i="0" baseline="0" dirty="0">
-                            <a:latin typeface="Cambria Math" panose="02040503050406030204" pitchFamily="18" charset="0"/>
-                          </a:rPr>
-                        </m:ctrlPr>
-                      </m:naryPr>
-                      <m:sub>
-                        <m:r>
-                          <a:rPr lang="en-US" sz="1000" b="0" i="0" baseline="0" dirty="0">
-                            <a:latin typeface="Cambria Math" panose="02040503050406030204" pitchFamily="18" charset="0"/>
-                          </a:rPr>
-                          <m:t>𝑖</m:t>
-                        </m:r>
-                      </m:sub>
-                      <m:sup/>
-                      <m:e>
-                        <m:sSup>
-                          <m:sSupPr>
-                            <m:ctrlPr>
-                              <a:rPr lang="en-US" sz="1000" b="0" i="0" baseline="0" dirty="0">
-                                <a:latin typeface="Cambria Math" panose="02040503050406030204" pitchFamily="18" charset="0"/>
-                              </a:rPr>
-                            </m:ctrlPr>
-                          </m:sSupPr>
-                          <m:e>
-                            <m:d>
-                              <m:dPr>
-                                <m:ctrlPr>
-                                  <a:rPr lang="en-US" sz="1000" b="0" i="0" baseline="0" dirty="0">
-                                    <a:latin typeface="Cambria Math" panose="02040503050406030204" pitchFamily="18" charset="0"/>
-                                  </a:rPr>
-                                </m:ctrlPr>
-                              </m:dPr>
-                              <m:e>
-                                <m:sSub>
-                                  <m:sSubPr>
-                                    <m:ctrlPr>
-                                      <a:rPr lang="en-US" sz="1000" b="0" i="0" baseline="0" dirty="0">
-                                        <a:latin typeface="Cambria Math" panose="02040503050406030204" pitchFamily="18" charset="0"/>
-                                      </a:rPr>
-                                    </m:ctrlPr>
-                                  </m:sSubPr>
-                                  <m:e>
-                                    <m:acc>
-                                      <m:accPr>
-                                        <m:chr m:val="ˆ"/>
-                                        <m:ctrlPr>
-                                          <a:rPr lang="en-US" sz="1000" b="0" i="0" baseline="0" dirty="0">
-                                            <a:latin typeface="Cambria Math" panose="02040503050406030204" pitchFamily="18" charset="0"/>
-                                          </a:rPr>
-                                        </m:ctrlPr>
-                                      </m:accPr>
-                                      <m:e>
-                                        <m:r>
-                                          <a:rPr lang="en-US" sz="1000" b="0" i="0" baseline="0" dirty="0">
-                                            <a:latin typeface="Cambria Math" panose="02040503050406030204" pitchFamily="18" charset="0"/>
-                                          </a:rPr>
-                                          <m:t>𝐴</m:t>
-                                        </m:r>
-                                      </m:e>
-                                    </m:acc>
-                                  </m:e>
-                                  <m:sub>
-                                    <m:r>
-                                      <a:rPr lang="en-US" sz="1000" b="0" i="0" baseline="0" dirty="0">
-                                        <a:latin typeface="Cambria Math" panose="02040503050406030204" pitchFamily="18" charset="0"/>
-                                      </a:rPr>
-                                      <m:t>𝑖</m:t>
-                                    </m:r>
-                                  </m:sub>
-                                </m:sSub>
-                                <m:r>
-                                  <a:rPr lang="en-US" sz="1000" b="0" i="0" baseline="0" dirty="0">
-                                    <a:latin typeface="Cambria Math" panose="02040503050406030204" pitchFamily="18" charset="0"/>
-                                  </a:rPr>
-                                  <m:t>−</m:t>
-                                </m:r>
-                                <m:acc>
-                                  <m:accPr>
-                                    <m:chr m:val="̅"/>
-                                    <m:ctrlPr>
-                                      <a:rPr lang="en-US" sz="1000" b="0" i="0" baseline="0" dirty="0">
-                                        <a:latin typeface="Cambria Math" panose="02040503050406030204" pitchFamily="18" charset="0"/>
-                                      </a:rPr>
-                                    </m:ctrlPr>
-                                  </m:accPr>
-                                  <m:e>
-                                    <m:r>
-                                      <a:rPr lang="en-US" sz="1000" b="0" i="0" baseline="0" dirty="0">
-                                        <a:latin typeface="Cambria Math" panose="02040503050406030204" pitchFamily="18" charset="0"/>
-                                      </a:rPr>
-                                      <m:t>𝐴</m:t>
-                                    </m:r>
-                                  </m:e>
-                                </m:acc>
-                              </m:e>
-                            </m:d>
-                          </m:e>
-                          <m:sup>
-                            <m:r>
-                              <a:rPr lang="en-US" sz="1000" b="0" i="0" baseline="0" dirty="0">
-                                <a:latin typeface="Cambria Math" panose="02040503050406030204" pitchFamily="18" charset="0"/>
-                              </a:rPr>
-                              <m:t>2</m:t>
-                            </m:r>
-                          </m:sup>
-                        </m:sSup>
-                      </m:e>
-                    </m:nary>
-                  </m:oMath>
-                </a14:m>
-                <a:r>
-                  <a:rPr sz="1000" b="0" i="0" baseline="0" dirty="0">
-                    <a:latin typeface="Calibri"/>
-                  </a:rPr>
-                  <a:t> — realized sorting on a fixed partition.</a:t>
-                </a:r>
-              </a:p>
-              <a:p>
-                <a:pPr>
-                  <a:buChar char="•"/>
-                </a:pPr>
-                <a:r>
-                  <a:rPr sz="1000" b="0" i="0" baseline="0" dirty="0">
-                    <a:latin typeface="Calibri"/>
-                  </a:rPr>
-                  <a:t>  Longitudinal </a:t>
-                </a:r>
-                <a14:m>
-                  <m:oMath xmlns:m="http://schemas.openxmlformats.org/officeDocument/2006/math">
-                    <m:sSup>
-                      <m:sSupPr>
-                        <m:ctrlPr>
-                          <a:rPr lang="en-US" sz="1000" b="0" i="0" baseline="0" dirty="0">
-                            <a:latin typeface="Cambria Math" panose="02040503050406030204" pitchFamily="18" charset="0"/>
-                          </a:rPr>
-                        </m:ctrlPr>
-                      </m:sSupPr>
-                      <m:e>
-                        <m:r>
-                          <a:rPr lang="en-US" sz="1000" b="0" i="0" baseline="0" dirty="0">
-                            <a:latin typeface="Cambria Math" panose="02040503050406030204" pitchFamily="18" charset="0"/>
-                          </a:rPr>
-                          <m:t>𝜌</m:t>
-                        </m:r>
-                      </m:e>
-                      <m:sup>
-                        <m:r>
-                          <a:rPr lang="en-US" sz="1000" b="0" i="0" baseline="0" dirty="0">
-                            <a:latin typeface="Cambria Math" panose="02040503050406030204" pitchFamily="18" charset="0"/>
-                          </a:rPr>
-                          <m:t>∗</m:t>
-                        </m:r>
-                      </m:sup>
-                    </m:sSup>
-                    <m:r>
-                      <a:rPr lang="en-US" sz="1000" b="0" i="0" baseline="0" dirty="0">
-                        <a:latin typeface="Cambria Math" panose="02040503050406030204" pitchFamily="18" charset="0"/>
-                      </a:rPr>
-                      <m:t>≈0</m:t>
-                    </m:r>
-                  </m:oMath>
-                </a14:m>
-                <a:r>
-                  <a:rPr sz="1000" b="0" i="0" baseline="0" dirty="0">
-                    <a:latin typeface="Calibri"/>
-                  </a:rPr>
-                  <a:t>; mean </a:t>
-                </a:r>
-                <a14:m>
-                  <m:oMath xmlns:m="http://schemas.openxmlformats.org/officeDocument/2006/math">
-                    <m:sSubSup>
-                      <m:sSubSupPr>
-                        <m:ctrlPr>
-                          <a:rPr lang="en-US" sz="1000" b="0" i="0" baseline="0" dirty="0">
-                            <a:latin typeface="Cambria Math" panose="02040503050406030204" pitchFamily="18" charset="0"/>
-                          </a:rPr>
-                        </m:ctrlPr>
-                      </m:sSubSupPr>
-                      <m:e>
-                        <m:r>
-                          <a:rPr lang="en-US" sz="1000" b="0" i="0" baseline="0" dirty="0">
-                            <a:latin typeface="Cambria Math" panose="02040503050406030204" pitchFamily="18" charset="0"/>
-                          </a:rPr>
-                          <m:t>𝐻</m:t>
-                        </m:r>
-                      </m:e>
-                      <m:sub>
-                        <m:r>
-                          <m:rPr>
-                            <m:sty m:val="p"/>
-                          </m:rPr>
-                          <a:rPr lang="en-US" sz="1000" b="0" i="0" baseline="0" dirty="0">
-                            <a:latin typeface="Cambria Math" panose="02040503050406030204" pitchFamily="18" charset="0"/>
-                          </a:rPr>
-                          <m:t>sort</m:t>
-                        </m:r>
-                      </m:sub>
-                      <m:sup>
-                        <m:r>
-                          <m:rPr>
-                            <m:sty m:val="p"/>
-                          </m:rPr>
-                          <a:rPr lang="en-US" sz="1000" b="0" i="0" baseline="0" dirty="0">
-                            <a:latin typeface="Cambria Math" panose="02040503050406030204" pitchFamily="18" charset="0"/>
-                          </a:rPr>
-                          <m:t>sim</m:t>
-                        </m:r>
-                      </m:sup>
-                    </m:sSubSup>
-                  </m:oMath>
-                </a14:m>
-                <a:r>
-                  <a:rPr sz="1000" b="0" i="0" baseline="0" dirty="0">
-                    <a:latin typeface="Calibri"/>
-                  </a:rPr>
-                  <a:t> at </a:t>
-                </a:r>
-                <a14:m>
-                  <m:oMath xmlns:m="http://schemas.openxmlformats.org/officeDocument/2006/math">
-                    <m:sSup>
-                      <m:sSupPr>
-                        <m:ctrlPr>
-                          <a:rPr lang="en-US" sz="1000" b="0" i="0" baseline="0" dirty="0">
-                            <a:latin typeface="Cambria Math" panose="02040503050406030204" pitchFamily="18" charset="0"/>
-                          </a:rPr>
-                        </m:ctrlPr>
-                      </m:sSupPr>
-                      <m:e>
-                        <m:r>
-                          <a:rPr lang="en-US" sz="1000" b="0" i="0" baseline="0" dirty="0">
-                            <a:latin typeface="Cambria Math" panose="02040503050406030204" pitchFamily="18" charset="0"/>
-                          </a:rPr>
-                          <m:t>𝜌</m:t>
-                        </m:r>
-                      </m:e>
-                      <m:sup>
-                        <m:r>
-                          <a:rPr lang="en-US" sz="1000" b="0" i="0" baseline="0" dirty="0">
-                            <a:latin typeface="Cambria Math" panose="02040503050406030204" pitchFamily="18" charset="0"/>
-                          </a:rPr>
-                          <m:t>∗</m:t>
-                        </m:r>
-                      </m:sup>
-                    </m:sSup>
-                  </m:oMath>
-                </a14:m>
-                <a:r>
-                  <a:rPr sz="1000" b="0" i="0" baseline="0" dirty="0">
-                    <a:latin typeface="Calibri"/>
-                  </a:rPr>
-                  <a:t> </a:t>
-                </a:r>
-                <a14:m>
-                  <m:oMath xmlns:m="http://schemas.openxmlformats.org/officeDocument/2006/math">
-                    <m:r>
-                      <a:rPr lang="en-US" sz="1000" b="0" i="0" baseline="0" dirty="0" smtClean="0">
-                        <a:latin typeface="Cambria Math" panose="02040503050406030204" pitchFamily="18" charset="0"/>
-                      </a:rPr>
-                      <m:t>=0.082</m:t>
-                    </m:r>
-                  </m:oMath>
-                </a14:m>
-                <a:r>
-                  <a:rPr sz="1000" b="0" i="0" baseline="0" dirty="0">
-                    <a:latin typeface="Calibri"/>
-                  </a:rPr>
-                  <a:t>; mean </a:t>
-                </a:r>
-                <a14:m>
-                  <m:oMath xmlns:m="http://schemas.openxmlformats.org/officeDocument/2006/math">
-                    <m:sSubSup>
-                      <m:sSubSupPr>
-                        <m:ctrlPr>
-                          <a:rPr lang="en-US" sz="1000" b="0" i="0" baseline="0" dirty="0">
-                            <a:latin typeface="Cambria Math" panose="02040503050406030204" pitchFamily="18" charset="0"/>
-                          </a:rPr>
-                        </m:ctrlPr>
-                      </m:sSubSupPr>
-                      <m:e>
-                        <m:r>
-                          <a:rPr lang="en-US" sz="1000" b="0" i="0" baseline="0" dirty="0">
-                            <a:latin typeface="Cambria Math" panose="02040503050406030204" pitchFamily="18" charset="0"/>
-                          </a:rPr>
-                          <m:t>𝐻</m:t>
-                        </m:r>
-                      </m:e>
-                      <m:sub>
-                        <m:r>
-                          <m:rPr>
-                            <m:sty m:val="p"/>
-                          </m:rPr>
-                          <a:rPr lang="en-US" sz="1000" b="0" i="0" baseline="0" dirty="0">
-                            <a:latin typeface="Cambria Math" panose="02040503050406030204" pitchFamily="18" charset="0"/>
-                          </a:rPr>
-                          <m:t>sort</m:t>
-                        </m:r>
-                      </m:sub>
-                      <m:sup>
-                        <m:r>
-                          <m:rPr>
-                            <m:sty m:val="p"/>
-                          </m:rPr>
-                          <a:rPr lang="en-US" sz="1000" b="0" i="0" baseline="0" dirty="0">
-                            <a:latin typeface="Cambria Math" panose="02040503050406030204" pitchFamily="18" charset="0"/>
-                          </a:rPr>
-                          <m:t>emp</m:t>
-                        </m:r>
-                      </m:sup>
-                    </m:sSubSup>
-                  </m:oMath>
-                </a14:m>
-                <a:r>
-                  <a:rPr sz="1000" b="0" i="0" baseline="0" dirty="0">
-                    <a:latin typeface="Calibri"/>
-                  </a:rPr>
-                  <a:t> </a:t>
-                </a:r>
-                <a14:m>
-                  <m:oMath xmlns:m="http://schemas.openxmlformats.org/officeDocument/2006/math">
-                    <m:r>
-                      <a:rPr lang="en-US" sz="1000" b="0" i="0" baseline="0" dirty="0" smtClean="0">
-                        <a:latin typeface="Cambria Math" panose="02040503050406030204" pitchFamily="18" charset="0"/>
-                      </a:rPr>
-                      <m:t>=0.064</m:t>
-                    </m:r>
-                  </m:oMath>
-                </a14:m>
-                <a:r>
-                  <a:rPr sz="1000" b="0" i="0" baseline="0" dirty="0">
-                    <a:latin typeface="Calibri"/>
-                  </a:rPr>
-                  <a:t>.</a:t>
-                </a:r>
-              </a:p>
-              <a:p>
-                <a:pPr>
-                  <a:buChar char="•"/>
-                </a:pPr>
-                <a:r>
-                  <a:rPr sz="1000" b="0" i="0" baseline="0" dirty="0">
-                    <a:latin typeface="Calibri"/>
-                  </a:rPr>
-                  <a:t>  Per-season: 11/11 seasons at </a:t>
-                </a:r>
-                <a14:m>
-                  <m:oMath xmlns:m="http://schemas.openxmlformats.org/officeDocument/2006/math">
-                    <m:sSup>
-                      <m:sSupPr>
-                        <m:ctrlPr>
-                          <a:rPr lang="en-US" sz="1000" b="0" i="0" baseline="0" dirty="0">
-                            <a:latin typeface="Cambria Math" panose="02040503050406030204" pitchFamily="18" charset="0"/>
-                          </a:rPr>
-                        </m:ctrlPr>
-                      </m:sSupPr>
-                      <m:e>
-                        <m:r>
-                          <a:rPr lang="en-US" sz="1000" b="0" i="0" baseline="0" dirty="0">
-                            <a:latin typeface="Cambria Math" panose="02040503050406030204" pitchFamily="18" charset="0"/>
-                          </a:rPr>
-                          <m:t>𝜌</m:t>
-                        </m:r>
-                      </m:e>
-                      <m:sup>
-                        <m:r>
-                          <a:rPr lang="en-US" sz="1000" b="0" i="0" baseline="0" dirty="0">
-                            <a:latin typeface="Cambria Math" panose="02040503050406030204" pitchFamily="18" charset="0"/>
-                          </a:rPr>
-                          <m:t>∗</m:t>
-                        </m:r>
-                      </m:sup>
-                    </m:sSup>
-                    <m:r>
-                      <a:rPr lang="en-US" sz="1000" b="0" i="0" baseline="0" dirty="0">
-                        <a:latin typeface="Cambria Math" panose="02040503050406030204" pitchFamily="18" charset="0"/>
-                      </a:rPr>
-                      <m:t>=0</m:t>
-                    </m:r>
-                  </m:oMath>
-                </a14:m>
-                <a:r>
-                  <a:rPr sz="1000" b="0" i="0" baseline="0" dirty="0">
-                    <a:latin typeface="Calibri"/>
-                  </a:rPr>
-                  <a:t>; all at </a:t>
-                </a:r>
-                <a14:m>
-                  <m:oMath xmlns:m="http://schemas.openxmlformats.org/officeDocument/2006/math">
-                    <m:sSup>
-                      <m:sSupPr>
-                        <m:ctrlPr>
-                          <a:rPr lang="en-US" sz="1000" b="0" i="0" baseline="0" dirty="0">
-                            <a:latin typeface="Cambria Math" panose="02040503050406030204" pitchFamily="18" charset="0"/>
-                          </a:rPr>
-                        </m:ctrlPr>
-                      </m:sSupPr>
-                      <m:e>
-                        <m:r>
-                          <a:rPr lang="en-US" sz="1000" b="0" i="0" baseline="0" dirty="0">
-                            <a:latin typeface="Cambria Math" panose="02040503050406030204" pitchFamily="18" charset="0"/>
-                          </a:rPr>
-                          <m:t>𝜌</m:t>
-                        </m:r>
-                      </m:e>
-                      <m:sup>
-                        <m:r>
-                          <a:rPr lang="en-US" sz="1000" b="0" i="0" baseline="0" dirty="0">
-                            <a:latin typeface="Cambria Math" panose="02040503050406030204" pitchFamily="18" charset="0"/>
-                          </a:rPr>
-                          <m:t>∗</m:t>
-                        </m:r>
-                      </m:sup>
-                    </m:sSup>
-                    <m:r>
-                      <a:rPr lang="en-US" sz="1000" b="0" i="0" baseline="0" dirty="0">
-                        <a:latin typeface="Cambria Math" panose="02040503050406030204" pitchFamily="18" charset="0"/>
-                      </a:rPr>
-                      <m:t>=0</m:t>
-                    </m:r>
-                  </m:oMath>
-                </a14:m>
-                <a:r>
-                  <a:rPr sz="1000" b="0" i="0" baseline="0" dirty="0">
-                    <a:latin typeface="Calibri"/>
-                  </a:rPr>
-                  <a:t>.</a:t>
-                </a:r>
-              </a:p>
-              <a:p>
-                <a:pPr>
-                  <a:buChar char="•"/>
-                </a:pPr>
-                <a:r>
-                  <a:rPr sz="1000" b="0" i="0" baseline="0" dirty="0">
-                    <a:latin typeface="Calibri"/>
-                  </a:rPr>
-                  <a:t>  Legacy reference </a:t>
-                </a:r>
-                <a14:m>
-                  <m:oMath xmlns:m="http://schemas.openxmlformats.org/officeDocument/2006/math">
-                    <m:r>
-                      <a:rPr lang="en-US" sz="1000" b="0" i="0" baseline="0" dirty="0" smtClean="0">
-                        <a:latin typeface="Cambria Math" panose="02040503050406030204" pitchFamily="18" charset="0"/>
-                      </a:rPr>
-                      <m:t>𝜌</m:t>
-                    </m:r>
-                    <m:r>
-                      <a:rPr lang="en-US" sz="1000" b="0" i="0" baseline="0" dirty="0" smtClean="0">
-                        <a:latin typeface="Cambria Math" panose="02040503050406030204" pitchFamily="18" charset="0"/>
-                      </a:rPr>
-                      <m:t>=0.5</m:t>
-                    </m:r>
-                  </m:oMath>
-                </a14:m>
-                <a:r>
-                  <a:rPr sz="1000" b="0" i="0" baseline="0" dirty="0">
-                    <a:latin typeface="Calibri"/>
-                  </a:rPr>
-                  <a:t>: mean </a:t>
-                </a:r>
-                <a14:m>
-                  <m:oMath xmlns:m="http://schemas.openxmlformats.org/officeDocument/2006/math">
-                    <m:d>
-                      <m:dPr>
-                        <m:begChr m:val="|"/>
-                        <m:endChr m:val="|"/>
-                        <m:ctrlPr>
-                          <a:rPr lang="en-US" sz="1000" b="0" i="0" baseline="0" dirty="0">
-                            <a:latin typeface="Cambria Math" panose="02040503050406030204" pitchFamily="18" charset="0"/>
-                          </a:rPr>
-                        </m:ctrlPr>
-                      </m:dPr>
-                      <m:e>
-                        <m:r>
-                          <a:rPr lang="en-US" sz="1000" b="0" i="0" baseline="0" dirty="0">
-                            <a:latin typeface="Cambria Math" panose="02040503050406030204" pitchFamily="18" charset="0"/>
-                          </a:rPr>
-                          <m:t>𝑒𝑟𝑟𝑜𝑟</m:t>
-                        </m:r>
-                      </m:e>
-                    </m:d>
-                    <m:r>
-                      <a:rPr lang="en-US" sz="1000" b="0" i="0" baseline="0" dirty="0">
-                        <a:latin typeface="Cambria Math" panose="02040503050406030204" pitchFamily="18" charset="0"/>
-                      </a:rPr>
-                      <m:t>≈0.112</m:t>
-                    </m:r>
-                  </m:oMath>
-                </a14:m>
-                <a:r>
-                  <a:rPr sz="1000" b="0" i="0" baseline="0" dirty="0">
-                    <a:latin typeface="Calibri"/>
-                  </a:rPr>
-                  <a:t> vs </a:t>
-                </a:r>
-                <a14:m>
-                  <m:oMath xmlns:m="http://schemas.openxmlformats.org/officeDocument/2006/math">
-                    <m:r>
-                      <a:rPr lang="en-US" sz="1000" b="0" i="0" baseline="0" dirty="0" smtClean="0">
-                        <a:latin typeface="Cambria Math" panose="02040503050406030204" pitchFamily="18" charset="0"/>
-                      </a:rPr>
-                      <m:t>≈0.018</m:t>
-                    </m:r>
-                  </m:oMath>
-                </a14:m>
-                <a:r>
-                  <a:rPr sz="1000" b="0" i="0" baseline="0" dirty="0">
-                    <a:latin typeface="Calibri"/>
-                  </a:rPr>
-                  <a:t> at </a:t>
-                </a:r>
-                <a14:m>
-                  <m:oMath xmlns:m="http://schemas.openxmlformats.org/officeDocument/2006/math">
-                    <m:sSup>
-                      <m:sSupPr>
-                        <m:ctrlPr>
-                          <a:rPr lang="en-US" sz="1000" b="0" i="0" baseline="0" dirty="0">
-                            <a:latin typeface="Cambria Math" panose="02040503050406030204" pitchFamily="18" charset="0"/>
-                          </a:rPr>
-                        </m:ctrlPr>
-                      </m:sSupPr>
-                      <m:e>
-                        <m:r>
-                          <a:rPr lang="en-US" sz="1000" b="0" i="0" baseline="0" dirty="0">
-                            <a:latin typeface="Cambria Math" panose="02040503050406030204" pitchFamily="18" charset="0"/>
-                          </a:rPr>
-                          <m:t>𝜌</m:t>
-                        </m:r>
-                      </m:e>
-                      <m:sup>
-                        <m:r>
-                          <a:rPr lang="en-US" sz="1000" b="0" i="0" baseline="0" dirty="0">
-                            <a:latin typeface="Cambria Math" panose="02040503050406030204" pitchFamily="18" charset="0"/>
-                          </a:rPr>
-                          <m:t>∗</m:t>
-                        </m:r>
-                      </m:sup>
-                    </m:sSup>
-                  </m:oMath>
-                </a14:m>
-                <a:r>
-                  <a:rPr sz="1000" b="0" i="0" baseline="0" dirty="0">
-                    <a:latin typeface="Calibri"/>
-                  </a:rPr>
-                  <a:t>.</a:t>
-                </a:r>
-              </a:p>
-              <a:p>
-                <a:pPr>
-                  <a:buChar char="•"/>
-                </a:pPr>
-                <a:r>
-                  <a:rPr sz="1000" b="0" i="0" baseline="0" dirty="0">
-                    <a:latin typeface="Calibri"/>
-                  </a:rPr>
-                  <a:t>  Figure bottom-right inset: per-season </a:t>
-                </a:r>
-                <a14:m>
-                  <m:oMath xmlns:m="http://schemas.openxmlformats.org/officeDocument/2006/math">
-                    <m:sSup>
-                      <m:sSupPr>
-                        <m:ctrlPr>
-                          <a:rPr lang="en-US" sz="1000" b="0" i="0" baseline="0" dirty="0">
-                            <a:latin typeface="Cambria Math" panose="02040503050406030204" pitchFamily="18" charset="0"/>
-                          </a:rPr>
-                        </m:ctrlPr>
-                      </m:sSupPr>
-                      <m:e>
-                        <m:r>
-                          <a:rPr lang="en-US" sz="1000" b="0" i="0" baseline="0" dirty="0">
-                            <a:latin typeface="Cambria Math" panose="02040503050406030204" pitchFamily="18" charset="0"/>
-                          </a:rPr>
-                          <m:t>𝜌</m:t>
-                        </m:r>
-                      </m:e>
-                      <m:sup>
-                        <m:r>
-                          <a:rPr lang="en-US" sz="1000" b="0" i="0" baseline="0" dirty="0">
-                            <a:latin typeface="Cambria Math" panose="02040503050406030204" pitchFamily="18" charset="0"/>
-                          </a:rPr>
-                          <m:t>∗</m:t>
-                        </m:r>
-                      </m:sup>
-                    </m:sSup>
-                  </m:oMath>
-                </a14:m>
-                <a:r>
-                  <a:rPr sz="1000" b="0" i="0" baseline="0" dirty="0">
-                    <a:latin typeface="Calibri"/>
-                  </a:rPr>
-                  <a:t> — flat at </a:t>
-                </a:r>
-                <a14:m>
-                  <m:oMath xmlns:m="http://schemas.openxmlformats.org/officeDocument/2006/math">
-                    <m:r>
-                      <a:rPr lang="en-US" sz="1000" b="0" i="0" baseline="0" dirty="0" smtClean="0">
-                        <a:latin typeface="Cambria Math" panose="02040503050406030204" pitchFamily="18" charset="0"/>
-                      </a:rPr>
-                      <m:t>0</m:t>
-                    </m:r>
-                  </m:oMath>
-                </a14:m>
-                <a:r>
-                  <a:rPr sz="1000" b="0" i="0" baseline="0" dirty="0">
-                    <a:latin typeface="Calibri"/>
-                  </a:rPr>
-                  <a:t> all seasons on hero panel.</a:t>
-                </a:r>
-              </a:p>
-              <a:p>
-                <a:pPr>
-                  <a:buChar char="•"/>
-                </a:pPr>
-                <a:r>
-                  <a:rPr sz="1000" b="0" i="0" baseline="0" dirty="0">
-                    <a:latin typeface="Calibri"/>
-                  </a:rPr>
-                  <a:t>  </a:t>
-                </a:r>
-                <a14:m>
-                  <m:oMath xmlns:m="http://schemas.openxmlformats.org/officeDocument/2006/math">
-                    <m:sSup>
-                      <m:sSupPr>
-                        <m:ctrlPr>
-                          <a:rPr lang="en-US" sz="1000" b="0" i="0" baseline="0" dirty="0">
-                            <a:latin typeface="Cambria Math" panose="02040503050406030204" pitchFamily="18" charset="0"/>
-                          </a:rPr>
-                        </m:ctrlPr>
-                      </m:sSupPr>
-                      <m:e>
-                        <m:r>
-                          <a:rPr lang="en-US" sz="1000" b="0" i="0" baseline="0" dirty="0">
-                            <a:latin typeface="Cambria Math" panose="02040503050406030204" pitchFamily="18" charset="0"/>
-                          </a:rPr>
-                          <m:t>𝜌</m:t>
-                        </m:r>
-                      </m:e>
-                      <m:sup>
-                        <m:r>
-                          <a:rPr lang="en-US" sz="1000" b="0" i="0" baseline="0" dirty="0">
-                            <a:latin typeface="Cambria Math" panose="02040503050406030204" pitchFamily="18" charset="0"/>
-                          </a:rPr>
-                          <m:t>∗</m:t>
-                        </m:r>
-                      </m:sup>
-                    </m:sSup>
-                    <m:r>
-                      <a:rPr lang="en-US" sz="1000" b="0" i="0" baseline="0" dirty="0">
-                        <a:latin typeface="Cambria Math" panose="02040503050406030204" pitchFamily="18" charset="0"/>
-                      </a:rPr>
-                      <m:t>=0</m:t>
-                    </m:r>
-                  </m:oMath>
-                </a14:m>
-                <a:r>
-                  <a:rPr sz="1000" b="0" i="0" baseline="0" dirty="0">
-                    <a:latin typeface="Calibri"/>
-                  </a:rPr>
-                  <a:t> — what we DO say: on the locked hero panel, the LG ASSIGN homophily knob calibrates to zero (11/11 seasons); empirical </a:t>
-                </a:r>
-                <a14:m>
-                  <m:oMath xmlns:m="http://schemas.openxmlformats.org/officeDocument/2006/math">
-                    <m:sSub>
-                      <m:sSubPr>
-                        <m:ctrlPr>
-                          <a:rPr lang="en-US" sz="1000" b="0" i="0" baseline="0" dirty="0">
-                            <a:latin typeface="Cambria Math" panose="02040503050406030204" pitchFamily="18" charset="0"/>
-                          </a:rPr>
-                        </m:ctrlPr>
-                      </m:sSubPr>
-                      <m:e>
-                        <m:r>
-                          <a:rPr lang="en-US" sz="1000" b="0" i="0" baseline="0" dirty="0">
-                            <a:latin typeface="Cambria Math" panose="02040503050406030204" pitchFamily="18" charset="0"/>
-                          </a:rPr>
-                          <m:t>𝐻</m:t>
-                        </m:r>
-                      </m:e>
-                      <m:sub>
-                        <m:r>
-                          <m:rPr>
-                            <m:sty m:val="p"/>
-                          </m:rPr>
-                          <a:rPr lang="en-US" sz="1000" b="0" i="0" baseline="0" dirty="0">
-                            <a:latin typeface="Cambria Math" panose="02040503050406030204" pitchFamily="18" charset="0"/>
-                          </a:rPr>
-                          <m:t>sort</m:t>
-                        </m:r>
-                      </m:sub>
-                    </m:sSub>
-                    <m:r>
-                      <a:rPr lang="en-US" sz="1000" b="0" i="0" baseline="0" dirty="0">
-                        <a:latin typeface="Cambria Math" panose="02040503050406030204" pitchFamily="18" charset="0"/>
-                      </a:rPr>
-                      <m:t>≈0.064</m:t>
-                    </m:r>
-                  </m:oMath>
-                </a14:m>
-                <a:r>
-                  <a:rPr sz="1000" b="0" i="0" baseline="0" dirty="0">
-                    <a:latin typeface="Calibri"/>
-                  </a:rPr>
-                  <a:t> (</a:t>
-                </a:r>
-                <a14:m>
-                  <m:oMath xmlns:m="http://schemas.openxmlformats.org/officeDocument/2006/math">
-                    <m:r>
-                      <a:rPr lang="en-US" sz="1000" b="0" i="0" baseline="0" dirty="0" smtClean="0">
-                        <a:latin typeface="Cambria Math" panose="02040503050406030204" pitchFamily="18" charset="0"/>
-                      </a:rPr>
-                      <m:t>≈0.0642059</m:t>
-                    </m:r>
-                  </m:oMath>
-                </a14:m>
-                <a:r>
-                  <a:rPr sz="1000" b="0" i="0" baseline="0" dirty="0">
-                    <a:latin typeface="Calibri"/>
-                  </a:rPr>
-                  <a:t> on </a:t>
-                </a:r>
-                <a14:m>
-                  <m:oMath xmlns:m="http://schemas.openxmlformats.org/officeDocument/2006/math">
-                    <m:d>
-                      <m:dPr>
-                        <m:begChr m:val="["/>
-                        <m:endChr m:val="]"/>
-                        <m:ctrlPr>
-                          <a:rPr lang="en-US" sz="1000" b="0" i="0" baseline="0" dirty="0">
-                            <a:latin typeface="Cambria Math" panose="02040503050406030204" pitchFamily="18" charset="0"/>
-                          </a:rPr>
-                        </m:ctrlPr>
-                      </m:dPr>
-                      <m:e>
-                        <m:r>
-                          <a:rPr lang="en-US" sz="1000" b="0" i="0" baseline="0" dirty="0">
-                            <a:latin typeface="Cambria Math" panose="02040503050406030204" pitchFamily="18" charset="0"/>
-                          </a:rPr>
-                          <m:t>0,1</m:t>
-                        </m:r>
-                      </m:e>
-                    </m:d>
-                  </m:oMath>
-                </a14:m>
-                <a:r>
-                  <a:rPr sz="1000" b="0" i="0" baseline="0" dirty="0">
-                    <a:latin typeface="Calibri"/>
-                  </a:rPr>
-                  <a:t> scale); sim at </a:t>
-                </a:r>
-                <a14:m>
-                  <m:oMath xmlns:m="http://schemas.openxmlformats.org/officeDocument/2006/math">
-                    <m:sSup>
-                      <m:sSupPr>
-                        <m:ctrlPr>
-                          <a:rPr lang="en-US" sz="1000" b="0" i="0" baseline="0" dirty="0">
-                            <a:latin typeface="Cambria Math" panose="02040503050406030204" pitchFamily="18" charset="0"/>
-                          </a:rPr>
-                        </m:ctrlPr>
-                      </m:sSupPr>
-                      <m:e>
-                        <m:r>
-                          <a:rPr lang="en-US" sz="1000" b="0" i="0" baseline="0" dirty="0">
-                            <a:latin typeface="Cambria Math" panose="02040503050406030204" pitchFamily="18" charset="0"/>
-                          </a:rPr>
-                          <m:t>𝜌</m:t>
-                        </m:r>
-                      </m:e>
-                      <m:sup>
-                        <m:r>
-                          <a:rPr lang="en-US" sz="1000" b="0" i="0" baseline="0" dirty="0">
-                            <a:latin typeface="Cambria Math" panose="02040503050406030204" pitchFamily="18" charset="0"/>
-                          </a:rPr>
-                          <m:t>∗</m:t>
-                        </m:r>
-                      </m:sup>
-                    </m:sSup>
-                  </m:oMath>
-                </a14:m>
-                <a:r>
-                  <a:rPr sz="1000" b="0" i="0" baseline="0" dirty="0">
-                    <a:latin typeface="Calibri"/>
-                  </a:rPr>
-                  <a:t> slightly high (</a:t>
-                </a:r>
-                <a14:m>
-                  <m:oMath xmlns:m="http://schemas.openxmlformats.org/officeDocument/2006/math">
-                    <m:r>
-                      <a:rPr lang="en-US" sz="1000" b="0" i="0" baseline="0" dirty="0" smtClean="0">
-                        <a:latin typeface="Cambria Math" panose="02040503050406030204" pitchFamily="18" charset="0"/>
-                      </a:rPr>
-                      <m:t>≈0.0821529</m:t>
-                    </m:r>
-                  </m:oMath>
-                </a14:m>
-                <a:r>
-                  <a:rPr sz="1000" b="0" i="0" baseline="0" dirty="0">
-                    <a:latin typeface="Calibri"/>
-                  </a:rPr>
-                  <a:t>); turning </a:t>
-                </a:r>
-                <a14:m>
-                  <m:oMath xmlns:m="http://schemas.openxmlformats.org/officeDocument/2006/math">
-                    <m:r>
-                      <a:rPr lang="en-US" sz="1000" b="0" i="0" baseline="0" dirty="0" smtClean="0">
-                        <a:latin typeface="Cambria Math" panose="02040503050406030204" pitchFamily="18" charset="0"/>
-                      </a:rPr>
-                      <m:t>𝜌</m:t>
-                    </m:r>
-                  </m:oMath>
-                </a14:m>
-                <a:r>
-                  <a:rPr sz="1000" b="0" i="0" baseline="0" dirty="0">
-                    <a:latin typeface="Calibri"/>
-                  </a:rPr>
-                  <a:t> up overshoots (see legacy </a:t>
-                </a:r>
-                <a14:m>
-                  <m:oMath xmlns:m="http://schemas.openxmlformats.org/officeDocument/2006/math">
-                    <m:r>
-                      <a:rPr lang="en-US" sz="1000" b="0" i="0" baseline="0" dirty="0" smtClean="0">
-                        <a:latin typeface="Cambria Math" panose="02040503050406030204" pitchFamily="18" charset="0"/>
-                      </a:rPr>
-                      <m:t>𝜌</m:t>
-                    </m:r>
-                    <m:r>
-                      <a:rPr lang="en-US" sz="1000" b="0" i="0" baseline="0" dirty="0" smtClean="0">
-                        <a:latin typeface="Cambria Math" panose="02040503050406030204" pitchFamily="18" charset="0"/>
-                      </a:rPr>
-                      <m:t>=0.5</m:t>
-                    </m:r>
-                  </m:oMath>
-                </a14:m>
-                <a:r>
-                  <a:rPr sz="1000" b="0" i="0" baseline="0" dirty="0">
-                    <a:latin typeface="Calibri"/>
-                  </a:rPr>
-                  <a:t> bullet).</a:t>
-                </a:r>
-              </a:p>
-              <a:p>
-                <a:pPr>
-                  <a:buChar char="•"/>
-                </a:pPr>
-                <a:r>
-                  <a:rPr sz="1000" b="0" i="0" baseline="0" dirty="0">
-                    <a:latin typeface="Calibri"/>
-                  </a:rPr>
-                  <a:t>  </a:t>
-                </a:r>
-                <a14:m>
-                  <m:oMath xmlns:m="http://schemas.openxmlformats.org/officeDocument/2006/math">
-                    <m:sSup>
-                      <m:sSupPr>
-                        <m:ctrlPr>
-                          <a:rPr lang="en-US" sz="1000" b="0" i="0" baseline="0" dirty="0">
-                            <a:latin typeface="Cambria Math" panose="02040503050406030204" pitchFamily="18" charset="0"/>
-                          </a:rPr>
-                        </m:ctrlPr>
-                      </m:sSupPr>
-                      <m:e>
-                        <m:r>
-                          <a:rPr lang="en-US" sz="1000" b="0" i="0" baseline="0" dirty="0">
-                            <a:latin typeface="Cambria Math" panose="02040503050406030204" pitchFamily="18" charset="0"/>
-                          </a:rPr>
-                          <m:t>𝜌</m:t>
-                        </m:r>
-                      </m:e>
-                      <m:sup>
-                        <m:r>
-                          <a:rPr lang="en-US" sz="1000" b="0" i="0" baseline="0" dirty="0">
-                            <a:latin typeface="Cambria Math" panose="02040503050406030204" pitchFamily="18" charset="0"/>
-                          </a:rPr>
-                          <m:t>∗</m:t>
-                        </m:r>
-                      </m:sup>
-                    </m:sSup>
-                    <m:r>
-                      <a:rPr lang="en-US" sz="1000" b="0" i="0" baseline="0" dirty="0">
-                        <a:latin typeface="Cambria Math" panose="02040503050406030204" pitchFamily="18" charset="0"/>
-                      </a:rPr>
-                      <m:t>=0</m:t>
-                    </m:r>
-                  </m:oMath>
-                </a14:m>
-                <a:r>
-                  <a:rPr sz="1000" b="0" i="0" baseline="0" dirty="0">
-                    <a:latin typeface="Calibri"/>
-                  </a:rPr>
-                  <a:t> — what we DO NOT say: NCAA has no team formation; Duke and a weak D-I school draw from the same talent pool; real-world assortativity is absent; Hero inverted-U / </a:t>
-                </a:r>
-                <a14:m>
-                  <m:oMath xmlns:m="http://schemas.openxmlformats.org/officeDocument/2006/math">
-                    <m:r>
-                      <a:rPr lang="en-US" sz="1000" b="0" i="0" baseline="0" dirty="0" smtClean="0">
-                        <a:latin typeface="Cambria Math" panose="02040503050406030204" pitchFamily="18" charset="0"/>
-                      </a:rPr>
-                      <m:t>𝜆</m:t>
-                    </m:r>
-                  </m:oMath>
-                </a14:m>
-                <a:r>
-                  <a:rPr sz="1000" b="0" i="0" baseline="0" dirty="0">
-                    <a:latin typeface="Calibri"/>
-                  </a:rPr>
-                  <a:t> / SELECT story is dead.</a:t>
-                </a:r>
-              </a:p>
-              <a:p>
-                <a:pPr>
-                  <a:buChar char="•"/>
-                </a:pPr>
-                <a:r>
-                  <a:rPr sz="1000" b="0" i="0" baseline="0" dirty="0">
-                    <a:latin typeface="Calibri"/>
-                  </a:rPr>
-                  <a:t>  </a:t>
-                </a:r>
-                <a14:m>
-                  <m:oMath xmlns:m="http://schemas.openxmlformats.org/officeDocument/2006/math">
-                    <m:sSub>
-                      <m:sSubPr>
-                        <m:ctrlPr>
-                          <a:rPr lang="en-US" sz="1000" b="0" i="0" baseline="0" dirty="0">
-                            <a:latin typeface="Cambria Math" panose="02040503050406030204" pitchFamily="18" charset="0"/>
-                          </a:rPr>
-                        </m:ctrlPr>
-                      </m:sSubPr>
-                      <m:e>
-                        <m:r>
-                          <a:rPr lang="en-US" sz="1000" b="0" i="0" baseline="0" dirty="0">
-                            <a:latin typeface="Cambria Math" panose="02040503050406030204" pitchFamily="18" charset="0"/>
-                          </a:rPr>
-                          <m:t>𝐻</m:t>
-                        </m:r>
-                      </m:e>
-                      <m:sub>
-                        <m:r>
-                          <m:rPr>
-                            <m:sty m:val="p"/>
-                          </m:rPr>
-                          <a:rPr lang="en-US" sz="1000" b="0" i="0" baseline="0" dirty="0">
-                            <a:latin typeface="Cambria Math" panose="02040503050406030204" pitchFamily="18" charset="0"/>
-                          </a:rPr>
-                          <m:t>sort</m:t>
-                        </m:r>
-                      </m:sub>
-                    </m:sSub>
-                  </m:oMath>
-                </a14:m>
-                <a:r>
-                  <a:rPr sz="1000" b="0" i="0" baseline="0" dirty="0">
-                    <a:latin typeface="Calibri"/>
-                  </a:rPr>
-                  <a:t> is realized sorting on a fixed roster partition (VECTOR lock) — not the generative </a:t>
-                </a:r>
-                <a14:m>
-                  <m:oMath xmlns:m="http://schemas.openxmlformats.org/officeDocument/2006/math">
-                    <m:r>
-                      <a:rPr lang="en-US" sz="1000" b="0" i="0" baseline="0" dirty="0" smtClean="0">
-                        <a:latin typeface="Cambria Math" panose="02040503050406030204" pitchFamily="18" charset="0"/>
-                      </a:rPr>
-                      <m:t>𝜌</m:t>
-                    </m:r>
-                  </m:oMath>
-                </a14:m>
-                <a:r>
-                  <a:rPr sz="1000" b="0" i="0" baseline="0" dirty="0">
-                    <a:latin typeface="Calibri"/>
-                  </a:rPr>
-                  <a:t> knob. Box QC lowered measured </a:t>
-                </a:r>
-                <a14:m>
-                  <m:oMath xmlns:m="http://schemas.openxmlformats.org/officeDocument/2006/math">
-                    <m:sSub>
-                      <m:sSubPr>
-                        <m:ctrlPr>
-                          <a:rPr lang="en-US" sz="1000" b="0" i="0" baseline="0" dirty="0">
-                            <a:latin typeface="Cambria Math" panose="02040503050406030204" pitchFamily="18" charset="0"/>
-                          </a:rPr>
-                        </m:ctrlPr>
-                      </m:sSubPr>
-                      <m:e>
-                        <m:r>
-                          <a:rPr lang="en-US" sz="1000" b="0" i="0" baseline="0" dirty="0">
-                            <a:latin typeface="Cambria Math" panose="02040503050406030204" pitchFamily="18" charset="0"/>
-                          </a:rPr>
-                          <m:t>𝐻</m:t>
-                        </m:r>
-                      </m:e>
-                      <m:sub>
-                        <m:r>
-                          <m:rPr>
-                            <m:sty m:val="p"/>
-                          </m:rPr>
-                          <a:rPr lang="en-US" sz="1000" b="0" i="0" baseline="0" dirty="0">
-                            <a:latin typeface="Cambria Math" panose="02040503050406030204" pitchFamily="18" charset="0"/>
-                          </a:rPr>
-                          <m:t>sort</m:t>
-                        </m:r>
-                      </m:sub>
-                    </m:sSub>
-                  </m:oMath>
-                </a14:m>
-                <a:r>
-                  <a:rPr sz="1000" b="0" i="0" baseline="0" dirty="0">
-                    <a:latin typeface="Calibri"/>
-                  </a:rPr>
-                  <a:t> vs pre-QC (</a:t>
-                </a:r>
-                <a14:m>
-                  <m:oMath xmlns:m="http://schemas.openxmlformats.org/officeDocument/2006/math">
-                    <m:r>
-                      <a:rPr lang="en-US" sz="1000" b="0" i="0" baseline="0" dirty="0" smtClean="0">
-                        <a:latin typeface="Cambria Math" panose="02040503050406030204" pitchFamily="18" charset="0"/>
-                      </a:rPr>
-                      <m:t>∼0.10→∼0.06</m:t>
-                    </m:r>
-                  </m:oMath>
-                </a14:m>
-                <a:r>
-                  <a:rPr sz="1000" b="0" i="0" baseline="0" dirty="0">
-                    <a:latin typeface="Calibri"/>
-                  </a:rPr>
-                  <a:t>); modest </a:t>
-                </a:r>
-                <a14:m>
-                  <m:oMath xmlns:m="http://schemas.openxmlformats.org/officeDocument/2006/math">
-                    <m:r>
-                      <a:rPr lang="en-US" sz="1000" b="0" i="0" baseline="0" dirty="0" smtClean="0">
-                        <a:latin typeface="Cambria Math" panose="02040503050406030204" pitchFamily="18" charset="0"/>
-                      </a:rPr>
-                      <m:t>≠</m:t>
-                    </m:r>
-                  </m:oMath>
-                </a14:m>
-                <a:r>
-                  <a:rPr sz="1000" b="0" i="0" baseline="0" dirty="0">
-                    <a:latin typeface="Calibri"/>
-                  </a:rPr>
-                  <a:t> zero. Contrast: slide</a:t>
-                </a:r>
-                <a:r>
-                  <a:rPr lang="en-US" sz="1000" b="0" i="0" baseline="0" dirty="0">
-                    <a:latin typeface="Calibri"/>
-                  </a:rPr>
-                  <a:t> 6 </a:t>
-                </a:r>
-                <a:r>
-                  <a:rPr sz="1000" b="0" i="0" baseline="0" dirty="0">
-                    <a:latin typeface="Calibri"/>
-                  </a:rPr>
-                  <a:t> </a:t>
-                </a:r>
-                <a14:m>
-                  <m:oMath xmlns:m="http://schemas.openxmlformats.org/officeDocument/2006/math">
-                    <m:r>
-                      <a:rPr lang="en-US" sz="1000" b="0" i="0" baseline="0" dirty="0" smtClean="0">
-                        <a:latin typeface="Cambria Math" panose="02040503050406030204" pitchFamily="18" charset="0"/>
-                      </a:rPr>
-                      <m:t>𝑝𝑝𝑚</m:t>
-                    </m:r>
-                    <m:r>
-                      <a:rPr lang="en-US" sz="1000" b="0" i="0" baseline="0" dirty="0" smtClean="0">
-                        <a:latin typeface="Cambria Math" panose="02040503050406030204" pitchFamily="18" charset="0"/>
-                      </a:rPr>
-                      <m:t>0</m:t>
-                    </m:r>
-                    <m:r>
-                      <a:rPr lang="en-US" sz="1000" b="0" i="0" baseline="0" dirty="0" smtClean="0">
-                        <a:latin typeface="Cambria Math" panose="02040503050406030204" pitchFamily="18" charset="0"/>
-                      </a:rPr>
-                      <m:t>𝑙𝑡</m:t>
-                    </m:r>
-                    <m:r>
-                      <a:rPr lang="en-US" sz="1000" b="0" i="0" baseline="0" dirty="0" smtClean="0">
-                        <a:latin typeface="Cambria Math" panose="02040503050406030204" pitchFamily="18" charset="0"/>
-                      </a:rPr>
-                      <m:t>20</m:t>
-                    </m:r>
-                  </m:oMath>
-                </a14:m>
-                <a:r>
-                  <a:rPr sz="1000" b="0" i="0" baseline="0" dirty="0">
-                    <a:latin typeface="Calibri"/>
-                  </a:rPr>
-                  <a:t> panel.</a:t>
-                </a:r>
-              </a:p>
-              <a:p>
-                <a:pPr>
-                  <a:buChar char="•"/>
-                </a:pPr>
-                <a:r>
-                  <a:rPr sz="1000" b="0" i="0" baseline="0" dirty="0">
-                    <a:latin typeface="Calibri"/>
-                  </a:rPr>
-                  <a:t>  VECTOR lock: </a:t>
-                </a:r>
-                <a14:m>
-                  <m:oMath xmlns:m="http://schemas.openxmlformats.org/officeDocument/2006/math">
-                    <m:sSub>
-                      <m:sSubPr>
-                        <m:ctrlPr>
-                          <a:rPr lang="en-US" sz="1000" b="0" i="0" baseline="0" dirty="0">
-                            <a:latin typeface="Cambria Math" panose="02040503050406030204" pitchFamily="18" charset="0"/>
-                          </a:rPr>
-                        </m:ctrlPr>
-                      </m:sSubPr>
-                      <m:e>
-                        <m:r>
-                          <a:rPr lang="en-US" sz="1000" b="0" i="0" baseline="0" dirty="0">
-                            <a:latin typeface="Cambria Math" panose="02040503050406030204" pitchFamily="18" charset="0"/>
-                          </a:rPr>
-                          <m:t>𝐻</m:t>
-                        </m:r>
-                      </m:e>
-                      <m:sub>
-                        <m:r>
-                          <a:rPr lang="en-US" sz="1000" b="0" i="0" baseline="0" dirty="0">
-                            <a:latin typeface="Cambria Math" panose="02040503050406030204" pitchFamily="18" charset="0"/>
-                          </a:rPr>
-                          <m:t>𝑠𝑜𝑟𝑡</m:t>
-                        </m:r>
-                      </m:sub>
-                    </m:sSub>
-                  </m:oMath>
-                </a14:m>
-                <a:r>
-                  <a:rPr sz="1000" b="0" i="0" baseline="0" dirty="0">
-                    <a:latin typeface="Calibri"/>
-                  </a:rPr>
-                  <a:t> is realized sorting — not the generative homophily knob </a:t>
-                </a:r>
-                <a14:m>
-                  <m:oMath xmlns:m="http://schemas.openxmlformats.org/officeDocument/2006/math">
-                    <m:r>
-                      <a:rPr lang="en-US" sz="1000" b="0" i="0" baseline="0" dirty="0" smtClean="0">
-                        <a:latin typeface="Cambria Math" panose="02040503050406030204" pitchFamily="18" charset="0"/>
-                      </a:rPr>
-                      <m:t>𝜌</m:t>
-                    </m:r>
-                  </m:oMath>
-                </a14:m>
-                <a:r>
-                  <a:rPr sz="1000" b="0" i="0" baseline="0" dirty="0">
-                    <a:latin typeface="Calibri"/>
-                  </a:rPr>
-                  <a:t>.</a:t>
-                </a:r>
-              </a:p>
-              <a:p>
-                <a:pPr>
-                  <a:buChar char="•"/>
-                </a:pPr>
-                <a:r>
-                  <a:rPr sz="1000" b="0" i="0" baseline="0" dirty="0">
-                    <a:latin typeface="Calibri"/>
-                  </a:rPr>
-                  <a:t>  Figure: small multiples — blue sim curve, red empirical line, green </a:t>
-                </a:r>
-                <a14:m>
-                  <m:oMath xmlns:m="http://schemas.openxmlformats.org/officeDocument/2006/math">
-                    <m:sSup>
-                      <m:sSupPr>
-                        <m:ctrlPr>
-                          <a:rPr lang="en-US" sz="1000" b="0" i="0" baseline="0" dirty="0">
-                            <a:latin typeface="Cambria Math" panose="02040503050406030204" pitchFamily="18" charset="0"/>
-                          </a:rPr>
-                        </m:ctrlPr>
-                      </m:sSupPr>
-                      <m:e>
-                        <m:r>
-                          <a:rPr lang="en-US" sz="1000" b="0" i="0" baseline="0" dirty="0">
-                            <a:latin typeface="Cambria Math" panose="02040503050406030204" pitchFamily="18" charset="0"/>
-                          </a:rPr>
-                          <m:t>𝜌</m:t>
-                        </m:r>
-                      </m:e>
-                      <m:sup>
-                        <m:r>
-                          <a:rPr lang="en-US" sz="1000" b="0" i="0" baseline="0" dirty="0">
-                            <a:latin typeface="Cambria Math" panose="02040503050406030204" pitchFamily="18" charset="0"/>
-                          </a:rPr>
-                          <m:t>∗</m:t>
-                        </m:r>
-                      </m:sup>
-                    </m:sSup>
-                  </m:oMath>
-                </a14:m>
-                <a:r>
-                  <a:rPr sz="1000" b="0" i="0" baseline="0" dirty="0">
-                    <a:latin typeface="Calibri"/>
-                  </a:rPr>
-                  <a:t> (x-axis zoomed to evaluated bracket).</a:t>
-                </a:r>
-              </a:p>
-            </p:txBody>
-          </p:sp>
-        </mc:Choice>
-        <mc:Fallback>
-          <p:sp>
-            <p:nvSpPr>
-              <p:cNvPr id="5" name="TextBox 4"/>
-              <p:cNvSpPr txBox="1">
-                <a:spLocks noRot="1" noChangeAspect="1" noMove="1" noResize="1" noEditPoints="1" noAdjustHandles="1" noChangeArrowheads="1" noChangeShapeType="1" noTextEdit="1"/>
-              </p:cNvSpPr>
-              <p:nvPr/>
-            </p:nvSpPr>
-            <p:spPr>
-              <a:xfrm>
-                <a:off x="283932" y="1199867"/>
-                <a:ext cx="4147904" cy="4481291"/>
-              </a:xfrm>
-              <a:prstGeom prst="rect">
-                <a:avLst/>
-              </a:prstGeom>
-              <a:blipFill>
-                <a:blip r:embed="rId5"/>
-                <a:stretch>
-                  <a:fillRect t="-282"/>
-                </a:stretch>
-              </a:blipFill>
-            </p:spPr>
-            <p:txBody>
-              <a:bodyPr/>
-              <a:lstStyle/>
-              <a:p>
-                <a:r>
-                  <a:rPr lang="en-US">
-                    <a:noFill/>
-                  </a:rPr>
-                  <a:t> </a:t>
-                </a:r>
-              </a:p>
-            </p:txBody>
-          </p:sp>
-        </mc:Fallback>
-      </mc:AlternateContent>
-      <mc:AlternateContent xmlns:mc="http://schemas.openxmlformats.org/markup-compatibility/2006">
-        <mc:Choice xmlns:a14="http://schemas.microsoft.com/office/drawing/2010/main" Requires="a14">
-          <p:sp>
-            <p:nvSpPr>
-              <p:cNvPr id="6" name="TextBox 5"/>
-              <p:cNvSpPr txBox="1"/>
-              <p:nvPr/>
-            </p:nvSpPr>
-            <p:spPr>
-              <a:xfrm>
-                <a:off x="384048" y="6166786"/>
-                <a:ext cx="11423599" cy="430887"/>
-              </a:xfrm>
-              <a:prstGeom prst="rect">
-                <a:avLst/>
-              </a:prstGeom>
-              <a:noFill/>
-            </p:spPr>
-            <p:txBody>
-              <a:bodyPr wrap="square">
-                <a:spAutoFit/>
-              </a:bodyPr>
-              <a:lstStyle/>
-              <a:p>
-                <a:pPr algn="l"/>
-                <a:r>
-                  <a:rPr sz="1100" b="1" i="0" baseline="0" dirty="0">
-                    <a:latin typeface="Calibri"/>
-                  </a:rPr>
-                  <a:t>Claim (Alex): Hero panel — LG ASSIGN </a:t>
-                </a:r>
-                <a14:m>
-                  <m:oMath xmlns:m="http://schemas.openxmlformats.org/officeDocument/2006/math">
-                    <m:sSup>
-                      <m:sSupPr>
-                        <m:ctrlPr>
-                          <a:rPr lang="en-US" sz="1100" b="1" i="0" baseline="0" dirty="0">
-                            <a:latin typeface="Cambria Math" panose="02040503050406030204" pitchFamily="18" charset="0"/>
-                          </a:rPr>
-                        </m:ctrlPr>
-                      </m:sSupPr>
-                      <m:e>
-                        <m:r>
-                          <a:rPr lang="en-US" sz="1100" b="1" i="0" baseline="0" dirty="0">
-                            <a:latin typeface="Cambria Math" panose="02040503050406030204" pitchFamily="18" charset="0"/>
-                          </a:rPr>
-                          <m:t>𝜌</m:t>
-                        </m:r>
-                      </m:e>
-                      <m:sup>
-                        <m:r>
-                          <a:rPr lang="en-US" sz="1100" b="1" i="0" baseline="0" dirty="0">
-                            <a:latin typeface="Cambria Math" panose="02040503050406030204" pitchFamily="18" charset="0"/>
-                          </a:rPr>
-                          <m:t>∗</m:t>
-                        </m:r>
-                      </m:sup>
-                    </m:sSup>
-                    <m:r>
-                      <a:rPr lang="en-US" sz="1100" b="1" i="0" baseline="0" dirty="0">
-                        <a:latin typeface="Cambria Math" panose="02040503050406030204" pitchFamily="18" charset="0"/>
-                      </a:rPr>
-                      <m:t>=0</m:t>
-                    </m:r>
-                  </m:oMath>
-                </a14:m>
-                <a:r>
-                  <a:rPr sz="1100" b="1" i="0" baseline="0" dirty="0">
-                    <a:latin typeface="Calibri"/>
-                  </a:rPr>
-                  <a:t> matches modest empirical </a:t>
-                </a:r>
-                <a14:m>
-                  <m:oMath xmlns:m="http://schemas.openxmlformats.org/officeDocument/2006/math">
-                    <m:sSub>
-                      <m:sSubPr>
-                        <m:ctrlPr>
-                          <a:rPr lang="en-US" sz="1100" b="1" i="0" baseline="0" dirty="0">
-                            <a:latin typeface="Cambria Math" panose="02040503050406030204" pitchFamily="18" charset="0"/>
-                          </a:rPr>
-                        </m:ctrlPr>
-                      </m:sSubPr>
-                      <m:e>
-                        <m:r>
-                          <a:rPr lang="en-US" sz="1100" b="1" i="0" baseline="0" dirty="0">
-                            <a:latin typeface="Cambria Math" panose="02040503050406030204" pitchFamily="18" charset="0"/>
-                          </a:rPr>
-                          <m:t>𝐻</m:t>
-                        </m:r>
-                      </m:e>
-                      <m:sub>
-                        <m:r>
-                          <m:rPr>
-                            <m:sty m:val="p"/>
-                          </m:rPr>
-                          <a:rPr lang="en-US" sz="1100" b="1" i="0" baseline="0" dirty="0">
-                            <a:latin typeface="Cambria Math" panose="02040503050406030204" pitchFamily="18" charset="0"/>
-                          </a:rPr>
-                          <m:t>sort</m:t>
-                        </m:r>
-                      </m:sub>
-                    </m:sSub>
-                    <m:r>
-                      <a:rPr lang="en-US" sz="1100" b="1" i="0" baseline="0" dirty="0">
-                        <a:latin typeface="Cambria Math" panose="02040503050406030204" pitchFamily="18" charset="0"/>
-                      </a:rPr>
-                      <m:t>≈0.064</m:t>
-                    </m:r>
-                  </m:oMath>
-                </a14:m>
-                <a:r>
-                  <a:rPr sz="1100" b="1" i="0" baseline="0" dirty="0">
-                    <a:latin typeface="Calibri"/>
-                  </a:rPr>
-                  <a:t>; legacy </a:t>
-                </a:r>
-                <a14:m>
-                  <m:oMath xmlns:m="http://schemas.openxmlformats.org/officeDocument/2006/math">
-                    <m:r>
-                      <a:rPr lang="en-US" sz="1100" b="1" i="0" baseline="0" dirty="0" smtClean="0">
-                        <a:latin typeface="Cambria Math" panose="02040503050406030204" pitchFamily="18" charset="0"/>
-                      </a:rPr>
-                      <m:t>𝜌</m:t>
-                    </m:r>
-                    <m:r>
-                      <a:rPr lang="en-US" sz="1100" b="1" i="0" baseline="0" dirty="0" smtClean="0">
-                        <a:latin typeface="Cambria Math" panose="02040503050406030204" pitchFamily="18" charset="0"/>
-                      </a:rPr>
-                      <m:t>=0.5</m:t>
-                    </m:r>
-                  </m:oMath>
-                </a14:m>
-                <a:r>
-                  <a:rPr sz="1100" b="1" i="0" baseline="0" dirty="0">
-                    <a:latin typeface="Calibri"/>
-                  </a:rPr>
-                  <a:t> overshoots (</a:t>
-                </a:r>
-                <a14:m>
-                  <m:oMath xmlns:m="http://schemas.openxmlformats.org/officeDocument/2006/math">
-                    <m:r>
-                      <a:rPr lang="en-US" sz="1100" b="1" i="0" baseline="0" dirty="0" smtClean="0">
-                        <a:latin typeface="Cambria Math" panose="02040503050406030204" pitchFamily="18" charset="0"/>
-                      </a:rPr>
-                      <m:t>0.11</m:t>
-                    </m:r>
-                  </m:oMath>
-                </a14:m>
-                <a:r>
-                  <a:rPr sz="1100" b="1" i="0" baseline="0" dirty="0">
-                    <a:latin typeface="Calibri"/>
-                  </a:rPr>
-                  <a:t> mean </a:t>
-                </a:r>
-                <a14:m>
-                  <m:oMath xmlns:m="http://schemas.openxmlformats.org/officeDocument/2006/math">
-                    <m:d>
-                      <m:dPr>
-                        <m:begChr m:val="|"/>
-                        <m:endChr m:val="|"/>
-                        <m:ctrlPr>
-                          <a:rPr lang="en-US" sz="1100" b="1" i="0" baseline="0" dirty="0">
-                            <a:latin typeface="Cambria Math" panose="02040503050406030204" pitchFamily="18" charset="0"/>
-                          </a:rPr>
-                        </m:ctrlPr>
-                      </m:dPr>
-                      <m:e>
-                        <m:r>
-                          <a:rPr lang="en-US" sz="1100" b="1" i="0" baseline="0" dirty="0">
-                            <a:latin typeface="Cambria Math" panose="02040503050406030204" pitchFamily="18" charset="0"/>
-                          </a:rPr>
-                          <m:t>𝑒𝑟𝑟𝑜𝑟</m:t>
-                        </m:r>
-                      </m:e>
-                    </m:d>
-                  </m:oMath>
-                </a14:m>
-                <a:r>
-                  <a:rPr sz="1100" b="1" i="0" baseline="0" dirty="0">
-                    <a:latin typeface="Calibri"/>
-                  </a:rPr>
-                  <a:t>). Model–measurement fit on this panel — not a claim that NCAA rosters are random.</a:t>
-                </a:r>
-              </a:p>
-            </p:txBody>
-          </p:sp>
-        </mc:Choice>
-        <mc:Fallback>
-          <p:sp>
-            <p:nvSpPr>
-              <p:cNvPr id="6" name="TextBox 5"/>
-              <p:cNvSpPr txBox="1">
-                <a:spLocks noRot="1" noChangeAspect="1" noMove="1" noResize="1" noEditPoints="1" noAdjustHandles="1" noChangeArrowheads="1" noChangeShapeType="1" noTextEdit="1"/>
-              </p:cNvSpPr>
-              <p:nvPr/>
-            </p:nvSpPr>
-            <p:spPr>
-              <a:xfrm>
-                <a:off x="384048" y="6166786"/>
-                <a:ext cx="11423599" cy="430887"/>
-              </a:xfrm>
-              <a:prstGeom prst="rect">
-                <a:avLst/>
-              </a:prstGeom>
-              <a:blipFill>
-                <a:blip r:embed="rId6"/>
-                <a:stretch>
-                  <a:fillRect b="-5714"/>
-                </a:stretch>
-              </a:blipFill>
-            </p:spPr>
-            <p:txBody>
-              <a:bodyPr/>
-              <a:lstStyle/>
-              <a:p>
-                <a:r>
-                  <a:rPr lang="en-US">
-                    <a:noFill/>
-                  </a:rPr>
-                  <a:t> </a:t>
-                </a:r>
-              </a:p>
-            </p:txBody>
-          </p:sp>
-        </mc:Fallback>
-      </mc:AlternateContent>
+      <p:sp>
+        <p:nvSpPr>
+          <p:cNvPr id="5" name="TextBox 4"/>
+          <p:cNvSpPr txBox="1"/>
+          <p:nvPr/>
+        </p:nvSpPr>
+        <p:spPr>
+          <a:xfrm>
+            <a:off x="384048" y="3849624"/>
+            <a:ext cx="3794760" cy="2148840"/>
+          </a:xfrm>
+          <a:prstGeom prst="rect">
+            <a:avLst/>
+          </a:prstGeom>
+          <a:noFill/>
+        </p:spPr>
+        <p:txBody>
+          <a:bodyPr wrap="square">
+            <a:spAutoFit/>
+          </a:bodyPr>
+          <a:lstStyle/>
+          <a:p>
+            <a:pPr>
+              <a:buChar char="•"/>
+              <a:lnSpc>
+                <a:spcPct val="150000"/>
+              </a:lnSpc>
+              <a:spcBef>
+                <a:spcPts val="0"/>
+              </a:spcBef>
+              <a:spcAft>
+                <a:spcPts val="0"/>
+              </a:spcAft>
+            </a:pPr>
+            <a:r>
+              <a:rPr sz="1000" b="0" i="0" baseline="0">
+                <a:latin typeface="Calibri"/>
+              </a:rPr>
+              <a:t>  PD21 locked calibration (Aug 2026): bracket search on hero panel for Alex ASSIGN $\rho$.</a:t>
+            </a:r>
+          </a:p>
+          <a:p>
+            <a:pPr>
+              <a:buChar char="•"/>
+              <a:lnSpc>
+                <a:spcPct val="150000"/>
+              </a:lnSpc>
+              <a:spcBef>
+                <a:spcPts val="0"/>
+              </a:spcBef>
+              <a:spcAft>
+                <a:spcPts val="0"/>
+              </a:spcAft>
+            </a:pPr>
+            <a:r>
+              <a:rPr sz="1000" b="0" i="0" baseline="0">
+                <a:latin typeface="Calibri"/>
+              </a:rPr>
+              <a:t>  Alex (Aug 2026): calibrate ASSIGN $\rho$ so LG simulated $H_{\mathrm{sort}}$ matches empirical NCAA; formal $\rho$ MLE parked.</a:t>
+            </a:r>
+          </a:p>
+          <a:p>
+            <a:pPr>
+              <a:buChar char="•"/>
+              <a:lnSpc>
+                <a:spcPct val="150000"/>
+              </a:lnSpc>
+              <a:spcBef>
+                <a:spcPts val="0"/>
+              </a:spcBef>
+              <a:spcAft>
+                <a:spcPts val="0"/>
+              </a:spcAft>
+            </a:pPr>
+            <a:r>
+              <a:rPr sz="1000" b="0" i="0" baseline="0">
+                <a:latin typeface="Calibri"/>
+              </a:rPr>
+              <a:t>  Panel: 2011–2021 MBB · min$\geq20$ min player-season drop · box QC at panel build · empirical roster caps · PPM z-scored within season.</a:t>
+            </a:r>
+          </a:p>
+          <a:p>
+            <a:pPr>
+              <a:buChar char="•"/>
+              <a:lnSpc>
+                <a:spcPct val="150000"/>
+              </a:lnSpc>
+              <a:spcBef>
+                <a:spcPts val="0"/>
+              </a:spcBef>
+              <a:spcAft>
+                <a:spcPts val="0"/>
+              </a:spcAft>
+            </a:pPr>
+            <a:r>
+              <a:rPr sz="1000" b="0" i="0" baseline="0">
+                <a:latin typeface="Calibri"/>
+              </a:rPr>
+              <a:t>  Search: bracket + bisect (tol=0.001), 50 seeds/arm; $H_{\mathrm{sort}}^{\mathrm{sim}}$ monotone in $\rho$.</a:t>
+            </a:r>
+          </a:p>
+          <a:p>
+            <a:pPr>
+              <a:buChar char="•"/>
+              <a:lnSpc>
+                <a:spcPct val="150000"/>
+              </a:lnSpc>
+              <a:spcBef>
+                <a:spcPts val="0"/>
+              </a:spcBef>
+              <a:spcAft>
+                <a:spcPts val="0"/>
+              </a:spcAft>
+            </a:pPr>
+            <a:r>
+              <a:rPr sz="1000" b="0" i="0" baseline="0">
+                <a:latin typeface="Calibri"/>
+              </a:rPr>
+              <a:t>  H_{sort} = 1 - \sum_i(\hat{A}_i - \hat{\mu}_{g(i)})^2 / \sum_i(\hat{A}_i - \bar{A})^2 — realized sorting on a fixed partition.</a:t>
+            </a:r>
+          </a:p>
+          <a:p>
+            <a:pPr>
+              <a:buChar char="•"/>
+              <a:lnSpc>
+                <a:spcPct val="150000"/>
+              </a:lnSpc>
+              <a:spcBef>
+                <a:spcPts val="0"/>
+              </a:spcBef>
+              <a:spcAft>
+                <a:spcPts val="0"/>
+              </a:spcAft>
+            </a:pPr>
+            <a:r>
+              <a:rPr sz="1000" b="0" i="0" baseline="0">
+                <a:latin typeface="Calibri"/>
+              </a:rPr>
+              <a:t>  Longitudinal $\rho^* \approx 0$; mean $H_{\mathrm{sort}}^{\mathrm{sim}}$ at $\rho^*$ = 0.082; mean $H_{\mathrm{sort}}^{\mathrm{emp}}$ = 0.064.</a:t>
+            </a:r>
+          </a:p>
+          <a:p>
+            <a:pPr>
+              <a:buChar char="•"/>
+              <a:lnSpc>
+                <a:spcPct val="150000"/>
+              </a:lnSpc>
+              <a:spcBef>
+                <a:spcPts val="0"/>
+              </a:spcBef>
+              <a:spcAft>
+                <a:spcPts val="0"/>
+              </a:spcAft>
+            </a:pPr>
+            <a:r>
+              <a:rPr sz="1000" b="0" i="0" baseline="0">
+                <a:latin typeface="Calibri"/>
+              </a:rPr>
+              <a:t>  Per-season: 11/11 seasons at $\rho^*=0$; all at $\rho^*=0$.</a:t>
+            </a:r>
+          </a:p>
+          <a:p>
+            <a:pPr>
+              <a:buChar char="•"/>
+              <a:lnSpc>
+                <a:spcPct val="150000"/>
+              </a:lnSpc>
+              <a:spcBef>
+                <a:spcPts val="0"/>
+              </a:spcBef>
+              <a:spcAft>
+                <a:spcPts val="0"/>
+              </a:spcAft>
+            </a:pPr>
+            <a:r>
+              <a:rPr sz="1000" b="0" i="0" baseline="0">
+                <a:latin typeface="Calibri"/>
+              </a:rPr>
+              <a:t>  Legacy reference $\rho=0.5$: mean $|error| \approx 0.112$ vs $\approx 0.018$ at $\rho^*$.</a:t>
+            </a:r>
+          </a:p>
+          <a:p>
+            <a:pPr>
+              <a:buChar char="•"/>
+              <a:lnSpc>
+                <a:spcPct val="150000"/>
+              </a:lnSpc>
+              <a:spcBef>
+                <a:spcPts val="0"/>
+              </a:spcBef>
+              <a:spcAft>
+                <a:spcPts val="0"/>
+              </a:spcAft>
+            </a:pPr>
+            <a:r>
+              <a:rPr sz="1000" b="0" i="0" baseline="0">
+                <a:latin typeface="Calibri"/>
+              </a:rPr>
+              <a:t>  Figure bottom-right inset: per-season $\rho^*$ — flat at $0$ all seasons on hero panel.</a:t>
+            </a:r>
+          </a:p>
+          <a:p>
+            <a:pPr>
+              <a:buChar char="•"/>
+              <a:lnSpc>
+                <a:spcPct val="150000"/>
+              </a:lnSpc>
+              <a:spcBef>
+                <a:spcPts val="0"/>
+              </a:spcBef>
+              <a:spcAft>
+                <a:spcPts val="0"/>
+              </a:spcAft>
+            </a:pPr>
+            <a:r>
+              <a:rPr sz="1000" b="0" i="0" baseline="0">
+                <a:latin typeface="Calibri"/>
+              </a:rPr>
+              <a:t>  $\rho^*=0$ — what we DO say: on the locked hero panel, the LG ASSIGN homophily knob calibrates to zero (11/11 seasons); empirical $H_{\mathrm{sort}}\approx 0.064$ ($\approx 0.0642059$ on $[0,1]$ scale); sim at $\rho^*$ slightly high ($\approx 0.0821529$); turning $\rho$ up overshoots (see legacy $\rho=0.5$ bullet).</a:t>
+            </a:r>
+          </a:p>
+          <a:p>
+            <a:pPr>
+              <a:buChar char="•"/>
+              <a:lnSpc>
+                <a:spcPct val="150000"/>
+              </a:lnSpc>
+              <a:spcBef>
+                <a:spcPts val="0"/>
+              </a:spcBef>
+              <a:spcAft>
+                <a:spcPts val="0"/>
+              </a:spcAft>
+            </a:pPr>
+            <a:r>
+              <a:rPr sz="1000" b="0" i="0" baseline="0">
+                <a:latin typeface="Calibri"/>
+              </a:rPr>
+              <a:t>  $\rho^*=0$ — what we DO NOT say: NCAA has no team formation; Duke and a weak D-I school draw from the same talent pool; real-world assortativity is absent; Hero inverted-U / $\lambda$ / SELECT story is dead.</a:t>
+            </a:r>
+          </a:p>
+          <a:p>
+            <a:pPr>
+              <a:buChar char="•"/>
+              <a:lnSpc>
+                <a:spcPct val="150000"/>
+              </a:lnSpc>
+              <a:spcBef>
+                <a:spcPts val="0"/>
+              </a:spcBef>
+              <a:spcAft>
+                <a:spcPts val="0"/>
+              </a:spcAft>
+            </a:pPr>
+            <a:r>
+              <a:rPr sz="1000" b="0" i="0" baseline="0">
+                <a:latin typeface="Calibri"/>
+              </a:rPr>
+              <a:t>  $H_{{\mathrm{{sort}}}}$ is realized sorting on a fixed roster partition (VECTOR lock) — not the generative $\rho$ knob. Box QC lowered measured $H_{{\mathrm{{sort}}}}$ vs pre-QC ($\sim 0.10 \rightarrow \sim 0.06$); modest $\neq$ zero. Contrast: ppm0lt20 panel (HAND20 slide 15).</a:t>
+            </a:r>
+          </a:p>
+          <a:p>
+            <a:pPr>
+              <a:buChar char="•"/>
+              <a:lnSpc>
+                <a:spcPct val="150000"/>
+              </a:lnSpc>
+              <a:spcBef>
+                <a:spcPts val="0"/>
+              </a:spcBef>
+              <a:spcAft>
+                <a:spcPts val="0"/>
+              </a:spcAft>
+            </a:pPr>
+            <a:r>
+              <a:rPr sz="1000" b="0" i="0" baseline="0">
+                <a:latin typeface="Calibri"/>
+              </a:rPr>
+              <a:t>  VECTOR lock: H_{sort} is realized sorting — not the generative homophily knob \rho.</a:t>
+            </a:r>
+          </a:p>
+          <a:p>
+            <a:pPr>
+              <a:buChar char="•"/>
+              <a:lnSpc>
+                <a:spcPct val="150000"/>
+              </a:lnSpc>
+              <a:spcBef>
+                <a:spcPts val="0"/>
+              </a:spcBef>
+              <a:spcAft>
+                <a:spcPts val="0"/>
+              </a:spcAft>
+            </a:pPr>
+            <a:r>
+              <a:rPr sz="1000" b="0" i="0" baseline="0">
+                <a:latin typeface="Calibri"/>
+              </a:rPr>
+              <a:t>  Figure: small multiples — blue sim curve, red empirical line, green $\rho^*$ (x-axis zoomed to evaluated bracket).</a:t>
+            </a:r>
+          </a:p>
+        </p:txBody>
+      </p:sp>
+      <p:sp>
+        <p:nvSpPr>
+          <p:cNvPr id="6" name="TextBox 5"/>
+          <p:cNvSpPr txBox="1"/>
+          <p:nvPr/>
+        </p:nvSpPr>
+        <p:spPr>
+          <a:xfrm>
+            <a:off x="384048" y="6053328"/>
+            <a:ext cx="11423599" cy="420624"/>
+          </a:xfrm>
+          <a:prstGeom prst="rect">
+            <a:avLst/>
+          </a:prstGeom>
+          <a:noFill/>
+        </p:spPr>
+        <p:txBody>
+          <a:bodyPr wrap="square">
+            <a:spAutoFit/>
+          </a:bodyPr>
+          <a:lstStyle/>
+          <a:p>
+            <a:pPr algn="l"/>
+            <a:r>
+              <a:rPr sz="1100" b="1" i="0" baseline="0">
+                <a:latin typeface="Calibri"/>
+              </a:rPr>
+              <a:t>Claim (Alex): Hero panel — LG ASSIGN $\rho^*=0$ matches modest empirical $H_{\mathrm{sort}}\approx0.064$; legacy $\rho=0.5$ overshoots ($0.11$ mean $|error|$). Model–measurement fit on this panel — not a claim that NCAA rosters are random.</a:t>
+            </a:r>
+          </a:p>
+        </p:txBody>
+      </p:sp>
     </p:spTree>
   </p:cSld>
   <p:clrMapOvr>

</xml_diff>